<commit_message>
Adding comments from the AIE book to the teleprompter script and the token demo script. Also updating the title of the Streamlit app and the dataframe display method.
</commit_message>
<xml_diff>
--- a/pptx/Session_01_Tokens_v1.0.pptx
+++ b/pptx/Session_01_Tokens_v1.0.pptx
@@ -8275,14 +8275,6 @@
               <a:rPr dirty="0"/>
               <a:t>AI Under the hood | Slide 2</a:t>
             </a:r>
-            <a:r>
-              <a:rPr dirty="0" err="1"/>
-              <a:t/>
-            </a:r>
-            <a:r>
-              <a:rPr dirty="0"/>
-              <a:t/>
-            </a:r>
           </a:p>
         </p:txBody>
       </p:sp>
@@ -9665,7 +9657,7 @@
         </p:nvSpPr>
         <p:spPr>
           <a:xfrm>
-            <a:off x="1097280" y="4206240"/>
+            <a:off x="822960" y="5788152"/>
             <a:ext cx="9966960" cy="914400"/>
           </a:xfrm>
           <a:prstGeom prst="roundRect">
@@ -9745,6 +9737,762 @@
                 <a:latin typeface="Aptos"/>
               </a:rPr>
               <a:t>AI Under the hood | Slide 7</a:t>
+            </a:r>
+          </a:p>
+        </p:txBody>
+      </p:sp>
+      <p:sp>
+        <p:nvSpPr>
+          <p:cNvPr id="8" name="Token Card">
+            <a:extLst>
+              <a:ext uri="{FF2B5EF4-FFF2-40B4-BE49-F238E27FC236}">
+                <a16:creationId xmlns:a16="http://schemas.microsoft.com/office/drawing/2014/main" id="{C1C42F9A-1A19-5862-1361-FF3109AFEA5F}"/>
+              </a:ext>
+            </a:extLst>
+          </p:cNvPr>
+          <p:cNvSpPr/>
+          <p:nvPr/>
+        </p:nvSpPr>
+        <p:spPr>
+          <a:xfrm>
+            <a:off x="1645920" y="7237477"/>
+            <a:ext cx="10424160" cy="1828800"/>
+          </a:xfrm>
+          <a:prstGeom prst="roundRect">
+            <a:avLst/>
+          </a:prstGeom>
+          <a:solidFill>
+            <a:srgbClr val="F5F8FC"/>
+          </a:solidFill>
+          <a:ln>
+            <a:solidFill>
+              <a:srgbClr val="BED2E6"/>
+            </a:solidFill>
+          </a:ln>
+        </p:spPr>
+        <p:txBody>
+          <a:bodyPr lIns="137160" tIns="137160" rIns="137160" bIns="137160" rtlCol="0" anchor="t"/>
+          <a:lstStyle/>
+          <a:p>
+            <a:pPr algn="l">
+              <a:defRPr sz="1750"/>
+            </a:pPr>
+            <a:endParaRPr sz="1550" dirty="0">
+              <a:solidFill>
+                <a:srgbClr val="172B4D"/>
+              </a:solidFill>
+              <a:latin typeface="Aptos"/>
+            </a:endParaRPr>
+          </a:p>
+        </p:txBody>
+      </p:sp>
+      <p:pic>
+        <p:nvPicPr>
+          <p:cNvPr id="1025" name="Picture 2">
+            <a:extLst>
+              <a:ext uri="{FF2B5EF4-FFF2-40B4-BE49-F238E27FC236}">
+                <a16:creationId xmlns:a16="http://schemas.microsoft.com/office/drawing/2014/main" id="{4F95BBDA-590B-270B-BC04-AF1E191FAA3F}"/>
+              </a:ext>
+            </a:extLst>
+          </p:cNvPr>
+          <p:cNvPicPr>
+            <a:picLocks noChangeAspect="1" noChangeArrowheads="1"/>
+          </p:cNvPicPr>
+          <p:nvPr/>
+        </p:nvPicPr>
+        <p:blipFill>
+          <a:blip r:embed="rId2">
+            <a:extLst>
+              <a:ext uri="{28A0092B-C50C-407E-A947-70E740481C1C}">
+                <a14:useLocalDpi xmlns:a14="http://schemas.microsoft.com/office/drawing/2010/main" val="0"/>
+              </a:ext>
+            </a:extLst>
+          </a:blip>
+          <a:srcRect/>
+          <a:stretch>
+            <a:fillRect/>
+          </a:stretch>
+        </p:blipFill>
+        <p:spPr bwMode="auto">
+          <a:xfrm>
+            <a:off x="822960" y="3266555"/>
+            <a:ext cx="6651625" cy="525093"/>
+          </a:xfrm>
+          <a:prstGeom prst="rect">
+            <a:avLst/>
+          </a:prstGeom>
+          <a:noFill/>
+          <a:extLst>
+            <a:ext uri="{909E8E84-426E-40DD-AFC4-6F175D3DCCD1}">
+              <a14:hiddenFill xmlns:a14="http://schemas.microsoft.com/office/drawing/2010/main">
+                <a:solidFill>
+                  <a:srgbClr val="FFFFFF"/>
+                </a:solidFill>
+              </a14:hiddenFill>
+            </a:ext>
+          </a:extLst>
+        </p:spPr>
+      </p:pic>
+      <p:sp>
+        <p:nvSpPr>
+          <p:cNvPr id="10" name="Rectangle 3">
+            <a:extLst>
+              <a:ext uri="{FF2B5EF4-FFF2-40B4-BE49-F238E27FC236}">
+                <a16:creationId xmlns:a16="http://schemas.microsoft.com/office/drawing/2014/main" id="{6167B4C7-FC18-6352-3591-BE6185B0662D}"/>
+              </a:ext>
+            </a:extLst>
+          </p:cNvPr>
+          <p:cNvSpPr>
+            <a:spLocks noChangeArrowheads="1"/>
+          </p:cNvSpPr>
+          <p:nvPr/>
+        </p:nvSpPr>
+        <p:spPr bwMode="auto">
+          <a:xfrm>
+            <a:off x="778081" y="3956758"/>
+            <a:ext cx="6142387" cy="1600438"/>
+          </a:xfrm>
+          <a:prstGeom prst="rect">
+            <a:avLst/>
+          </a:prstGeom>
+          <a:noFill/>
+          <a:ln>
+            <a:noFill/>
+          </a:ln>
+          <a:effectLst/>
+          <a:extLst>
+            <a:ext uri="{909E8E84-426E-40DD-AFC4-6F175D3DCCD1}">
+              <a14:hiddenFill xmlns:a14="http://schemas.microsoft.com/office/drawing/2010/main">
+                <a:solidFill>
+                  <a:schemeClr val="accent1"/>
+                </a:solidFill>
+              </a14:hiddenFill>
+            </a:ext>
+            <a:ext uri="{91240B29-F687-4F45-9708-019B960494DF}">
+              <a14:hiddenLine xmlns:a14="http://schemas.microsoft.com/office/drawing/2010/main" w="9525">
+                <a:solidFill>
+                  <a:schemeClr val="tx1"/>
+                </a:solidFill>
+                <a:miter lim="800000"/>
+                <a:headEnd/>
+                <a:tailEnd/>
+              </a14:hiddenLine>
+            </a:ext>
+            <a:ext uri="{AF507438-7753-43E0-B8FC-AC1667EBCBE1}">
+              <a14:hiddenEffects xmlns:a14="http://schemas.microsoft.com/office/drawing/2010/main">
+                <a:effectLst>
+                  <a:outerShdw dist="35921" dir="2700000" algn="ctr" rotWithShape="0">
+                    <a:schemeClr val="bg2"/>
+                  </a:outerShdw>
+                </a:effectLst>
+              </a14:hiddenEffects>
+            </a:ext>
+          </a:extLst>
+        </p:spPr>
+        <p:txBody>
+          <a:bodyPr vert="horz" wrap="none" lIns="91440" tIns="45720" rIns="91440" bIns="45720" numCol="1" anchor="ctr" anchorCtr="0" compatLnSpc="1">
+            <a:prstTxWarp prst="textNoShape">
+              <a:avLst/>
+            </a:prstTxWarp>
+            <a:spAutoFit/>
+          </a:bodyPr>
+          <a:lstStyle/>
+          <a:p>
+            <a:pPr defTabSz="914400" eaLnBrk="0" fontAlgn="base" hangingPunct="0">
+              <a:spcBef>
+                <a:spcPct val="0"/>
+              </a:spcBef>
+              <a:spcAft>
+                <a:spcPct val="0"/>
+              </a:spcAft>
+            </a:pPr>
+            <a:r>
+              <a:rPr lang="en-US" sz="1400" b="0" dirty="0">
+                <a:solidFill>
+                  <a:srgbClr val="000000"/>
+                </a:solidFill>
+                <a:effectLst/>
+                <a:latin typeface="Aptos" panose="020B0004020202020204" pitchFamily="34" charset="0"/>
+              </a:rPr>
+              <a:t>The set of all tokens a model can work with is called the model’s </a:t>
+            </a:r>
+            <a:r>
+              <a:rPr lang="en-US" sz="1400" b="0" dirty="0">
+                <a:solidFill>
+                  <a:srgbClr val="000000"/>
+                </a:solidFill>
+                <a:effectLst/>
+                <a:highlight>
+                  <a:srgbClr val="FFFF00"/>
+                </a:highlight>
+                <a:latin typeface="Aptos" panose="020B0004020202020204" pitchFamily="34" charset="0"/>
+              </a:rPr>
+              <a:t>vocabulary</a:t>
+            </a:r>
+            <a:r>
+              <a:rPr lang="en-US" sz="1400" b="0" dirty="0">
+                <a:solidFill>
+                  <a:srgbClr val="000000"/>
+                </a:solidFill>
+                <a:effectLst/>
+                <a:latin typeface="Aptos" panose="020B0004020202020204" pitchFamily="34" charset="0"/>
+              </a:rPr>
+              <a:t>.</a:t>
+            </a:r>
+            <a:r>
+              <a:rPr lang="en-US" sz="1400" b="0" dirty="0">
+                <a:solidFill>
+                  <a:srgbClr val="000000"/>
+                </a:solidFill>
+                <a:effectLst/>
+                <a:latin typeface="Consolas" panose="020B0609020204030204" pitchFamily="49" charset="0"/>
+              </a:rPr>
+              <a:t> </a:t>
+            </a:r>
+          </a:p>
+          <a:p>
+            <a:pPr marL="0" marR="0" lvl="0" indent="0" algn="l" defTabSz="914400" rtl="0" eaLnBrk="0" fontAlgn="base" latinLnBrk="0" hangingPunct="0">
+              <a:lnSpc>
+                <a:spcPct val="100000"/>
+              </a:lnSpc>
+              <a:spcBef>
+                <a:spcPct val="0"/>
+              </a:spcBef>
+              <a:spcAft>
+                <a:spcPct val="0"/>
+              </a:spcAft>
+              <a:buClrTx/>
+              <a:buSzTx/>
+              <a:buFontTx/>
+              <a:buNone/>
+              <a:tabLst/>
+            </a:pPr>
+            <a:r>
+              <a:rPr kumimoji="0" lang="en-US" altLang="en-US" sz="1400" b="0" i="0" u="none" strike="noStrike" cap="none" normalizeH="0" baseline="0" dirty="0">
+                <a:ln>
+                  <a:noFill/>
+                </a:ln>
+                <a:solidFill>
+                  <a:schemeClr val="tx1"/>
+                </a:solidFill>
+                <a:effectLst/>
+                <a:latin typeface="Aptos" panose="020B0004020202020204" pitchFamily="34" charset="0"/>
+                <a:ea typeface="MS Mincho" panose="02020609040205080304" pitchFamily="49" charset="-128"/>
+                <a:cs typeface="Cambria" panose="02040503050406030204" pitchFamily="18" charset="0"/>
+              </a:rPr>
+              <a:t>The process of breaking an original text into tokens is called </a:t>
+            </a:r>
+            <a:r>
+              <a:rPr kumimoji="0" lang="en-US" altLang="en-US" sz="1400" b="0" i="0" u="none" strike="noStrike" cap="none" normalizeH="0" baseline="0" dirty="0">
+                <a:ln>
+                  <a:noFill/>
+                </a:ln>
+                <a:solidFill>
+                  <a:schemeClr val="tx1"/>
+                </a:solidFill>
+                <a:effectLst/>
+                <a:highlight>
+                  <a:srgbClr val="FFFF00"/>
+                </a:highlight>
+                <a:latin typeface="Aptos" panose="020B0004020202020204" pitchFamily="34" charset="0"/>
+                <a:ea typeface="MS Mincho" panose="02020609040205080304" pitchFamily="49" charset="-128"/>
+                <a:cs typeface="Cambria" panose="02040503050406030204" pitchFamily="18" charset="0"/>
+              </a:rPr>
+              <a:t>tokenization</a:t>
+            </a:r>
+            <a:r>
+              <a:rPr kumimoji="0" lang="en-US" altLang="en-US" sz="1400" b="0" i="0" u="none" strike="noStrike" cap="none" normalizeH="0" baseline="0" dirty="0">
+                <a:ln>
+                  <a:noFill/>
+                </a:ln>
+                <a:solidFill>
+                  <a:schemeClr val="tx1"/>
+                </a:solidFill>
+                <a:effectLst/>
+                <a:latin typeface="Aptos" panose="020B0004020202020204" pitchFamily="34" charset="0"/>
+                <a:ea typeface="MS Mincho" panose="02020609040205080304" pitchFamily="49" charset="-128"/>
+                <a:cs typeface="Cambria" panose="02040503050406030204" pitchFamily="18" charset="0"/>
+              </a:rPr>
+              <a:t>. </a:t>
+            </a:r>
+          </a:p>
+          <a:p>
+            <a:endParaRPr lang="en-US" sz="1400" dirty="0"/>
+          </a:p>
+          <a:p>
+            <a:r>
+              <a:rPr lang="en-US" sz="1400" dirty="0"/>
+              <a:t>An example phrase is:</a:t>
+            </a:r>
+          </a:p>
+          <a:p>
+            <a:r>
+              <a:rPr lang="en-US" sz="1400" b="1" dirty="0"/>
+              <a:t>“The unbelievable replay was replayed unbelievably.”</a:t>
+            </a:r>
+            <a:endParaRPr lang="en-US" sz="1400" dirty="0"/>
+          </a:p>
+          <a:p>
+            <a:pPr marL="0" marR="0" lvl="0" indent="0" algn="l" defTabSz="914400" rtl="0" eaLnBrk="0" fontAlgn="base" latinLnBrk="0" hangingPunct="0">
+              <a:lnSpc>
+                <a:spcPct val="100000"/>
+              </a:lnSpc>
+              <a:spcBef>
+                <a:spcPct val="0"/>
+              </a:spcBef>
+              <a:spcAft>
+                <a:spcPct val="0"/>
+              </a:spcAft>
+              <a:buClrTx/>
+              <a:buSzTx/>
+              <a:buFontTx/>
+              <a:buNone/>
+              <a:tabLst/>
+            </a:pPr>
+            <a:r>
+              <a:rPr kumimoji="0" lang="en-US" altLang="en-US" sz="1400" b="0" i="0" u="none" strike="noStrike" cap="none" normalizeH="0" baseline="0" dirty="0">
+                <a:ln>
+                  <a:noFill/>
+                </a:ln>
+                <a:solidFill>
+                  <a:schemeClr val="tx1"/>
+                </a:solidFill>
+                <a:effectLst/>
+                <a:latin typeface="Aptos" panose="020B0004020202020204" pitchFamily="34" charset="0"/>
+                <a:ea typeface="MS Mincho" panose="02020609040205080304" pitchFamily="49" charset="-128"/>
+                <a:cs typeface="Cambria" panose="02040503050406030204" pitchFamily="18" charset="0"/>
+              </a:rPr>
+              <a:t>The | </a:t>
+            </a:r>
+            <a:r>
+              <a:rPr kumimoji="0" lang="en-US" altLang="en-US" sz="1400" b="0" i="0" u="none" strike="noStrike" cap="none" normalizeH="0" baseline="0" dirty="0">
+                <a:ln>
+                  <a:noFill/>
+                </a:ln>
+                <a:solidFill>
+                  <a:schemeClr val="tx1"/>
+                </a:solidFill>
+                <a:effectLst/>
+                <a:highlight>
+                  <a:srgbClr val="00FFFF"/>
+                </a:highlight>
+                <a:latin typeface="Aptos" panose="020B0004020202020204" pitchFamily="34" charset="0"/>
+                <a:ea typeface="MS Mincho" panose="02020609040205080304" pitchFamily="49" charset="-128"/>
+                <a:cs typeface="Cambria" panose="02040503050406030204" pitchFamily="18" charset="0"/>
+              </a:rPr>
+              <a:t>un</a:t>
+            </a:r>
+            <a:r>
+              <a:rPr kumimoji="0" lang="en-US" altLang="en-US" sz="1400" b="0" i="0" u="none" strike="noStrike" cap="none" normalizeH="0" baseline="0" dirty="0">
+                <a:ln>
+                  <a:noFill/>
+                </a:ln>
+                <a:solidFill>
+                  <a:schemeClr val="tx1"/>
+                </a:solidFill>
+                <a:effectLst/>
+                <a:latin typeface="Aptos" panose="020B0004020202020204" pitchFamily="34" charset="0"/>
+                <a:ea typeface="MS Mincho" panose="02020609040205080304" pitchFamily="49" charset="-128"/>
+                <a:cs typeface="Cambria" panose="02040503050406030204" pitchFamily="18" charset="0"/>
+              </a:rPr>
+              <a:t> | </a:t>
+            </a:r>
+            <a:r>
+              <a:rPr kumimoji="0" lang="en-US" altLang="en-US" sz="1400" b="0" i="0" u="none" strike="noStrike" cap="none" normalizeH="0" baseline="0" dirty="0" err="1">
+                <a:ln>
+                  <a:noFill/>
+                </a:ln>
+                <a:solidFill>
+                  <a:schemeClr val="tx1"/>
+                </a:solidFill>
+                <a:effectLst/>
+                <a:highlight>
+                  <a:srgbClr val="FFFF00"/>
+                </a:highlight>
+                <a:latin typeface="Aptos" panose="020B0004020202020204" pitchFamily="34" charset="0"/>
+                <a:ea typeface="MS Mincho" panose="02020609040205080304" pitchFamily="49" charset="-128"/>
+                <a:cs typeface="Cambria" panose="02040503050406030204" pitchFamily="18" charset="0"/>
+              </a:rPr>
+              <a:t>believ</a:t>
+            </a:r>
+            <a:r>
+              <a:rPr kumimoji="0" lang="en-US" altLang="en-US" sz="1400" b="0" i="0" u="none" strike="noStrike" cap="none" normalizeH="0" baseline="0" dirty="0">
+                <a:ln>
+                  <a:noFill/>
+                </a:ln>
+                <a:solidFill>
+                  <a:schemeClr val="tx1"/>
+                </a:solidFill>
+                <a:effectLst/>
+                <a:latin typeface="Aptos" panose="020B0004020202020204" pitchFamily="34" charset="0"/>
+                <a:ea typeface="MS Mincho" panose="02020609040205080304" pitchFamily="49" charset="-128"/>
+                <a:cs typeface="Cambria" panose="02040503050406030204" pitchFamily="18" charset="0"/>
+              </a:rPr>
+              <a:t> | </a:t>
+            </a:r>
+            <a:r>
+              <a:rPr kumimoji="0" lang="en-US" altLang="en-US" sz="1400" b="0" i="0" u="none" strike="noStrike" cap="none" normalizeH="0" baseline="0" dirty="0">
+                <a:ln>
+                  <a:noFill/>
+                </a:ln>
+                <a:solidFill>
+                  <a:schemeClr val="tx1"/>
+                </a:solidFill>
+                <a:effectLst/>
+                <a:highlight>
+                  <a:srgbClr val="00FF00"/>
+                </a:highlight>
+                <a:latin typeface="Aptos" panose="020B0004020202020204" pitchFamily="34" charset="0"/>
+                <a:ea typeface="MS Mincho" panose="02020609040205080304" pitchFamily="49" charset="-128"/>
+                <a:cs typeface="Cambria" panose="02040503050406030204" pitchFamily="18" charset="0"/>
+              </a:rPr>
+              <a:t>able</a:t>
+            </a:r>
+            <a:r>
+              <a:rPr kumimoji="0" lang="en-US" altLang="en-US" sz="1400" b="0" i="0" u="none" strike="noStrike" cap="none" normalizeH="0" baseline="0" dirty="0">
+                <a:ln>
+                  <a:noFill/>
+                </a:ln>
+                <a:solidFill>
+                  <a:schemeClr val="tx1"/>
+                </a:solidFill>
+                <a:effectLst/>
+                <a:latin typeface="Aptos" panose="020B0004020202020204" pitchFamily="34" charset="0"/>
+                <a:ea typeface="MS Mincho" panose="02020609040205080304" pitchFamily="49" charset="-128"/>
+                <a:cs typeface="Cambria" panose="02040503050406030204" pitchFamily="18" charset="0"/>
+              </a:rPr>
+              <a:t> | </a:t>
+            </a:r>
+            <a:r>
+              <a:rPr kumimoji="0" lang="en-US" altLang="en-US" sz="1400" b="0" i="0" u="none" strike="noStrike" cap="none" normalizeH="0" baseline="0" dirty="0">
+                <a:ln>
+                  <a:noFill/>
+                </a:ln>
+                <a:solidFill>
+                  <a:schemeClr val="tx1"/>
+                </a:solidFill>
+                <a:effectLst/>
+                <a:highlight>
+                  <a:srgbClr val="C0C0C0"/>
+                </a:highlight>
+                <a:latin typeface="Aptos" panose="020B0004020202020204" pitchFamily="34" charset="0"/>
+                <a:ea typeface="MS Mincho" panose="02020609040205080304" pitchFamily="49" charset="-128"/>
+                <a:cs typeface="Cambria" panose="02040503050406030204" pitchFamily="18" charset="0"/>
+              </a:rPr>
+              <a:t>re</a:t>
+            </a:r>
+            <a:r>
+              <a:rPr kumimoji="0" lang="en-US" altLang="en-US" sz="1400" b="0" i="0" u="none" strike="noStrike" cap="none" normalizeH="0" baseline="0" dirty="0">
+                <a:ln>
+                  <a:noFill/>
+                </a:ln>
+                <a:solidFill>
+                  <a:schemeClr val="tx1"/>
+                </a:solidFill>
+                <a:effectLst/>
+                <a:latin typeface="Aptos" panose="020B0004020202020204" pitchFamily="34" charset="0"/>
+                <a:ea typeface="MS Mincho" panose="02020609040205080304" pitchFamily="49" charset="-128"/>
+                <a:cs typeface="Cambria" panose="02040503050406030204" pitchFamily="18" charset="0"/>
+              </a:rPr>
+              <a:t> | </a:t>
+            </a:r>
+            <a:r>
+              <a:rPr kumimoji="0" lang="en-US" altLang="en-US" sz="1400" b="0" i="0" u="none" strike="noStrike" cap="none" normalizeH="0" baseline="0" dirty="0">
+                <a:ln>
+                  <a:noFill/>
+                </a:ln>
+                <a:solidFill>
+                  <a:schemeClr val="tx1"/>
+                </a:solidFill>
+                <a:effectLst/>
+                <a:highlight>
+                  <a:srgbClr val="FF00FF"/>
+                </a:highlight>
+                <a:latin typeface="Aptos" panose="020B0004020202020204" pitchFamily="34" charset="0"/>
+                <a:ea typeface="MS Mincho" panose="02020609040205080304" pitchFamily="49" charset="-128"/>
+                <a:cs typeface="Cambria" panose="02040503050406030204" pitchFamily="18" charset="0"/>
+              </a:rPr>
+              <a:t>play</a:t>
+            </a:r>
+            <a:r>
+              <a:rPr kumimoji="0" lang="en-US" altLang="en-US" sz="1400" b="0" i="0" u="none" strike="noStrike" cap="none" normalizeH="0" baseline="0" dirty="0">
+                <a:ln>
+                  <a:noFill/>
+                </a:ln>
+                <a:solidFill>
+                  <a:schemeClr val="tx1"/>
+                </a:solidFill>
+                <a:effectLst/>
+                <a:latin typeface="Aptos" panose="020B0004020202020204" pitchFamily="34" charset="0"/>
+                <a:ea typeface="MS Mincho" panose="02020609040205080304" pitchFamily="49" charset="-128"/>
+                <a:cs typeface="Cambria" panose="02040503050406030204" pitchFamily="18" charset="0"/>
+              </a:rPr>
+              <a:t> | was | </a:t>
+            </a:r>
+            <a:r>
+              <a:rPr kumimoji="0" lang="en-US" altLang="en-US" sz="1400" b="0" i="0" u="none" strike="noStrike" cap="none" normalizeH="0" baseline="0" dirty="0">
+                <a:ln>
+                  <a:noFill/>
+                </a:ln>
+                <a:solidFill>
+                  <a:schemeClr val="tx1"/>
+                </a:solidFill>
+                <a:effectLst/>
+                <a:highlight>
+                  <a:srgbClr val="C0C0C0"/>
+                </a:highlight>
+                <a:latin typeface="Aptos" panose="020B0004020202020204" pitchFamily="34" charset="0"/>
+                <a:ea typeface="MS Mincho" panose="02020609040205080304" pitchFamily="49" charset="-128"/>
+                <a:cs typeface="Cambria" panose="02040503050406030204" pitchFamily="18" charset="0"/>
+              </a:rPr>
+              <a:t>re</a:t>
+            </a:r>
+            <a:r>
+              <a:rPr kumimoji="0" lang="en-US" altLang="en-US" sz="1400" b="0" i="0" u="none" strike="noStrike" cap="none" normalizeH="0" baseline="0" dirty="0">
+                <a:ln>
+                  <a:noFill/>
+                </a:ln>
+                <a:solidFill>
+                  <a:schemeClr val="tx1"/>
+                </a:solidFill>
+                <a:effectLst/>
+                <a:latin typeface="Aptos" panose="020B0004020202020204" pitchFamily="34" charset="0"/>
+                <a:ea typeface="MS Mincho" panose="02020609040205080304" pitchFamily="49" charset="-128"/>
+                <a:cs typeface="Cambria" panose="02040503050406030204" pitchFamily="18" charset="0"/>
+              </a:rPr>
+              <a:t> | </a:t>
+            </a:r>
+            <a:r>
+              <a:rPr kumimoji="0" lang="en-US" altLang="en-US" sz="1400" b="0" i="0" u="none" strike="noStrike" cap="none" normalizeH="0" baseline="0" dirty="0">
+                <a:ln>
+                  <a:noFill/>
+                </a:ln>
+                <a:solidFill>
+                  <a:schemeClr val="tx1"/>
+                </a:solidFill>
+                <a:effectLst/>
+                <a:highlight>
+                  <a:srgbClr val="FF00FF"/>
+                </a:highlight>
+                <a:latin typeface="Aptos" panose="020B0004020202020204" pitchFamily="34" charset="0"/>
+                <a:ea typeface="MS Mincho" panose="02020609040205080304" pitchFamily="49" charset="-128"/>
+                <a:cs typeface="Cambria" panose="02040503050406030204" pitchFamily="18" charset="0"/>
+              </a:rPr>
+              <a:t>play</a:t>
+            </a:r>
+            <a:r>
+              <a:rPr kumimoji="0" lang="en-US" altLang="en-US" sz="1400" b="0" i="0" u="none" strike="noStrike" cap="none" normalizeH="0" baseline="0" dirty="0">
+                <a:ln>
+                  <a:noFill/>
+                </a:ln>
+                <a:solidFill>
+                  <a:schemeClr val="tx1"/>
+                </a:solidFill>
+                <a:effectLst/>
+                <a:latin typeface="Aptos" panose="020B0004020202020204" pitchFamily="34" charset="0"/>
+                <a:ea typeface="MS Mincho" panose="02020609040205080304" pitchFamily="49" charset="-128"/>
+                <a:cs typeface="Cambria" panose="02040503050406030204" pitchFamily="18" charset="0"/>
+              </a:rPr>
+              <a:t> | ed | </a:t>
+            </a:r>
+            <a:r>
+              <a:rPr kumimoji="0" lang="en-US" altLang="en-US" sz="1400" b="0" i="0" u="none" strike="noStrike" cap="none" normalizeH="0" baseline="0" dirty="0">
+                <a:ln>
+                  <a:noFill/>
+                </a:ln>
+                <a:solidFill>
+                  <a:schemeClr val="tx1"/>
+                </a:solidFill>
+                <a:effectLst/>
+                <a:highlight>
+                  <a:srgbClr val="00FFFF"/>
+                </a:highlight>
+                <a:latin typeface="Aptos" panose="020B0004020202020204" pitchFamily="34" charset="0"/>
+                <a:ea typeface="MS Mincho" panose="02020609040205080304" pitchFamily="49" charset="-128"/>
+                <a:cs typeface="Cambria" panose="02040503050406030204" pitchFamily="18" charset="0"/>
+              </a:rPr>
+              <a:t>un</a:t>
+            </a:r>
+            <a:r>
+              <a:rPr kumimoji="0" lang="en-US" altLang="en-US" sz="1400" b="0" i="0" u="none" strike="noStrike" cap="none" normalizeH="0" baseline="0" dirty="0">
+                <a:ln>
+                  <a:noFill/>
+                </a:ln>
+                <a:solidFill>
+                  <a:schemeClr val="tx1"/>
+                </a:solidFill>
+                <a:effectLst/>
+                <a:latin typeface="Aptos" panose="020B0004020202020204" pitchFamily="34" charset="0"/>
+                <a:ea typeface="MS Mincho" panose="02020609040205080304" pitchFamily="49" charset="-128"/>
+                <a:cs typeface="Cambria" panose="02040503050406030204" pitchFamily="18" charset="0"/>
+              </a:rPr>
+              <a:t> | </a:t>
+            </a:r>
+            <a:r>
+              <a:rPr kumimoji="0" lang="en-US" altLang="en-US" sz="1400" b="0" i="0" u="none" strike="noStrike" cap="none" normalizeH="0" baseline="0" dirty="0" err="1">
+                <a:ln>
+                  <a:noFill/>
+                </a:ln>
+                <a:solidFill>
+                  <a:schemeClr val="tx1"/>
+                </a:solidFill>
+                <a:effectLst/>
+                <a:highlight>
+                  <a:srgbClr val="FFFF00"/>
+                </a:highlight>
+                <a:latin typeface="Aptos" panose="020B0004020202020204" pitchFamily="34" charset="0"/>
+                <a:ea typeface="MS Mincho" panose="02020609040205080304" pitchFamily="49" charset="-128"/>
+                <a:cs typeface="Cambria" panose="02040503050406030204" pitchFamily="18" charset="0"/>
+              </a:rPr>
+              <a:t>believ</a:t>
+            </a:r>
+            <a:r>
+              <a:rPr kumimoji="0" lang="en-US" altLang="en-US" sz="1400" b="0" i="0" u="none" strike="noStrike" cap="none" normalizeH="0" baseline="0" dirty="0">
+                <a:ln>
+                  <a:noFill/>
+                </a:ln>
+                <a:solidFill>
+                  <a:schemeClr val="tx1"/>
+                </a:solidFill>
+                <a:effectLst/>
+                <a:latin typeface="Aptos" panose="020B0004020202020204" pitchFamily="34" charset="0"/>
+                <a:ea typeface="MS Mincho" panose="02020609040205080304" pitchFamily="49" charset="-128"/>
+                <a:cs typeface="Cambria" panose="02040503050406030204" pitchFamily="18" charset="0"/>
+              </a:rPr>
+              <a:t> | </a:t>
+            </a:r>
+            <a:r>
+              <a:rPr kumimoji="0" lang="en-US" altLang="en-US" sz="1400" b="0" i="0" u="none" strike="noStrike" cap="none" normalizeH="0" baseline="0" dirty="0">
+                <a:ln>
+                  <a:noFill/>
+                </a:ln>
+                <a:solidFill>
+                  <a:schemeClr val="tx1"/>
+                </a:solidFill>
+                <a:effectLst/>
+                <a:highlight>
+                  <a:srgbClr val="00FF00"/>
+                </a:highlight>
+                <a:latin typeface="Aptos" panose="020B0004020202020204" pitchFamily="34" charset="0"/>
+                <a:ea typeface="MS Mincho" panose="02020609040205080304" pitchFamily="49" charset="-128"/>
+                <a:cs typeface="Cambria" panose="02040503050406030204" pitchFamily="18" charset="0"/>
+              </a:rPr>
+              <a:t>able</a:t>
+            </a:r>
+            <a:r>
+              <a:rPr kumimoji="0" lang="en-US" altLang="en-US" sz="1400" b="0" i="0" u="none" strike="noStrike" cap="none" normalizeH="0" baseline="0" dirty="0">
+                <a:ln>
+                  <a:noFill/>
+                </a:ln>
+                <a:solidFill>
+                  <a:schemeClr val="tx1"/>
+                </a:solidFill>
+                <a:effectLst/>
+                <a:latin typeface="Aptos" panose="020B0004020202020204" pitchFamily="34" charset="0"/>
+                <a:ea typeface="MS Mincho" panose="02020609040205080304" pitchFamily="49" charset="-128"/>
+                <a:cs typeface="Cambria" panose="02040503050406030204" pitchFamily="18" charset="0"/>
+              </a:rPr>
+              <a:t> | </a:t>
+            </a:r>
+            <a:r>
+              <a:rPr kumimoji="0" lang="en-US" altLang="en-US" sz="1400" b="0" i="0" u="none" strike="noStrike" cap="none" normalizeH="0" baseline="0" dirty="0" err="1">
+                <a:ln>
+                  <a:noFill/>
+                </a:ln>
+                <a:solidFill>
+                  <a:schemeClr val="tx1"/>
+                </a:solidFill>
+                <a:effectLst/>
+                <a:latin typeface="Aptos" panose="020B0004020202020204" pitchFamily="34" charset="0"/>
+                <a:ea typeface="MS Mincho" panose="02020609040205080304" pitchFamily="49" charset="-128"/>
+                <a:cs typeface="Cambria" panose="02040503050406030204" pitchFamily="18" charset="0"/>
+              </a:rPr>
+              <a:t>ly</a:t>
+            </a:r>
+            <a:endParaRPr kumimoji="0" lang="en-US" altLang="en-US" sz="1400" b="0" i="0" u="none" strike="noStrike" cap="none" normalizeH="0" baseline="0" dirty="0">
+              <a:ln>
+                <a:noFill/>
+              </a:ln>
+              <a:solidFill>
+                <a:schemeClr val="tx1"/>
+              </a:solidFill>
+              <a:effectLst/>
+              <a:latin typeface="Aptos" panose="020B0004020202020204" pitchFamily="34" charset="0"/>
+              <a:ea typeface="MS Mincho" panose="02020609040205080304" pitchFamily="49" charset="-128"/>
+              <a:cs typeface="Cambria" panose="02040503050406030204" pitchFamily="18" charset="0"/>
+            </a:endParaRPr>
+          </a:p>
+          <a:p>
+            <a:pPr marL="0" marR="0" lvl="0" indent="0" algn="l" defTabSz="914400" rtl="0" eaLnBrk="0" fontAlgn="base" latinLnBrk="0" hangingPunct="0">
+              <a:lnSpc>
+                <a:spcPct val="100000"/>
+              </a:lnSpc>
+              <a:spcBef>
+                <a:spcPct val="0"/>
+              </a:spcBef>
+              <a:spcAft>
+                <a:spcPct val="0"/>
+              </a:spcAft>
+              <a:buClrTx/>
+              <a:buSzTx/>
+              <a:buFontTx/>
+              <a:buNone/>
+              <a:tabLst/>
+            </a:pPr>
+            <a:r>
+              <a:rPr lang="en-US" sz="1400" dirty="0"/>
+              <a:t>The model can store </a:t>
+            </a:r>
+            <a:r>
+              <a:rPr lang="en-US" sz="1400" u="sng" dirty="0"/>
+              <a:t>reusable token fragments</a:t>
+            </a:r>
+            <a:endParaRPr kumimoji="0" lang="en-US" altLang="en-US" sz="1400" b="0" i="0" u="sng" strike="noStrike" cap="none" normalizeH="0" baseline="0" dirty="0">
+              <a:ln>
+                <a:noFill/>
+              </a:ln>
+              <a:solidFill>
+                <a:schemeClr val="tx1"/>
+              </a:solidFill>
+              <a:effectLst/>
+              <a:latin typeface="Aptos" panose="020B0004020202020204" pitchFamily="34" charset="0"/>
+              <a:ea typeface="MS Mincho" panose="02020609040205080304" pitchFamily="49" charset="-128"/>
+              <a:cs typeface="Cambria" panose="02040503050406030204" pitchFamily="18" charset="0"/>
+            </a:endParaRPr>
+          </a:p>
+        </p:txBody>
+      </p:sp>
+      <p:sp>
+        <p:nvSpPr>
+          <p:cNvPr id="12" name="TextBox 11">
+            <a:extLst>
+              <a:ext uri="{FF2B5EF4-FFF2-40B4-BE49-F238E27FC236}">
+                <a16:creationId xmlns:a16="http://schemas.microsoft.com/office/drawing/2014/main" id="{5B802190-2FB1-3317-D97F-381C8AC829A6}"/>
+              </a:ext>
+            </a:extLst>
+          </p:cNvPr>
+          <p:cNvSpPr txBox="1"/>
+          <p:nvPr/>
+        </p:nvSpPr>
+        <p:spPr>
+          <a:xfrm>
+            <a:off x="822960" y="3755395"/>
+            <a:ext cx="6097508" cy="261610"/>
+          </a:xfrm>
+          <a:prstGeom prst="rect">
+            <a:avLst/>
+          </a:prstGeom>
+          <a:noFill/>
+        </p:spPr>
+        <p:txBody>
+          <a:bodyPr wrap="square">
+            <a:spAutoFit/>
+          </a:bodyPr>
+          <a:lstStyle/>
+          <a:p>
+            <a:r>
+              <a:rPr lang="en-US" sz="1100" i="1" dirty="0"/>
+              <a:t>An example of how GPT-4 tokenizes a phrase.</a:t>
             </a:r>
           </a:p>
         </p:txBody>

</xml_diff>

<commit_message>
Added details on embeddings and vectors, and added a script to update the learning dashboard with new content.
</commit_message>
<xml_diff>
--- a/pptx/Session_01_Tokens_v1.0.pptx
+++ b/pptx/Session_01_Tokens_v1.0.pptx
@@ -1,6 +1,6 @@
 
 <file path=ppt/presentation.xml><?xml version="1.0" encoding="utf-8"?>
-<p:presentation xmlns:a="http://schemas.openxmlformats.org/drawingml/2006/main" xmlns:r="http://schemas.openxmlformats.org/officeDocument/2006/relationships" xmlns:p="http://schemas.openxmlformats.org/presentationml/2006/main" saveSubsetFonts="1" autoCompressPictures="0">
+<p:presentation xmlns:a="http://schemas.openxmlformats.org/drawingml/2006/main" xmlns:ns3="http://schemas.microsoft.com/office/powerpoint/2012/main" xmlns:p="http://schemas.openxmlformats.org/presentationml/2006/main" xmlns:r="http://schemas.openxmlformats.org/officeDocument/2006/relationships" saveSubsetFonts="1" autoCompressPictures="0">
   <p:sldMasterIdLst>
     <p:sldMasterId id="2147483648" r:id="rId1"/>
   </p:sldMasterIdLst>
@@ -15,6 +15,7 @@
     <p:sldId id="267" r:id="rId9"/>
     <p:sldId id="260" r:id="rId10"/>
     <p:sldId id="268" r:id="rId11"/>
+    <p:sldId id="275" r:id="rId25"/>
     <p:sldId id="261" r:id="rId12"/>
     <p:sldId id="269" r:id="rId13"/>
     <p:sldId id="262" r:id="rId14"/>
@@ -124,18 +125,18 @@
   </p:defaultTextStyle>
   <p:extLst>
     <p:ext uri="{EFAFB233-063F-42B5-8137-9DF3F51BA10A}">
-      <p15:sldGuideLst xmlns:p15="http://schemas.microsoft.com/office/powerpoint/2012/main">
-        <p15:guide id="1" orient="horz" pos="2160">
-          <p15:clr>
+      <ns3:sldGuideLst>
+        <ns3:guide id="1" orient="horz" pos="2160">
+          <ns3:clr>
             <a:srgbClr val="A4A3A4"/>
-          </p15:clr>
-        </p15:guide>
-        <p15:guide id="2" pos="2880">
-          <p15:clr>
+          </ns3:clr>
+        </ns3:guide>
+        <ns3:guide id="2" pos="2880">
+          <ns3:clr>
             <a:srgbClr val="A4A3A4"/>
-          </p15:clr>
-        </p15:guide>
-      </p15:sldGuideLst>
+          </ns3:clr>
+        </ns3:guide>
+      </ns3:sldGuideLst>
     </p:ext>
   </p:extLst>
 </p:presentation>
@@ -320,7 +321,7 @@
           <a:p>
             <a:fld id="{5BCAD085-E8A6-8845-BD4E-CB4CCA059FC4}" type="datetimeFigureOut">
               <a:rPr lang="en-US" smtClean="0"/>
-              <a:t>5/25/2026</a:t>
+              <a:t>5/26/2026</a:t>
             </a:fld>
             <a:endParaRPr lang="en-US"/>
           </a:p>
@@ -488,7 +489,7 @@
           <a:p>
             <a:fld id="{5BCAD085-E8A6-8845-BD4E-CB4CCA059FC4}" type="datetimeFigureOut">
               <a:rPr lang="en-US" smtClean="0"/>
-              <a:t>5/25/2026</a:t>
+              <a:t>5/26/2026</a:t>
             </a:fld>
             <a:endParaRPr lang="en-US"/>
           </a:p>
@@ -666,7 +667,7 @@
           <a:p>
             <a:fld id="{5BCAD085-E8A6-8845-BD4E-CB4CCA059FC4}" type="datetimeFigureOut">
               <a:rPr lang="en-US" smtClean="0"/>
-              <a:t>5/25/2026</a:t>
+              <a:t>5/26/2026</a:t>
             </a:fld>
             <a:endParaRPr lang="en-US"/>
           </a:p>
@@ -834,7 +835,7 @@
           <a:p>
             <a:fld id="{5BCAD085-E8A6-8845-BD4E-CB4CCA059FC4}" type="datetimeFigureOut">
               <a:rPr lang="en-US" smtClean="0"/>
-              <a:t>5/25/2026</a:t>
+              <a:t>5/26/2026</a:t>
             </a:fld>
             <a:endParaRPr lang="en-US"/>
           </a:p>
@@ -1079,7 +1080,7 @@
           <a:p>
             <a:fld id="{5BCAD085-E8A6-8845-BD4E-CB4CCA059FC4}" type="datetimeFigureOut">
               <a:rPr lang="en-US" smtClean="0"/>
-              <a:t>5/25/2026</a:t>
+              <a:t>5/26/2026</a:t>
             </a:fld>
             <a:endParaRPr lang="en-US"/>
           </a:p>
@@ -1364,7 +1365,7 @@
           <a:p>
             <a:fld id="{5BCAD085-E8A6-8845-BD4E-CB4CCA059FC4}" type="datetimeFigureOut">
               <a:rPr lang="en-US" smtClean="0"/>
-              <a:t>5/25/2026</a:t>
+              <a:t>5/26/2026</a:t>
             </a:fld>
             <a:endParaRPr lang="en-US"/>
           </a:p>
@@ -1783,7 +1784,7 @@
           <a:p>
             <a:fld id="{5BCAD085-E8A6-8845-BD4E-CB4CCA059FC4}" type="datetimeFigureOut">
               <a:rPr lang="en-US" smtClean="0"/>
-              <a:t>5/25/2026</a:t>
+              <a:t>5/26/2026</a:t>
             </a:fld>
             <a:endParaRPr lang="en-US"/>
           </a:p>
@@ -1900,7 +1901,7 @@
           <a:p>
             <a:fld id="{5BCAD085-E8A6-8845-BD4E-CB4CCA059FC4}" type="datetimeFigureOut">
               <a:rPr lang="en-US" smtClean="0"/>
-              <a:t>5/25/2026</a:t>
+              <a:t>5/26/2026</a:t>
             </a:fld>
             <a:endParaRPr lang="en-US"/>
           </a:p>
@@ -1995,7 +1996,7 @@
           <a:p>
             <a:fld id="{5BCAD085-E8A6-8845-BD4E-CB4CCA059FC4}" type="datetimeFigureOut">
               <a:rPr lang="en-US" smtClean="0"/>
-              <a:t>5/25/2026</a:t>
+              <a:t>5/26/2026</a:t>
             </a:fld>
             <a:endParaRPr lang="en-US"/>
           </a:p>
@@ -2270,7 +2271,7 @@
           <a:p>
             <a:fld id="{5BCAD085-E8A6-8845-BD4E-CB4CCA059FC4}" type="datetimeFigureOut">
               <a:rPr lang="en-US" smtClean="0"/>
-              <a:t>5/25/2026</a:t>
+              <a:t>5/26/2026</a:t>
             </a:fld>
             <a:endParaRPr lang="en-US"/>
           </a:p>
@@ -2522,7 +2523,7 @@
           <a:p>
             <a:fld id="{5BCAD085-E8A6-8845-BD4E-CB4CCA059FC4}" type="datetimeFigureOut">
               <a:rPr lang="en-US" smtClean="0"/>
-              <a:t>5/25/2026</a:t>
+              <a:t>5/26/2026</a:t>
             </a:fld>
             <a:endParaRPr lang="en-US"/>
           </a:p>
@@ -2733,7 +2734,7 @@
           <a:p>
             <a:fld id="{5BCAD085-E8A6-8845-BD4E-CB4CCA059FC4}" type="datetimeFigureOut">
               <a:rPr lang="en-US" smtClean="0"/>
-              <a:t>5/25/2026</a:t>
+              <a:t>5/26/2026</a:t>
             </a:fld>
             <a:endParaRPr lang="en-US"/>
           </a:p>
@@ -3545,7 +3546,7 @@
         </p:nvSpPr>
         <p:spPr>
           <a:xfrm>
-            <a:off x="1097280" y="4206240"/>
+            <a:off x="822960" y="5577840"/>
             <a:ext cx="9966960" cy="914400"/>
           </a:xfrm>
           <a:prstGeom prst="roundRect">
@@ -3624,8 +3625,145 @@
                 </a:solidFill>
                 <a:latin typeface="Aptos"/>
               </a:rPr>
-              <a:t>AI Under the hood | Slide 9</a:t>
-            </a:r>
+              <a:t>AI Under the hood | Slide 10</a:t>
+            </a:r>
+          </a:p>
+        </p:txBody>
+      </p:sp>
+      <p:sp>
+        <p:nvSpPr>
+          <p:cNvPr id="9" name="Definition">
+            <a:extLst>
+              <a:ext uri="{FF2B5EF4-FFF2-40B4-BE49-F238E27FC236}">
+                <a16:creationId xmlns:a16="http://schemas.microsoft.com/office/drawing/2014/main" id="{0FCD2D10-DB6A-EBB2-1E45-F3B0AF2ABB4B}"/>
+              </a:ext>
+            </a:extLst>
+          </p:cNvPr>
+          <p:cNvSpPr/>
+          <p:nvPr/>
+        </p:nvSpPr>
+        <p:spPr>
+          <a:xfrm>
+            <a:off x="822959" y="3831882"/>
+            <a:ext cx="9784081" cy="1654518"/>
+          </a:xfrm>
+          <a:prstGeom prst="roundRect">
+            <a:avLst/>
+          </a:prstGeom>
+          <a:solidFill>
+            <a:srgbClr val="F5F8FC"/>
+          </a:solidFill>
+          <a:ln>
+            <a:solidFill>
+              <a:srgbClr val="BED2E6"/>
+            </a:solidFill>
+          </a:ln>
+        </p:spPr>
+        <p:txBody>
+          <a:bodyPr lIns="137160" tIns="137160" rIns="137160" bIns="137160" rtlCol="0" anchor="t"/>
+          <a:lstStyle/>
+          <a:p>
+            <a:pPr algn="l">
+              <a:defRPr sz="1750"/>
+            </a:pPr>
+            <a:r>
+              <a:rPr lang="en-US" sz="1550" dirty="0">
+                <a:solidFill>
+                  <a:srgbClr val="0B2F5B"/>
+                </a:solidFill>
+                <a:latin typeface="Aptos" panose="020B0004020202020204" pitchFamily="34" charset="0"/>
+              </a:rPr>
+              <a:t>A neural network contains a gigantic Embedding table matrix</a:t>
+            </a:r>
+          </a:p>
+          <a:p>
+            <a:pPr algn="l">
+              <a:defRPr sz="1750"/>
+            </a:pPr>
+            <a:endParaRPr lang="en-US" sz="1550" dirty="0">
+              <a:solidFill>
+                <a:srgbClr val="0B2F5B"/>
+              </a:solidFill>
+              <a:latin typeface="Aptos" panose="020B0004020202020204" pitchFamily="34" charset="0"/>
+            </a:endParaRPr>
+          </a:p>
+          <a:p>
+            <a:pPr algn="l">
+              <a:defRPr sz="1750"/>
+            </a:pPr>
+            <a:r>
+              <a:rPr lang="en-US" sz="1550" dirty="0">
+                <a:solidFill>
+                  <a:srgbClr val="0B2F5B"/>
+                </a:solidFill>
+                <a:latin typeface="Aptos" panose="020B0004020202020204" pitchFamily="34" charset="0"/>
+              </a:rPr>
+              <a:t>Example dimensions:  Vocabulary size * Embedding dimension</a:t>
+            </a:r>
+          </a:p>
+          <a:p>
+            <a:pPr algn="l">
+              <a:defRPr sz="1750"/>
+            </a:pPr>
+            <a:r>
+              <a:rPr lang="en-US" sz="1550" dirty="0">
+                <a:solidFill>
+                  <a:srgbClr val="0B2F5B"/>
+                </a:solidFill>
+                <a:latin typeface="Aptos" panose="020B0004020202020204" pitchFamily="34" charset="0"/>
+              </a:rPr>
+              <a:t>GPT4                                            100,256          *               1,536</a:t>
+            </a:r>
+          </a:p>
+          <a:p>
+            <a:pPr algn="l">
+              <a:defRPr sz="1750"/>
+            </a:pPr>
+            <a:endParaRPr lang="en-US" sz="1550" dirty="0">
+              <a:solidFill>
+                <a:srgbClr val="0B2F5B"/>
+              </a:solidFill>
+              <a:latin typeface="Aptos" panose="020B0004020202020204" pitchFamily="34" charset="0"/>
+            </a:endParaRPr>
+          </a:p>
+          <a:p>
+            <a:pPr algn="l">
+              <a:defRPr sz="1750"/>
+            </a:pPr>
+            <a:r>
+              <a:rPr lang="en-US" sz="1550" dirty="0">
+                <a:solidFill>
+                  <a:srgbClr val="0B2F5B"/>
+                </a:solidFill>
+                <a:latin typeface="Aptos" panose="020B0004020202020204" pitchFamily="34" charset="0"/>
+              </a:rPr>
+              <a:t>Meaning: each token is represented by 1,536 floating point numbers</a:t>
+            </a:r>
+            <a:endParaRPr lang="en-US" sz="1550" dirty="0">
+              <a:latin typeface="Aptos" panose="020B0004020202020204" pitchFamily="34" charset="0"/>
+            </a:endParaRPr>
+          </a:p>
+          <a:p>
+            <a:pPr algn="l">
+              <a:defRPr sz="1750"/>
+            </a:pPr>
+            <a:endParaRPr sz="1750" dirty="0">
+              <a:solidFill>
+                <a:srgbClr val="0B2F5B"/>
+              </a:solidFill>
+              <a:latin typeface="Aptos"/>
+            </a:endParaRPr>
+          </a:p>
+          <a:p>
+            <a:pPr algn="l">
+              <a:defRPr sz="1550"/>
+            </a:pPr>
+            <a:endParaRPr sz="1550" dirty="0">
+              <a:solidFill>
+                <a:srgbClr val="172B4D"/>
+              </a:solidFill>
+              <a:latin typeface="Aptos"/>
+            </a:endParaRPr>
           </a:p>
         </p:txBody>
       </p:sp>
@@ -3733,7 +3871,7 @@
         <p:spPr>
           <a:xfrm>
             <a:off x="914400" y="1280160"/>
-            <a:ext cx="10424160" cy="1965960"/>
+            <a:ext cx="10424160" cy="1616949"/>
           </a:xfrm>
           <a:prstGeom prst="roundRect">
             <a:avLst/>
@@ -3802,7 +3940,7 @@
         </p:nvSpPr>
         <p:spPr>
           <a:xfrm>
-            <a:off x="914400" y="3749039"/>
+            <a:off x="868680" y="5288128"/>
             <a:ext cx="10424160" cy="1097280"/>
           </a:xfrm>
           <a:prstGeom prst="roundRect">
@@ -3895,8 +4033,87 @@
               </a:defRPr>
             </a:pPr>
             <a:r>
-              <a:t>AI Under the hood | Slide 10</a:t>
-            </a:r>
+              <a:t>AI Under the hood | Slide 12</a:t>
+            </a:r>
+          </a:p>
+        </p:txBody>
+      </p:sp>
+      <p:sp>
+        <p:nvSpPr>
+          <p:cNvPr id="7" name="Rounded Rectangle 3">
+            <a:extLst>
+              <a:ext uri="{FF2B5EF4-FFF2-40B4-BE49-F238E27FC236}">
+                <a16:creationId xmlns:a16="http://schemas.microsoft.com/office/drawing/2014/main" id="{4D62C980-9521-DFEE-0DCD-FEEC67E8FE40}"/>
+              </a:ext>
+            </a:extLst>
+          </p:cNvPr>
+          <p:cNvSpPr/>
+          <p:nvPr/>
+        </p:nvSpPr>
+        <p:spPr>
+          <a:xfrm>
+            <a:off x="883920" y="3307531"/>
+            <a:ext cx="10424160" cy="1616949"/>
+          </a:xfrm>
+          <a:prstGeom prst="roundRect">
+            <a:avLst/>
+          </a:prstGeom>
+          <a:solidFill>
+            <a:srgbClr val="F5F8FC"/>
+          </a:solidFill>
+          <a:ln>
+            <a:solidFill>
+              <a:srgbClr val="BED2E6"/>
+            </a:solidFill>
+          </a:ln>
+        </p:spPr>
+        <p:style>
+          <a:lnRef idx="1">
+            <a:schemeClr val="accent1"/>
+          </a:lnRef>
+          <a:fillRef idx="3">
+            <a:schemeClr val="accent1"/>
+          </a:fillRef>
+          <a:effectRef idx="2">
+            <a:schemeClr val="accent1"/>
+          </a:effectRef>
+          <a:fontRef idx="minor">
+            <a:schemeClr val="lt1"/>
+          </a:fontRef>
+        </p:style>
+        <p:txBody>
+          <a:bodyPr lIns="182880" tIns="109728" rIns="182880" rtlCol="0" anchor="ctr"/>
+          <a:lstStyle/>
+          <a:p>
+            <a:pPr algn="ctr">
+              <a:defRPr sz="2200">
+                <a:solidFill>
+                  <a:srgbClr val="172B4D"/>
+                </a:solidFill>
+                <a:latin typeface="Consolas"/>
+              </a:defRPr>
+            </a:pPr>
+            <a:r>
+              <a:rPr lang="en-US" dirty="0"/>
+              <a:t>Conceptually: </a:t>
+            </a:r>
+            <a:r>
+              <a:rPr lang="en-US" dirty="0" err="1"/>
+              <a:t>EmbeddingMatrix</a:t>
+            </a:r>
+            <a:r>
+              <a:rPr lang="en-US" dirty="0"/>
+              <a:t>[ </a:t>
+            </a:r>
+            <a:r>
+              <a:rPr lang="en-US" dirty="0" err="1"/>
+              <a:t>token_id</a:t>
+            </a:r>
+            <a:r>
+              <a:rPr lang="en-US" dirty="0"/>
+              <a:t> ] returns a vector</a:t>
+            </a:r>
+            <a:endParaRPr dirty="0"/>
           </a:p>
         </p:txBody>
       </p:sp>
@@ -4076,7 +4293,7 @@
         <p:spPr>
           <a:xfrm>
             <a:off x="4846320" y="1188720"/>
-            <a:ext cx="5760720" cy="2560320"/>
+            <a:ext cx="5760720" cy="2377440"/>
           </a:xfrm>
           <a:prstGeom prst="roundRect">
             <a:avLst/>
@@ -4160,7 +4377,25 @@
                 </a:solidFill>
                 <a:latin typeface="Consolas"/>
               </a:rPr>
-              <a:t>4. Output: [-0.62, 0.18, 0.45, -0.09]</a:t>
+              <a:t>4. Output</a:t>
+            </a:r>
+            <a:r>
+              <a:rPr lang="en-US" sz="1500" dirty="0">
+                <a:solidFill>
+                  <a:srgbClr val="172B4D"/>
+                </a:solidFill>
+                <a:latin typeface="Consolas"/>
+              </a:rPr>
+              <a:t> Vector</a:t>
+            </a:r>
+            <a:r>
+              <a:rPr sz="1500" dirty="0">
+                <a:solidFill>
+                  <a:srgbClr val="172B4D"/>
+                </a:solidFill>
+                <a:latin typeface="Consolas"/>
+              </a:rPr>
+              <a:t>: [-0.62, 0.18, 0.45, -0.09]</a:t>
             </a:r>
           </a:p>
         </p:txBody>
@@ -4173,8 +4408,8 @@
         </p:nvSpPr>
         <p:spPr>
           <a:xfrm>
-            <a:off x="1097280" y="4206240"/>
-            <a:ext cx="9966960" cy="914400"/>
+            <a:off x="822960" y="4346840"/>
+            <a:ext cx="9966960" cy="1807072"/>
           </a:xfrm>
           <a:prstGeom prst="roundRect">
             <a:avLst/>
@@ -4204,6 +4439,12 @@
               </a:rPr>
               <a:t>Key takeaway</a:t>
             </a:r>
+            <a:endParaRPr lang="en-US" sz="1850" b="1" dirty="0">
+              <a:solidFill>
+                <a:srgbClr val="0B2F5B"/>
+              </a:solidFill>
+              <a:latin typeface="Aptos"/>
+            </a:endParaRPr>
           </a:p>
           <a:p>
             <a:pPr algn="ctr">
@@ -4216,8 +4457,86 @@
                 </a:solidFill>
                 <a:latin typeface="Aptos"/>
               </a:rPr>
-              <a:t>A vector is the numeric representation that moves forward. The values are learned, then selected by ID.</a:t>
-            </a:r>
+              <a:t>A vector is the numeric representation that moves forward. </a:t>
+            </a:r>
+            <a:endParaRPr lang="en-US" sz="1700" dirty="0">
+              <a:solidFill>
+                <a:srgbClr val="172B4D"/>
+              </a:solidFill>
+              <a:latin typeface="Aptos"/>
+            </a:endParaRPr>
+          </a:p>
+          <a:p>
+            <a:pPr algn="ctr">
+              <a:defRPr sz="1700"/>
+            </a:pPr>
+            <a:r>
+              <a:rPr sz="1700" dirty="0">
+                <a:solidFill>
+                  <a:srgbClr val="172B4D"/>
+                </a:solidFill>
+                <a:latin typeface="Aptos"/>
+              </a:rPr>
+              <a:t>The values are learned, then selected by ID.</a:t>
+            </a:r>
+            <a:endParaRPr lang="en-US" sz="1700" dirty="0">
+              <a:solidFill>
+                <a:srgbClr val="172B4D"/>
+              </a:solidFill>
+              <a:latin typeface="Aptos"/>
+            </a:endParaRPr>
+          </a:p>
+          <a:p>
+            <a:pPr algn="ctr">
+              <a:defRPr sz="1700"/>
+            </a:pPr>
+            <a:endParaRPr lang="en-US" sz="1700" dirty="0">
+              <a:solidFill>
+                <a:srgbClr val="172B4D"/>
+              </a:solidFill>
+              <a:latin typeface="Aptos"/>
+            </a:endParaRPr>
+          </a:p>
+          <a:p>
+            <a:pPr algn="ctr">
+              <a:defRPr sz="1700"/>
+            </a:pPr>
+            <a:r>
+              <a:rPr lang="en-US" sz="1700" dirty="0">
+                <a:solidFill>
+                  <a:srgbClr val="172B4D"/>
+                </a:solidFill>
+                <a:latin typeface="Aptos"/>
+              </a:rPr>
+              <a:t>The word “Sales” </a:t>
+            </a:r>
+            <a:r>
+              <a:rPr lang="en-US" sz="1700" dirty="0">
+                <a:solidFill>
+                  <a:srgbClr val="172B4D"/>
+                </a:solidFill>
+                <a:highlight>
+                  <a:srgbClr val="FFFF00"/>
+                </a:highlight>
+                <a:latin typeface="Aptos"/>
+              </a:rPr>
+              <a:t>now is a point in multidimensional space</a:t>
+            </a:r>
+            <a:r>
+              <a:rPr lang="en-US" sz="1700" dirty="0">
+                <a:solidFill>
+                  <a:srgbClr val="172B4D"/>
+                </a:solidFill>
+                <a:latin typeface="Aptos"/>
+              </a:rPr>
+              <a:t>.</a:t>
+            </a:r>
+            <a:endParaRPr sz="1700" dirty="0">
+              <a:solidFill>
+                <a:srgbClr val="172B4D"/>
+              </a:solidFill>
+              <a:latin typeface="Aptos"/>
+            </a:endParaRPr>
           </a:p>
         </p:txBody>
       </p:sp>
@@ -4252,7 +4571,7 @@
                 </a:solidFill>
                 <a:latin typeface="Aptos"/>
               </a:rPr>
-              <a:t>AI Under the hood | Slide 11</a:t>
+              <a:t>AI Under the hood | Slide 13</a:t>
             </a:r>
           </a:p>
         </p:txBody>
@@ -4731,7 +5050,7 @@
               </a:defRPr>
             </a:pPr>
             <a:r>
-              <a:t>AI Under the hood | Slide 12</a:t>
+              <a:t>AI Under the hood | Slide 14</a:t>
             </a:r>
           </a:p>
         </p:txBody>
@@ -4993,7 +5312,7 @@
               </a:defRPr>
             </a:pPr>
             <a:r>
-              <a:t>AI Under the hood | Slide 13</a:t>
+              <a:t>AI Under the hood | Slide 15</a:t>
             </a:r>
           </a:p>
         </p:txBody>
@@ -5518,7 +5837,7 @@
                 </a:solidFill>
                 <a:latin typeface="Aptos"/>
               </a:rPr>
-              <a:t>AI Under the hood | Slide 14</a:t>
+              <a:t>AI Under the hood | Slide 16</a:t>
             </a:r>
           </a:p>
         </p:txBody>
@@ -5687,6 +6006,15 @@
               <a:defRPr sz="2100"/>
             </a:pPr>
             <a:r>
+              <a:rPr lang="en-US" sz="2100" b="1" dirty="0">
+                <a:solidFill>
+                  <a:srgbClr val="0B5CAD"/>
+                </a:solidFill>
+                <a:latin typeface="Aptos"/>
+              </a:rPr>
+              <a:t>---</a:t>
+            </a:r>
+            <a:r>
               <a:rPr sz="2100" b="1" dirty="0">
                 <a:solidFill>
                   <a:srgbClr val="0B5CAD"/>
@@ -5766,6 +6094,15 @@
               <a:defRPr sz="2100"/>
             </a:pPr>
             <a:r>
+              <a:rPr lang="en-US" sz="2100" b="1" dirty="0">
+                <a:solidFill>
+                  <a:srgbClr val="0B5CAD"/>
+                </a:solidFill>
+                <a:latin typeface="Aptos"/>
+              </a:rPr>
+              <a:t>----</a:t>
+            </a:r>
+            <a:r>
               <a:rPr sz="2100" b="1" dirty="0">
                 <a:solidFill>
                   <a:srgbClr val="0B5CAD"/>
@@ -7572,7 +7909,7 @@
                 </a:solidFill>
                 <a:latin typeface="Aptos"/>
               </a:rPr>
-              <a:t>AI Under the hood | Slide 15</a:t>
+              <a:t>AI Under the hood | Slide 17</a:t>
             </a:r>
           </a:p>
         </p:txBody>
@@ -7653,7 +7990,7 @@
                 </a:solidFill>
                 <a:latin typeface="Aptos"/>
               </a:rPr>
-              <a:t>AI Under the hood | Slide 16</a:t>
+              <a:t>AI Under the hood | Slide 18</a:t>
             </a:r>
           </a:p>
         </p:txBody>
@@ -8099,7 +8436,7 @@
               </a:defRPr>
             </a:pPr>
             <a:r>
-              <a:t>AI Under the hood | Slide 17</a:t>
+              <a:t>AI Under the hood | Slide 19</a:t>
             </a:r>
           </a:p>
         </p:txBody>
@@ -8373,7 +8710,7 @@
               </a:defRPr>
             </a:pPr>
             <a:r>
-              <a:t>AI Under the hood | Slide 18</a:t>
+              <a:t>AI Under the hood | Slide 20</a:t>
             </a:r>
           </a:p>
         </p:txBody>
@@ -8454,7 +8791,7 @@
                 </a:solidFill>
                 <a:latin typeface="Aptos"/>
               </a:rPr>
-              <a:t>AI Under the hood | Slide 3</a:t>
+              <a:t>AI Under the hood | Slide 2</a:t>
             </a:r>
           </a:p>
         </p:txBody>
@@ -8537,6 +8874,592 @@
           <a:lstStyle/>
           <a:p>
             <a:endParaRPr lang="en-US" dirty="0"/>
+          </a:p>
+        </p:txBody>
+      </p:sp>
+    </p:spTree>
+  </p:cSld>
+  <p:clrMapOvr>
+    <a:masterClrMapping/>
+  </p:clrMapOvr>
+</p:sld>
+</file>
+
+<file path=ppt/slides/slide20.xml><?xml version="1.0" encoding="utf-8"?>
+<p:sld xmlns:a="http://schemas.openxmlformats.org/drawingml/2006/main" xmlns:r="http://schemas.openxmlformats.org/officeDocument/2006/relationships" xmlns:p="http://schemas.openxmlformats.org/presentationml/2006/main">
+  <p:cSld>
+    <p:spTree>
+      <p:nvGrpSpPr>
+        <p:cNvPr id="1" name=""/>
+        <p:cNvGrpSpPr/>
+        <p:nvPr/>
+      </p:nvGrpSpPr>
+      <p:grpSpPr>
+        <a:xfrm>
+          <a:off x="0" y="0"/>
+          <a:ext cx="0" cy="0"/>
+          <a:chOff x="0" y="0"/>
+          <a:chExt cx="0" cy="0"/>
+        </a:xfrm>
+      </p:grpSpPr>
+      <p:sp>
+        <p:nvSpPr>
+          <p:cNvPr id="2" name="Title"/>
+          <p:cNvSpPr txBox="1"/>
+          <p:nvPr/>
+        </p:nvSpPr>
+        <p:spPr>
+          <a:xfrm>
+            <a:off x="548640" y="274320"/>
+            <a:ext cx="11125200" cy="548640"/>
+          </a:xfrm>
+          <a:prstGeom prst="rect">
+            <a:avLst/>
+          </a:prstGeom>
+          <a:noFill/>
+          <a:ln/>
+        </p:spPr>
+        <p:txBody>
+          <a:bodyPr lIns="0" tIns="0" rIns="0" bIns="0" rtlCol="0" anchor="t"/>
+          <a:lstStyle/>
+          <a:p>
+            <a:pPr algn="l">
+              <a:defRPr sz="2600"/>
+            </a:pPr>
+            <a:r>
+              <a:rPr sz="2600" b="1" dirty="0">
+                <a:solidFill>
+                  <a:srgbClr val="0B2F5B"/>
+                </a:solidFill>
+                <a:latin typeface="Aptos"/>
+              </a:rPr>
+              <a:t>Embeddings: Learned Geometric Coordinates of Meaning</a:t>
+            </a:r>
+          </a:p>
+        </p:txBody>
+      </p:sp>
+      <p:sp>
+        <p:nvSpPr>
+          <p:cNvPr id="3" name="Subtitle"/>
+          <p:cNvSpPr txBox="1"/>
+          <p:nvPr/>
+        </p:nvSpPr>
+        <p:spPr>
+          <a:xfrm>
+            <a:off x="594360" y="777240"/>
+            <a:ext cx="10820400" cy="365760"/>
+          </a:xfrm>
+          <a:prstGeom prst="rect">
+            <a:avLst/>
+          </a:prstGeom>
+          <a:noFill/>
+          <a:ln/>
+        </p:spPr>
+        <p:txBody>
+          <a:bodyPr lIns="0" tIns="0" rIns="0" bIns="0" rtlCol="0" anchor="t"/>
+          <a:lstStyle/>
+          <a:p>
+            <a:pPr algn="l">
+              <a:defRPr sz="1550"/>
+            </a:pPr>
+            <a:r>
+              <a:rPr sz="1550" dirty="0">
+                <a:solidFill>
+                  <a:srgbClr val="52616B"/>
+                </a:solidFill>
+                <a:latin typeface="Aptos"/>
+              </a:rPr>
+              <a:t>Training turns random vectors into a map where distance carries semantics.</a:t>
+            </a:r>
+          </a:p>
+        </p:txBody>
+      </p:sp>
+      <p:sp>
+        <p:nvSpPr>
+          <p:cNvPr id="4" name="Initially Random"/>
+          <p:cNvSpPr/>
+          <p:nvPr/>
+        </p:nvSpPr>
+        <p:spPr>
+          <a:xfrm>
+            <a:off x="640080" y="1280160"/>
+            <a:ext cx="3291840" cy="1737360"/>
+          </a:xfrm>
+          <a:prstGeom prst="roundRect">
+            <a:avLst/>
+          </a:prstGeom>
+          <a:solidFill>
+            <a:srgbClr val="F5F8FC"/>
+          </a:solidFill>
+          <a:ln>
+            <a:solidFill>
+              <a:srgbClr val="BED2E6"/>
+            </a:solidFill>
+          </a:ln>
+        </p:spPr>
+        <p:txBody>
+          <a:bodyPr lIns="91440" tIns="91440" rIns="91440" bIns="91440" rtlCol="0" anchor="t"/>
+          <a:lstStyle/>
+          <a:p>
+            <a:pPr algn="l">
+              <a:defRPr sz="1700"/>
+            </a:pPr>
+            <a:r>
+              <a:rPr sz="1700" b="1" dirty="0">
+                <a:solidFill>
+                  <a:srgbClr val="0B2F5B"/>
+                </a:solidFill>
+                <a:latin typeface="Aptos"/>
+              </a:rPr>
+              <a:t>Initially</a:t>
+            </a:r>
+          </a:p>
+          <a:p>
+            <a:pPr algn="l">
+              <a:defRPr sz="1250"/>
+            </a:pPr>
+            <a:r>
+              <a:rPr sz="1250" dirty="0">
+                <a:solidFill>
+                  <a:srgbClr val="172B4D"/>
+                </a:solidFill>
+                <a:latin typeface="Consolas"/>
+              </a:rPr>
+              <a:t>MAG     = [random garbage]</a:t>
+            </a:r>
+            <a:br/>
+            <a:r>
+              <a:rPr sz="1250" dirty="0">
+                <a:solidFill>
+                  <a:srgbClr val="172B4D"/>
+                </a:solidFill>
+                <a:latin typeface="Consolas"/>
+              </a:rPr>
+              <a:t>sales   = [random garbage]</a:t>
+            </a:r>
+            <a:br/>
+            <a:r>
+              <a:rPr sz="1250" dirty="0">
+                <a:solidFill>
+                  <a:srgbClr val="172B4D"/>
+                </a:solidFill>
+                <a:latin typeface="Consolas"/>
+              </a:rPr>
+              <a:t>Chicago = [random garbage]</a:t>
+            </a:r>
+          </a:p>
+        </p:txBody>
+      </p:sp>
+      <p:sp>
+        <p:nvSpPr>
+          <p:cNvPr id="5" name="Training Contexts"/>
+          <p:cNvSpPr/>
+          <p:nvPr/>
+        </p:nvSpPr>
+        <p:spPr>
+          <a:xfrm>
+            <a:off x="4389120" y="1280160"/>
+            <a:ext cx="3200400" cy="1737360"/>
+          </a:xfrm>
+          <a:prstGeom prst="roundRect">
+            <a:avLst/>
+          </a:prstGeom>
+          <a:solidFill>
+            <a:srgbClr val="F5F8FC"/>
+          </a:solidFill>
+          <a:ln>
+            <a:solidFill>
+              <a:srgbClr val="BED2E6"/>
+            </a:solidFill>
+          </a:ln>
+        </p:spPr>
+        <p:txBody>
+          <a:bodyPr lIns="91440" tIns="91440" rIns="91440" bIns="91440" rtlCol="0" anchor="t"/>
+          <a:lstStyle/>
+          <a:p>
+            <a:pPr algn="l">
+              <a:defRPr sz="1700"/>
+            </a:pPr>
+            <a:r>
+              <a:rPr sz="1700" b="1" dirty="0">
+                <a:solidFill>
+                  <a:srgbClr val="0B2F5B"/>
+                </a:solidFill>
+                <a:latin typeface="Aptos"/>
+              </a:rPr>
+              <a:t>During training</a:t>
+            </a:r>
+          </a:p>
+          <a:p>
+            <a:pPr algn="l">
+              <a:defRPr sz="1350"/>
+            </a:pPr>
+            <a:r>
+              <a:rPr sz="1350" dirty="0">
+                <a:solidFill>
+                  <a:srgbClr val="172B4D"/>
+                </a:solidFill>
+                <a:latin typeface="Consolas"/>
+              </a:rPr>
+              <a:t>sales up</a:t>
+            </a:r>
+            <a:br/>
+            <a:r>
+              <a:rPr sz="1350" dirty="0">
+                <a:solidFill>
+                  <a:srgbClr val="172B4D"/>
+                </a:solidFill>
+                <a:latin typeface="Consolas"/>
+              </a:rPr>
+              <a:t>sales increased</a:t>
+            </a:r>
+            <a:br/>
+            <a:r>
+              <a:rPr sz="1350" dirty="0">
+                <a:solidFill>
+                  <a:srgbClr val="172B4D"/>
+                </a:solidFill>
+                <a:latin typeface="Consolas"/>
+              </a:rPr>
+              <a:t>revenue growth</a:t>
+            </a:r>
+            <a:br/>
+            <a:r>
+              <a:rPr sz="1350" dirty="0">
+                <a:solidFill>
+                  <a:srgbClr val="172B4D"/>
+                </a:solidFill>
+                <a:latin typeface="Consolas"/>
+              </a:rPr>
+              <a:t>Chicago region</a:t>
+            </a:r>
+          </a:p>
+        </p:txBody>
+      </p:sp>
+      <p:sp>
+        <p:nvSpPr>
+          <p:cNvPr id="6" name="Geometry Meaning"/>
+          <p:cNvSpPr/>
+          <p:nvPr/>
+        </p:nvSpPr>
+        <p:spPr>
+          <a:xfrm>
+            <a:off x="8138160" y="1280160"/>
+            <a:ext cx="3200400" cy="1737360"/>
+          </a:xfrm>
+          <a:prstGeom prst="roundRect">
+            <a:avLst/>
+          </a:prstGeom>
+          <a:solidFill>
+            <a:srgbClr val="EAF3FF"/>
+          </a:solidFill>
+          <a:ln>
+            <a:solidFill>
+              <a:srgbClr val="0B5CAD"/>
+            </a:solidFill>
+          </a:ln>
+        </p:spPr>
+        <p:txBody>
+          <a:bodyPr lIns="91440" tIns="91440" rIns="91440" bIns="91440" rtlCol="0" anchor="t"/>
+          <a:lstStyle/>
+          <a:p>
+            <a:pPr algn="l">
+              <a:defRPr sz="1700"/>
+            </a:pPr>
+            <a:r>
+              <a:rPr sz="1700" b="1" dirty="0">
+                <a:solidFill>
+                  <a:srgbClr val="0B2F5B"/>
+                </a:solidFill>
+                <a:latin typeface="Aptos"/>
+              </a:rPr>
+              <a:t>Backprop moves vectors</a:t>
+            </a:r>
+          </a:p>
+          <a:p>
+            <a:pPr algn="l">
+              <a:defRPr sz="1375"/>
+            </a:pPr>
+            <a:r>
+              <a:rPr sz="1375" dirty="0">
+                <a:solidFill>
+                  <a:srgbClr val="172B4D"/>
+                </a:solidFill>
+                <a:latin typeface="Aptos"/>
+              </a:rPr>
+              <a:t>similar words move closer</a:t>
+            </a:r>
+            <a:br/>
+            <a:r>
+              <a:rPr sz="1375" dirty="0">
+                <a:solidFill>
+                  <a:srgbClr val="172B4D"/>
+                </a:solidFill>
+                <a:latin typeface="Aptos"/>
+              </a:rPr>
+              <a:t>unrelated words move apart</a:t>
+            </a:r>
+            <a:br/>
+            <a:r>
+              <a:rPr sz="1375" dirty="0">
+                <a:solidFill>
+                  <a:srgbClr val="172B4D"/>
+                </a:solidFill>
+                <a:latin typeface="Aptos"/>
+              </a:rPr>
+              <a:t>geometry stores meaning</a:t>
+            </a:r>
+          </a:p>
+        </p:txBody>
+      </p:sp>
+      <p:sp>
+        <p:nvSpPr>
+          <p:cNvPr id="7" name="Visual Intuition"/>
+          <p:cNvSpPr/>
+          <p:nvPr/>
+        </p:nvSpPr>
+        <p:spPr>
+          <a:xfrm>
+            <a:off x="640080" y="3370320"/>
+            <a:ext cx="5029200" cy="2011680"/>
+          </a:xfrm>
+          <a:prstGeom prst="roundRect">
+            <a:avLst/>
+          </a:prstGeom>
+          <a:solidFill>
+            <a:srgbClr val="FFFFFF"/>
+          </a:solidFill>
+          <a:ln>
+            <a:solidFill>
+              <a:srgbClr val="BED2E6"/>
+            </a:solidFill>
+          </a:ln>
+        </p:spPr>
+        <p:txBody>
+          <a:bodyPr lIns="91440" tIns="91440" rIns="91440" bIns="91440" rtlCol="0" anchor="t"/>
+          <a:lstStyle/>
+          <a:p>
+            <a:pPr algn="l">
+              <a:defRPr sz="1650"/>
+            </a:pPr>
+            <a:r>
+              <a:rPr sz="1650" b="1" dirty="0">
+                <a:solidFill>
+                  <a:srgbClr val="0B2F5B"/>
+                </a:solidFill>
+                <a:latin typeface="Aptos"/>
+              </a:rPr>
+              <a:t>Visual intuition: distances encode relationships</a:t>
+            </a:r>
+          </a:p>
+          <a:p>
+            <a:pPr algn="l">
+              <a:defRPr sz="1250"/>
+            </a:pPr>
+            <a:r>
+              <a:rPr sz="1250" dirty="0">
+                <a:solidFill>
+                  <a:srgbClr val="172B4D"/>
+                </a:solidFill>
+                <a:latin typeface="Consolas"/>
+              </a:rPr>
+              <a:t>king   (2, 9, 4)    queen  (2, 9, 5)</a:t>
+            </a:r>
+            <a:br/>
+            <a:r>
+              <a:rPr sz="1250" dirty="0">
+                <a:solidFill>
+                  <a:srgbClr val="172B4D"/>
+                </a:solidFill>
+                <a:latin typeface="Consolas"/>
+              </a:rPr>
+              <a:t>man    (1, 4, 3)    woman  (1, 4, 4)</a:t>
+            </a:r>
+          </a:p>
+          <a:p>
+            <a:pPr algn="l">
+              <a:defRPr sz="1550"/>
+            </a:pPr>
+            <a:r>
+              <a:rPr sz="1550" b="1" dirty="0">
+                <a:solidFill>
+                  <a:srgbClr val="0B5CAD"/>
+                </a:solidFill>
+                <a:latin typeface="Consolas"/>
+              </a:rPr>
+              <a:t>king - man + woman ~= queen</a:t>
+            </a:r>
+          </a:p>
+        </p:txBody>
+      </p:sp>
+      <p:sp>
+        <p:nvSpPr>
+          <p:cNvPr id="8" name="Sentence Embeddings"/>
+          <p:cNvSpPr/>
+          <p:nvPr/>
+        </p:nvSpPr>
+        <p:spPr>
+          <a:xfrm>
+            <a:off x="5989320" y="3370320"/>
+            <a:ext cx="5394960" cy="2011680"/>
+          </a:xfrm>
+          <a:prstGeom prst="roundRect">
+            <a:avLst/>
+          </a:prstGeom>
+          <a:solidFill>
+            <a:srgbClr val="FFFFFF"/>
+          </a:solidFill>
+          <a:ln>
+            <a:solidFill>
+              <a:srgbClr val="BED2E6"/>
+            </a:solidFill>
+          </a:ln>
+        </p:spPr>
+        <p:txBody>
+          <a:bodyPr lIns="91440" tIns="91440" rIns="91440" bIns="91440" rtlCol="0" anchor="t"/>
+          <a:lstStyle/>
+          <a:p>
+            <a:pPr algn="l">
+              <a:defRPr sz="1650"/>
+            </a:pPr>
+            <a:r>
+              <a:rPr sz="1650" b="1" dirty="0">
+                <a:solidFill>
+                  <a:srgbClr val="0B2F5B"/>
+                </a:solidFill>
+                <a:latin typeface="Aptos"/>
+              </a:rPr>
+              <a:t>Sentence embeddings combine token vectors</a:t>
+            </a:r>
+          </a:p>
+          <a:p>
+            <a:pPr algn="l">
+              <a:defRPr sz="1250"/>
+            </a:pPr>
+            <a:r>
+              <a:rPr sz="1250" dirty="0">
+                <a:solidFill>
+                  <a:srgbClr val="172B4D"/>
+                </a:solidFill>
+                <a:latin typeface="Aptos"/>
+              </a:rPr>
+              <a:t>averaging | attention | transformers | pooling</a:t>
+            </a:r>
+          </a:p>
+          <a:p>
+            <a:pPr algn="l">
+              <a:defRPr sz="1200"/>
+            </a:pPr>
+            <a:r>
+              <a:rPr sz="1200" dirty="0">
+                <a:solidFill>
+                  <a:srgbClr val="172B4D"/>
+                </a:solidFill>
+                <a:latin typeface="Consolas"/>
+              </a:rPr>
+              <a:t>"MAG sales are up in Chicago"</a:t>
+            </a:r>
+            <a:br/>
+            <a:r>
+              <a:rPr sz="1200" dirty="0">
+                <a:solidFill>
+                  <a:srgbClr val="172B4D"/>
+                </a:solidFill>
+                <a:latin typeface="Consolas"/>
+              </a:rPr>
+              <a:t>-&gt; [0.192, -0.551, 0.882, ... 1536 dims ...]</a:t>
+            </a:r>
+          </a:p>
+          <a:p>
+            <a:pPr algn="l">
+              <a:defRPr sz="1225"/>
+            </a:pPr>
+            <a:r>
+              <a:rPr sz="1225" dirty="0">
+                <a:solidFill>
+                  <a:srgbClr val="52616B"/>
+                </a:solidFill>
+                <a:latin typeface="Aptos"/>
+              </a:rPr>
+              <a:t>captures business context, trend, location, and organization semantics</a:t>
+            </a:r>
+          </a:p>
+        </p:txBody>
+      </p:sp>
+      <p:sp>
+        <p:nvSpPr>
+          <p:cNvPr id="9" name="Why This Works"/>
+          <p:cNvSpPr/>
+          <p:nvPr/>
+        </p:nvSpPr>
+        <p:spPr>
+          <a:xfrm>
+            <a:off x="914400" y="5791200"/>
+            <a:ext cx="10393680" cy="548640"/>
+          </a:xfrm>
+          <a:prstGeom prst="roundRect">
+            <a:avLst/>
+          </a:prstGeom>
+          <a:solidFill>
+            <a:srgbClr val="F5F8FC"/>
+          </a:solidFill>
+          <a:ln>
+            <a:solidFill>
+              <a:srgbClr val="BED2E6"/>
+            </a:solidFill>
+          </a:ln>
+        </p:spPr>
+        <p:txBody>
+          <a:bodyPr lIns="91440" tIns="91440" rIns="91440" bIns="91440" rtlCol="0" anchor="ctr"/>
+          <a:lstStyle/>
+          <a:p>
+            <a:pPr algn="l">
+              <a:defRPr sz="1450"/>
+            </a:pPr>
+            <a:r>
+              <a:rPr sz="1450" dirty="0">
+                <a:solidFill>
+                  <a:srgbClr val="172B4D"/>
+                </a:solidFill>
+                <a:latin typeface="Aptos"/>
+              </a:rPr>
+              <a:t>Why it works: language has statistical structure. Context patterns -&gt; geometric relationships. Foundation for Word2Vec, GloVe, BERT, GPT, and LLMs.</a:t>
+            </a:r>
+          </a:p>
+        </p:txBody>
+      </p:sp>
+      <p:sp>
+        <p:nvSpPr>
+          <p:cNvPr id="10" name="Footer"/>
+          <p:cNvSpPr txBox="1"/>
+          <p:nvPr/>
+        </p:nvSpPr>
+        <p:spPr>
+          <a:xfrm>
+            <a:off x="320040" y="6473952"/>
+            <a:ext cx="11521440" cy="228600"/>
+          </a:xfrm>
+          <a:prstGeom prst="rect">
+            <a:avLst/>
+          </a:prstGeom>
+          <a:noFill/>
+        </p:spPr>
+        <p:txBody>
+          <a:bodyPr wrap="none">
+            <a:spAutoFit/>
+          </a:bodyPr>
+          <a:lstStyle/>
+          <a:p>
+            <a:pPr>
+              <a:defRPr sz="900">
+                <a:solidFill>
+                  <a:srgbClr val="52616B"/>
+                </a:solidFill>
+              </a:defRPr>
+            </a:pPr>
+            <a:r>
+              <a:t>AI Under the hood | Slide 11</a:t>
+            </a:r>
           </a:p>
         </p:txBody>
       </p:sp>
@@ -8957,7 +9880,7 @@
             </a:pPr>
             <a:r>
               <a:rPr dirty="0"/>
-              <a:t>AI Under the hood | Slide 2</a:t>
+              <a:t>AI Under the hood | Slide 4</a:t>
             </a:r>
           </a:p>
         </p:txBody>
@@ -9283,7 +10206,7 @@
               </a:defRPr>
             </a:pPr>
             <a:r>
-              <a:t>AI Under the hood | Slide 4</a:t>
+              <a:t>AI Under the hood | Slide 5</a:t>
             </a:r>
           </a:p>
         </p:txBody>
@@ -9609,7 +10532,7 @@
               </a:defRPr>
             </a:pPr>
             <a:r>
-              <a:t>AI Under the hood | Slide 5</a:t>
+              <a:t>AI Under the hood | Slide 6</a:t>
             </a:r>
           </a:p>
         </p:txBody>
@@ -9967,7 +10890,7 @@
               </a:defRPr>
             </a:pPr>
             <a:r>
-              <a:t>AI Under the hood | Slide 6</a:t>
+              <a:t>AI Under the hood | Slide 7</a:t>
             </a:r>
           </a:p>
         </p:txBody>
@@ -10338,7 +11261,7 @@
                 </a:solidFill>
                 <a:latin typeface="Aptos"/>
               </a:rPr>
-              <a:t>AI Under the hood | Slide 7</a:t>
+              <a:t>AI Under the hood | Slide 8</a:t>
             </a:r>
           </a:p>
         </p:txBody>
@@ -11383,7 +12306,11 @@
             </a:br>
             <a:r>
               <a:rPr dirty="0"/>
-              <a:t>        ↓</a:t>
+              <a:t>        </a:t>
+            </a:r>
+            <a:r>
+              <a:rPr lang="en-US" dirty="0"/>
+              <a:t>↓</a:t>
             </a:r>
             <a:br>
               <a:rPr dirty="0"/>
@@ -11496,7 +12423,7 @@
               </a:defRPr>
             </a:pPr>
             <a:r>
-              <a:t>AI Under the hood | Slide 8</a:t>
+              <a:t>AI Under the hood | Slide 9</a:t>
             </a:r>
           </a:p>
         </p:txBody>

</xml_diff>

<commit_message>
Capturing the latest updates of the slides.
</commit_message>
<xml_diff>
--- a/pptx/Session_01_Tokens_v1.0.pptx
+++ b/pptx/Session_01_Tokens_v1.0.pptx
@@ -3589,9 +3589,21 @@
                 <a:solidFill>
                   <a:srgbClr val="172B4D"/>
                 </a:solidFill>
-                <a:latin typeface="Aptos"/>
-              </a:rPr>
-              <a:t>During inference, we do not calculate these numbers from spelling. We look up the learned row.</a:t>
+                <a:highlight>
+                  <a:srgbClr val="FFFF00"/>
+                </a:highlight>
+                <a:latin typeface="Aptos"/>
+              </a:rPr>
+              <a:t>During inference, we do not calculate these numbers from spelling. </a:t>
+            </a:r>
+            <a:r>
+              <a:rPr sz="1700" dirty="0">
+                <a:solidFill>
+                  <a:srgbClr val="172B4D"/>
+                </a:solidFill>
+                <a:latin typeface="Aptos"/>
+              </a:rPr>
+              <a:t>We look up the learned row.</a:t>
             </a:r>
           </a:p>
         </p:txBody>
@@ -3861,7 +3873,28 @@
                 </a:solidFill>
                 <a:latin typeface="Aptos"/>
               </a:rPr>
-              <a:t>Training turns random vectors into a map where distance carries semantics.</a:t>
+              <a:t>Training turns random vectors into a map where </a:t>
+            </a:r>
+            <a:r>
+              <a:rPr sz="1550" dirty="0">
+                <a:solidFill>
+                  <a:srgbClr val="52616B"/>
+                </a:solidFill>
+                <a:highlight>
+                  <a:srgbClr val="FFFF00"/>
+                </a:highlight>
+                <a:latin typeface="Aptos"/>
+              </a:rPr>
+              <a:t>distance carries semantics</a:t>
+            </a:r>
+            <a:r>
+              <a:rPr sz="1550" dirty="0">
+                <a:solidFill>
+                  <a:srgbClr val="52616B"/>
+                </a:solidFill>
+                <a:latin typeface="Aptos"/>
+              </a:rPr>
+              <a:t>.</a:t>
             </a:r>
           </a:p>
         </p:txBody>
@@ -4305,17 +4338,43 @@
           <a:bodyPr lIns="91440" tIns="91440" rIns="91440" bIns="91440" rtlCol="0" anchor="ctr"/>
           <a:lstStyle/>
           <a:p>
-            <a:pPr algn="l">
+            <a:pPr algn="ctr">
               <a:defRPr sz="1450"/>
             </a:pPr>
             <a:r>
+              <a:rPr sz="1450" b="1" dirty="0">
+                <a:solidFill>
+                  <a:srgbClr val="172B4D"/>
+                </a:solidFill>
+                <a:highlight>
+                  <a:srgbClr val="FFFF00"/>
+                </a:highlight>
+                <a:latin typeface="Aptos"/>
+              </a:rPr>
+              <a:t>Why it works: language has statistical structure. Context patterns -&gt; geometric relationships. </a:t>
+            </a:r>
+            <a:endParaRPr lang="en-US" sz="1450" b="1" dirty="0">
+              <a:solidFill>
+                <a:srgbClr val="172B4D"/>
+              </a:solidFill>
+              <a:highlight>
+                <a:srgbClr val="FFFF00"/>
+              </a:highlight>
+              <a:latin typeface="Aptos"/>
+            </a:endParaRPr>
+          </a:p>
+          <a:p>
+            <a:pPr algn="ctr">
+              <a:defRPr sz="1450"/>
+            </a:pPr>
+            <a:r>
               <a:rPr sz="1450" dirty="0">
                 <a:solidFill>
                   <a:srgbClr val="172B4D"/>
                 </a:solidFill>
                 <a:latin typeface="Aptos"/>
               </a:rPr>
-              <a:t>Why it works: language has statistical structure. Context patterns -&gt; geometric relationships. Foundation for Word2Vec, GloVe, BERT, GPT, and LLMs.</a:t>
+              <a:t>Foundation for Word2Vec, GloVe, BERT, GPT, and LLMs.</a:t>
             </a:r>
           </a:p>
         </p:txBody>
@@ -5094,21 +5153,24 @@
                 <a:solidFill>
                   <a:srgbClr val="172B4D"/>
                 </a:solidFill>
-                <a:latin typeface="Aptos"/>
-              </a:rPr>
-              <a:t>The word “Sales” </a:t>
-            </a:r>
-            <a:r>
-              <a:rPr lang="en-US" sz="1700" dirty="0">
-                <a:solidFill>
-                  <a:srgbClr val="172B4D"/>
-                </a:solidFill>
                 <a:highlight>
                   <a:srgbClr val="FFFF00"/>
                 </a:highlight>
                 <a:latin typeface="Aptos"/>
               </a:rPr>
-              <a:t>now is a point in multidimensional space</a:t>
+              <a:t>The word “Sales” now is a </a:t>
+            </a:r>
+            <a:r>
+              <a:rPr lang="en-US" sz="1700" u="sng" dirty="0">
+                <a:solidFill>
+                  <a:srgbClr val="172B4D"/>
+                </a:solidFill>
+                <a:highlight>
+                  <a:srgbClr val="FFFF00"/>
+                </a:highlight>
+                <a:latin typeface="Aptos"/>
+              </a:rPr>
+              <a:t>point in multidimensional space</a:t>
             </a:r>
             <a:r>
               <a:rPr lang="en-US" sz="1700" dirty="0">
@@ -5594,15 +5656,27 @@
               </a:defRPr>
             </a:pPr>
             <a:r>
-              <a:rPr dirty="0"/>
+              <a:rPr dirty="0">
+                <a:highlight>
+                  <a:srgbClr val="FFFF00"/>
+                </a:highlight>
+              </a:rPr>
               <a:t>The integer </a:t>
             </a:r>
             <a:r>
-              <a:rPr lang="en-US" dirty="0"/>
+              <a:rPr lang="en-US" dirty="0">
+                <a:highlight>
+                  <a:srgbClr val="FFFF00"/>
+                </a:highlight>
+              </a:rPr>
               <a:t>3</a:t>
             </a:r>
             <a:r>
-              <a:rPr dirty="0"/>
+              <a:rPr dirty="0">
+                <a:highlight>
+                  <a:srgbClr val="FFFF00"/>
+                </a:highlight>
+              </a:rPr>
               <a:t> does not contain the meaning of “sales.” It points to a learned row in the embedding matrix.</a:t>
             </a:r>
           </a:p>
@@ -7764,7 +7838,7 @@
         </p:nvSpPr>
         <p:spPr>
           <a:xfrm>
-            <a:off x="1715063" y="5995403"/>
+            <a:off x="2685447" y="6151138"/>
             <a:ext cx="8861337" cy="615553"/>
           </a:xfrm>
           <a:prstGeom prst="rect">
@@ -7791,6 +7865,9 @@
                 <a:solidFill>
                   <a:srgbClr val="0B2F5B"/>
                 </a:solidFill>
+                <a:highlight>
+                  <a:srgbClr val="FFFF00"/>
+                </a:highlight>
                 <a:latin typeface="Aptos"/>
               </a:rPr>
               <a:t>Embeddings convert language into geometry. </a:t>
@@ -7799,6 +7876,9 @@
               <a:solidFill>
                 <a:srgbClr val="0B2F5B"/>
               </a:solidFill>
+              <a:highlight>
+                <a:srgbClr val="FFFF00"/>
+              </a:highlight>
               <a:latin typeface="Aptos"/>
             </a:endParaRPr>
           </a:p>
@@ -7816,6 +7896,9 @@
                 <a:solidFill>
                   <a:srgbClr val="0B2F5B"/>
                 </a:solidFill>
+                <a:highlight>
+                  <a:srgbClr val="FFFF00"/>
+                </a:highlight>
                 <a:latin typeface="Aptos"/>
               </a:rPr>
               <a:t>The Transformer manipulates that geometry to infer meaning and predict the next token.</a:t>
@@ -15329,7 +15412,7 @@
             </a:r>
           </a:p>
           <a:p>
-            <a:pPr>
+            <a:pPr algn="ctr">
               <a:spcAft>
                 <a:spcPts val="200"/>
               </a:spcAft>
@@ -15340,7 +15423,11 @@
               </a:defRPr>
             </a:pPr>
             <a:r>
-              <a:rPr dirty="0"/>
+              <a:rPr dirty="0">
+                <a:highlight>
+                  <a:srgbClr val="FFFF00"/>
+                </a:highlight>
+              </a:rPr>
               <a:t>The tokenizer does not define meaning. It maps known text pieces to integer IDs.</a:t>
             </a:r>
           </a:p>

</xml_diff>

<commit_message>
Added 2 NN demos one jupyter notebook and one html demo, and updated the pptx and index.md to include the new demos.
</commit_message>
<xml_diff>
--- a/pptx/Session_01_Tokens_v1.0.pptx
+++ b/pptx/Session_01_Tokens_v1.0.pptx
@@ -323,7 +323,7 @@
           <a:p>
             <a:fld id="{5BCAD085-E8A6-8845-BD4E-CB4CCA059FC4}" type="datetimeFigureOut">
               <a:rPr lang="en-US" smtClean="0"/>
-              <a:t>5/30/2026</a:t>
+              <a:t>6/1/2026</a:t>
             </a:fld>
             <a:endParaRPr lang="en-US"/>
           </a:p>
@@ -491,7 +491,7 @@
           <a:p>
             <a:fld id="{5BCAD085-E8A6-8845-BD4E-CB4CCA059FC4}" type="datetimeFigureOut">
               <a:rPr lang="en-US" smtClean="0"/>
-              <a:t>5/30/2026</a:t>
+              <a:t>6/1/2026</a:t>
             </a:fld>
             <a:endParaRPr lang="en-US"/>
           </a:p>
@@ -669,7 +669,7 @@
           <a:p>
             <a:fld id="{5BCAD085-E8A6-8845-BD4E-CB4CCA059FC4}" type="datetimeFigureOut">
               <a:rPr lang="en-US" smtClean="0"/>
-              <a:t>5/30/2026</a:t>
+              <a:t>6/1/2026</a:t>
             </a:fld>
             <a:endParaRPr lang="en-US"/>
           </a:p>
@@ -837,7 +837,7 @@
           <a:p>
             <a:fld id="{5BCAD085-E8A6-8845-BD4E-CB4CCA059FC4}" type="datetimeFigureOut">
               <a:rPr lang="en-US" smtClean="0"/>
-              <a:t>5/30/2026</a:t>
+              <a:t>6/1/2026</a:t>
             </a:fld>
             <a:endParaRPr lang="en-US"/>
           </a:p>
@@ -1082,7 +1082,7 @@
           <a:p>
             <a:fld id="{5BCAD085-E8A6-8845-BD4E-CB4CCA059FC4}" type="datetimeFigureOut">
               <a:rPr lang="en-US" smtClean="0"/>
-              <a:t>5/30/2026</a:t>
+              <a:t>6/1/2026</a:t>
             </a:fld>
             <a:endParaRPr lang="en-US"/>
           </a:p>
@@ -1367,7 +1367,7 @@
           <a:p>
             <a:fld id="{5BCAD085-E8A6-8845-BD4E-CB4CCA059FC4}" type="datetimeFigureOut">
               <a:rPr lang="en-US" smtClean="0"/>
-              <a:t>5/30/2026</a:t>
+              <a:t>6/1/2026</a:t>
             </a:fld>
             <a:endParaRPr lang="en-US"/>
           </a:p>
@@ -1786,7 +1786,7 @@
           <a:p>
             <a:fld id="{5BCAD085-E8A6-8845-BD4E-CB4CCA059FC4}" type="datetimeFigureOut">
               <a:rPr lang="en-US" smtClean="0"/>
-              <a:t>5/30/2026</a:t>
+              <a:t>6/1/2026</a:t>
             </a:fld>
             <a:endParaRPr lang="en-US"/>
           </a:p>
@@ -1903,7 +1903,7 @@
           <a:p>
             <a:fld id="{5BCAD085-E8A6-8845-BD4E-CB4CCA059FC4}" type="datetimeFigureOut">
               <a:rPr lang="en-US" smtClean="0"/>
-              <a:t>5/30/2026</a:t>
+              <a:t>6/1/2026</a:t>
             </a:fld>
             <a:endParaRPr lang="en-US"/>
           </a:p>
@@ -1998,7 +1998,7 @@
           <a:p>
             <a:fld id="{5BCAD085-E8A6-8845-BD4E-CB4CCA059FC4}" type="datetimeFigureOut">
               <a:rPr lang="en-US" smtClean="0"/>
-              <a:t>5/30/2026</a:t>
+              <a:t>6/1/2026</a:t>
             </a:fld>
             <a:endParaRPr lang="en-US"/>
           </a:p>
@@ -2273,7 +2273,7 @@
           <a:p>
             <a:fld id="{5BCAD085-E8A6-8845-BD4E-CB4CCA059FC4}" type="datetimeFigureOut">
               <a:rPr lang="en-US" smtClean="0"/>
-              <a:t>5/30/2026</a:t>
+              <a:t>6/1/2026</a:t>
             </a:fld>
             <a:endParaRPr lang="en-US"/>
           </a:p>
@@ -2525,7 +2525,7 @@
           <a:p>
             <a:fld id="{5BCAD085-E8A6-8845-BD4E-CB4CCA059FC4}" type="datetimeFigureOut">
               <a:rPr lang="en-US" smtClean="0"/>
-              <a:t>5/30/2026</a:t>
+              <a:t>6/1/2026</a:t>
             </a:fld>
             <a:endParaRPr lang="en-US"/>
           </a:p>
@@ -2736,7 +2736,7 @@
           <a:p>
             <a:fld id="{5BCAD085-E8A6-8845-BD4E-CB4CCA059FC4}" type="datetimeFigureOut">
               <a:rPr lang="en-US" smtClean="0"/>
-              <a:t>5/30/2026</a:t>
+              <a:t>6/1/2026</a:t>
             </a:fld>
             <a:endParaRPr lang="en-US"/>
           </a:p>
@@ -3222,55 +3222,34 @@
         </p:nvSpPr>
         <p:spPr>
           <a:xfrm>
-            <a:off x="3068801" y="5564188"/>
-            <a:ext cx="5486400" cy="1072002"/>
+            <a:off x="3068800" y="5367338"/>
+            <a:ext cx="5739639" cy="1268852"/>
           </a:xfrm>
         </p:spPr>
         <p:txBody>
           <a:bodyPr>
-            <a:normAutofit lnSpcReduction="10000"/>
+            <a:normAutofit fontScale="77500" lnSpcReduction="20000"/>
           </a:bodyPr>
           <a:lstStyle/>
           <a:p>
             <a:r>
-              <a:rPr lang="en-US" dirty="0"/>
+              <a:rPr lang="en-US" b="1" dirty="0"/>
               <a:t>AI Under the Hood</a:t>
             </a:r>
           </a:p>
           <a:p>
-            <a:r>
-              <a:rPr lang="en-US" dirty="0"/>
-              <a:t>Text </a:t>
-            </a:r>
-            <a:r>
-              <a:rPr lang="en-US" dirty="0">
-                <a:sym typeface="Wingdings" panose="05000000000000000000" pitchFamily="2" charset="2"/>
-              </a:rPr>
-              <a:t></a:t>
-            </a:r>
-            <a:r>
-              <a:rPr lang="en-US" dirty="0"/>
-              <a:t> Tokens </a:t>
-            </a:r>
-            <a:r>
-              <a:rPr lang="en-US" dirty="0">
-                <a:sym typeface="Wingdings" panose="05000000000000000000" pitchFamily="2" charset="2"/>
-              </a:rPr>
-              <a:t></a:t>
-            </a:r>
-            <a:r>
-              <a:rPr lang="en-US" dirty="0"/>
-              <a:t> Vectors </a:t>
-            </a:r>
-            <a:r>
-              <a:rPr lang="en-US" dirty="0">
-                <a:sym typeface="Wingdings" panose="05000000000000000000" pitchFamily="2" charset="2"/>
-              </a:rPr>
-              <a:t></a:t>
-            </a:r>
-            <a:r>
-              <a:rPr lang="en-US" dirty="0"/>
-              <a:t> Model Input</a:t>
+            <a:endParaRPr lang="en-US" b="1" dirty="0"/>
+          </a:p>
+          <a:p>
+            <a:r>
+              <a:rPr lang="en-US" b="1" dirty="0"/>
+              <a:t>Following a Business Question Through Tokens, Embeddings, Neural Networks, and Inference</a:t>
+            </a:r>
+          </a:p>
+          <a:p>
+            <a:r>
+              <a:rPr lang="en-US" b="1" dirty="0"/>
+              <a:t>What Really Happens When You Ask AI a Question?</a:t>
             </a:r>
           </a:p>
           <a:p>
@@ -11425,7 +11404,7 @@
         <p:spPr>
           <a:xfrm>
             <a:off x="1158240" y="5212080"/>
-            <a:ext cx="5943600" cy="365760"/>
+            <a:ext cx="5943600" cy="621792"/>
           </a:xfrm>
           <a:prstGeom prst="roundRect">
             <a:avLst/>
@@ -11467,7 +11446,7 @@
         <p:spPr>
           <a:xfrm>
             <a:off x="7437120" y="5212080"/>
-            <a:ext cx="3657600" cy="548640"/>
+            <a:ext cx="3657600" cy="621792"/>
           </a:xfrm>
           <a:prstGeom prst="roundRect">
             <a:avLst/>

</xml_diff>

<commit_message>
Modified the Diavgiea notes, and the pptx, and added a bunch of new files for the demos. Also added a new email server agent demo, and updated the requirements.txt to include the new dependencies for the agent demo. Updated the index.md and mkdocs.yml to include the new files in the documentation.
</commit_message>
<xml_diff>
--- a/pptx/Session_01_Tokens_v1.0.pptx
+++ b/pptx/Session_01_Tokens_v1.0.pptx
@@ -14,17 +14,16 @@
     <p:sldId id="259" r:id="rId8"/>
     <p:sldId id="267" r:id="rId9"/>
     <p:sldId id="260" r:id="rId10"/>
-    <p:sldId id="268" r:id="rId11"/>
-    <p:sldId id="275" r:id="rId12"/>
-    <p:sldId id="261" r:id="rId13"/>
-    <p:sldId id="269" r:id="rId14"/>
-    <p:sldId id="262" r:id="rId15"/>
+    <p:sldId id="269" r:id="rId11"/>
+    <p:sldId id="262" r:id="rId12"/>
+    <p:sldId id="268" r:id="rId13"/>
+    <p:sldId id="275" r:id="rId14"/>
+    <p:sldId id="261" r:id="rId15"/>
     <p:sldId id="276" r:id="rId16"/>
     <p:sldId id="277" r:id="rId17"/>
     <p:sldId id="270" r:id="rId18"/>
     <p:sldId id="271" r:id="rId19"/>
-    <p:sldId id="272" r:id="rId20"/>
-    <p:sldId id="265" r:id="rId21"/>
+    <p:sldId id="278" r:id="rId20"/>
   </p:sldIdLst>
   <p:sldSz cx="12192000" cy="6858000"/>
   <p:notesSz cx="6858000" cy="9144000"/>
@@ -321,7 +320,7 @@
           <a:p>
             <a:fld id="{5BCAD085-E8A6-8845-BD4E-CB4CCA059FC4}" type="datetimeFigureOut">
               <a:rPr lang="en-US" smtClean="0"/>
-              <a:t>6/2/2026</a:t>
+              <a:t>6/4/2026</a:t>
             </a:fld>
             <a:endParaRPr lang="en-US"/>
           </a:p>
@@ -489,7 +488,7 @@
           <a:p>
             <a:fld id="{5BCAD085-E8A6-8845-BD4E-CB4CCA059FC4}" type="datetimeFigureOut">
               <a:rPr lang="en-US" smtClean="0"/>
-              <a:t>6/2/2026</a:t>
+              <a:t>6/4/2026</a:t>
             </a:fld>
             <a:endParaRPr lang="en-US"/>
           </a:p>
@@ -667,7 +666,7 @@
           <a:p>
             <a:fld id="{5BCAD085-E8A6-8845-BD4E-CB4CCA059FC4}" type="datetimeFigureOut">
               <a:rPr lang="en-US" smtClean="0"/>
-              <a:t>6/2/2026</a:t>
+              <a:t>6/4/2026</a:t>
             </a:fld>
             <a:endParaRPr lang="en-US"/>
           </a:p>
@@ -835,7 +834,7 @@
           <a:p>
             <a:fld id="{5BCAD085-E8A6-8845-BD4E-CB4CCA059FC4}" type="datetimeFigureOut">
               <a:rPr lang="en-US" smtClean="0"/>
-              <a:t>6/2/2026</a:t>
+              <a:t>6/4/2026</a:t>
             </a:fld>
             <a:endParaRPr lang="en-US"/>
           </a:p>
@@ -1080,7 +1079,7 @@
           <a:p>
             <a:fld id="{5BCAD085-E8A6-8845-BD4E-CB4CCA059FC4}" type="datetimeFigureOut">
               <a:rPr lang="en-US" smtClean="0"/>
-              <a:t>6/2/2026</a:t>
+              <a:t>6/4/2026</a:t>
             </a:fld>
             <a:endParaRPr lang="en-US"/>
           </a:p>
@@ -1365,7 +1364,7 @@
           <a:p>
             <a:fld id="{5BCAD085-E8A6-8845-BD4E-CB4CCA059FC4}" type="datetimeFigureOut">
               <a:rPr lang="en-US" smtClean="0"/>
-              <a:t>6/2/2026</a:t>
+              <a:t>6/4/2026</a:t>
             </a:fld>
             <a:endParaRPr lang="en-US"/>
           </a:p>
@@ -1784,7 +1783,7 @@
           <a:p>
             <a:fld id="{5BCAD085-E8A6-8845-BD4E-CB4CCA059FC4}" type="datetimeFigureOut">
               <a:rPr lang="en-US" smtClean="0"/>
-              <a:t>6/2/2026</a:t>
+              <a:t>6/4/2026</a:t>
             </a:fld>
             <a:endParaRPr lang="en-US"/>
           </a:p>
@@ -1901,7 +1900,7 @@
           <a:p>
             <a:fld id="{5BCAD085-E8A6-8845-BD4E-CB4CCA059FC4}" type="datetimeFigureOut">
               <a:rPr lang="en-US" smtClean="0"/>
-              <a:t>6/2/2026</a:t>
+              <a:t>6/4/2026</a:t>
             </a:fld>
             <a:endParaRPr lang="en-US"/>
           </a:p>
@@ -1996,7 +1995,7 @@
           <a:p>
             <a:fld id="{5BCAD085-E8A6-8845-BD4E-CB4CCA059FC4}" type="datetimeFigureOut">
               <a:rPr lang="en-US" smtClean="0"/>
-              <a:t>6/2/2026</a:t>
+              <a:t>6/4/2026</a:t>
             </a:fld>
             <a:endParaRPr lang="en-US"/>
           </a:p>
@@ -2271,7 +2270,7 @@
           <a:p>
             <a:fld id="{5BCAD085-E8A6-8845-BD4E-CB4CCA059FC4}" type="datetimeFigureOut">
               <a:rPr lang="en-US" smtClean="0"/>
-              <a:t>6/2/2026</a:t>
+              <a:t>6/4/2026</a:t>
             </a:fld>
             <a:endParaRPr lang="en-US"/>
           </a:p>
@@ -2523,7 +2522,7 @@
           <a:p>
             <a:fld id="{5BCAD085-E8A6-8845-BD4E-CB4CCA059FC4}" type="datetimeFigureOut">
               <a:rPr lang="en-US" smtClean="0"/>
-              <a:t>6/2/2026</a:t>
+              <a:t>6/4/2026</a:t>
             </a:fld>
             <a:endParaRPr lang="en-US"/>
           </a:p>
@@ -2734,7 +2733,7 @@
           <a:p>
             <a:fld id="{5BCAD085-E8A6-8845-BD4E-CB4CCA059FC4}" type="datetimeFigureOut">
               <a:rPr lang="en-US" smtClean="0"/>
-              <a:t>6/2/2026</a:t>
+              <a:t>6/4/2026</a:t>
             </a:fld>
             <a:endParaRPr lang="en-US"/>
           </a:p>
@@ -3322,7 +3321,7 @@
                 </a:solidFill>
                 <a:latin typeface="Aptos"/>
               </a:rPr>
-              <a:t>What Is an Embedding?</a:t>
+              <a:t>What Is a Vector?</a:t>
             </a:r>
           </a:p>
         </p:txBody>
@@ -3358,14 +3357,14 @@
                 </a:solidFill>
                 <a:latin typeface="Aptos"/>
               </a:rPr>
-              <a:t>A learned table that turns token IDs into numeric rows</a:t>
-            </a:r>
-          </a:p>
-        </p:txBody>
-      </p:sp>
-      <p:sp>
-        <p:nvSpPr>
-          <p:cNvPr id="4" name="Definition"/>
+              <a:t>A compact list of numbers the neural network can compute with</a:t>
+            </a:r>
+          </a:p>
+        </p:txBody>
+      </p:sp>
+      <p:sp>
+        <p:nvSpPr>
+          <p:cNvPr id="4" name="Vector"/>
           <p:cNvSpPr/>
           <p:nvPr/>
         </p:nvSpPr>
@@ -3400,35 +3399,49 @@
                 </a:solidFill>
                 <a:latin typeface="Aptos"/>
               </a:rPr>
-              <a:t>Embedding table</a:t>
+              <a:t>Vector</a:t>
             </a:r>
           </a:p>
           <a:p>
             <a:pPr algn="l">
-              <a:defRPr sz="1550"/>
-            </a:pPr>
-            <a:r>
-              <a:rPr sz="1550" dirty="0">
+              <a:defRPr sz="1500"/>
+            </a:pPr>
+            <a:r>
+              <a:rPr sz="1500" dirty="0">
                 <a:solidFill>
                   <a:srgbClr val="172B4D"/>
                 </a:solidFill>
-                <a:latin typeface="Aptos"/>
-              </a:rPr>
-              <a:t>An embedding table is a matrix learned during training. Each token ID selects one row from that matrix.</a:t>
-            </a:r>
-          </a:p>
-        </p:txBody>
-      </p:sp>
-      <p:sp>
-        <p:nvSpPr>
-          <p:cNvPr id="5" name="Example Table"/>
+                <a:latin typeface="Consolas"/>
+              </a:rPr>
+              <a:t>sales vector:</a:t>
+            </a:r>
+          </a:p>
+          <a:p>
+            <a:pPr algn="l">
+              <a:defRPr sz="1500"/>
+            </a:pPr>
+            <a:r>
+              <a:rPr sz="1500" dirty="0">
+                <a:solidFill>
+                  <a:srgbClr val="172B4D"/>
+                </a:solidFill>
+                <a:latin typeface="Consolas"/>
+              </a:rPr>
+              <a:t>[-0.62, 0.18, 0.45, -0.09]</a:t>
+            </a:r>
+          </a:p>
+        </p:txBody>
+      </p:sp>
+      <p:sp>
+        <p:nvSpPr>
+          <p:cNvPr id="5" name="Algorithm"/>
           <p:cNvSpPr/>
           <p:nvPr/>
         </p:nvSpPr>
         <p:spPr>
           <a:xfrm>
             <a:off x="4846320" y="1188720"/>
-            <a:ext cx="5760720" cy="2560320"/>
+            <a:ext cx="5760720" cy="2377440"/>
           </a:xfrm>
           <a:prstGeom prst="roundRect">
             <a:avLst/>
@@ -3456,7 +3469,7 @@
                 </a:solidFill>
                 <a:latin typeface="Aptos"/>
               </a:rPr>
-              <a:t>Tiny example</a:t>
+              <a:t>Demo algorithm for sales</a:t>
             </a:r>
           </a:p>
           <a:p>
@@ -3470,7 +3483,7 @@
                 </a:solidFill>
                 <a:latin typeface="Consolas"/>
               </a:rPr>
-              <a:t>ID   token      vector row</a:t>
+              <a:t>1. Token: "sales"</a:t>
             </a:r>
           </a:p>
           <a:p>
@@ -3484,7 +3497,7 @@
                 </a:solidFill>
                 <a:latin typeface="Consolas"/>
               </a:rPr>
-              <a:t>1    are        [ 0.21, -0.44,  0.78,  0.12]</a:t>
+              <a:t>2. Vocabulary lookup: "sales" -&gt; 3</a:t>
             </a:r>
           </a:p>
           <a:p>
@@ -3498,7 +3511,7 @@
                 </a:solidFill>
                 <a:latin typeface="Consolas"/>
               </a:rPr>
-              <a:t>2    MAG        [ 0.03,  0.91, -0.14,  0.36]</a:t>
+              <a:t>3. Embedding lookup: E[3]</a:t>
             </a:r>
           </a:p>
           <a:p>
@@ -3512,7 +3525,25 @@
                 </a:solidFill>
                 <a:latin typeface="Consolas"/>
               </a:rPr>
-              <a:t>3    sales      [-0.62,  0.18,  0.45, -0.09]</a:t>
+              <a:t>4. Output</a:t>
+            </a:r>
+            <a:r>
+              <a:rPr lang="en-US" sz="1500" dirty="0">
+                <a:solidFill>
+                  <a:srgbClr val="172B4D"/>
+                </a:solidFill>
+                <a:latin typeface="Consolas"/>
+              </a:rPr>
+              <a:t> Vector</a:t>
+            </a:r>
+            <a:r>
+              <a:rPr sz="1500" dirty="0">
+                <a:solidFill>
+                  <a:srgbClr val="172B4D"/>
+                </a:solidFill>
+                <a:latin typeface="Consolas"/>
+              </a:rPr>
+              <a:t>: [-0.62, 0.18, 0.45, -0.09]</a:t>
             </a:r>
           </a:p>
         </p:txBody>
@@ -3525,8 +3556,8 @@
         </p:nvSpPr>
         <p:spPr>
           <a:xfrm>
-            <a:off x="822960" y="5577840"/>
-            <a:ext cx="9966960" cy="914400"/>
+            <a:off x="822960" y="4346840"/>
+            <a:ext cx="9966960" cy="1807072"/>
           </a:xfrm>
           <a:prstGeom prst="roundRect">
             <a:avLst/>
@@ -3556,189 +3587,7 @@
               </a:rPr>
               <a:t>Key takeaway</a:t>
             </a:r>
-          </a:p>
-          <a:p>
-            <a:pPr algn="ctr">
-              <a:defRPr sz="1700"/>
-            </a:pPr>
-            <a:r>
-              <a:rPr sz="1700" dirty="0">
-                <a:solidFill>
-                  <a:srgbClr val="172B4D"/>
-                </a:solidFill>
-                <a:highlight>
-                  <a:srgbClr val="FFFF00"/>
-                </a:highlight>
-                <a:latin typeface="Aptos"/>
-              </a:rPr>
-              <a:t>During inference, we do not calculate these numbers from spelling. </a:t>
-            </a:r>
-            <a:r>
-              <a:rPr sz="1700" dirty="0">
-                <a:solidFill>
-                  <a:srgbClr val="172B4D"/>
-                </a:solidFill>
-                <a:latin typeface="Aptos"/>
-              </a:rPr>
-              <a:t>We look up the learned row.</a:t>
-            </a:r>
-          </a:p>
-        </p:txBody>
-      </p:sp>
-      <p:sp>
-        <p:nvSpPr>
-          <p:cNvPr id="40" name="Footer"/>
-          <p:cNvSpPr/>
-          <p:nvPr/>
-        </p:nvSpPr>
-        <p:spPr>
-          <a:xfrm>
-            <a:off x="320040" y="6473952"/>
-            <a:ext cx="11521440" cy="228600"/>
-          </a:xfrm>
-          <a:prstGeom prst="rect">
-            <a:avLst/>
-          </a:prstGeom>
-          <a:noFill/>
-          <a:ln/>
-        </p:spPr>
-        <p:txBody>
-          <a:bodyPr lIns="0" tIns="0" rIns="0" bIns="0" rtlCol="0" anchor="t"/>
-          <a:lstStyle/>
-          <a:p>
-            <a:pPr algn="r">
-              <a:defRPr sz="850"/>
-            </a:pPr>
-            <a:r>
-              <a:rPr sz="850" dirty="0">
-                <a:solidFill>
-                  <a:srgbClr val="6B778C"/>
-                </a:solidFill>
-                <a:latin typeface="Aptos"/>
-              </a:rPr>
-              <a:t>AI Under the hood | Slide 10</a:t>
-            </a:r>
-          </a:p>
-        </p:txBody>
-      </p:sp>
-      <p:sp>
-        <p:nvSpPr>
-          <p:cNvPr id="9" name="Definition">
-            <a:extLst>
-              <a:ext uri="{FF2B5EF4-FFF2-40B4-BE49-F238E27FC236}">
-                <a16:creationId xmlns:a16="http://schemas.microsoft.com/office/drawing/2014/main" id="{0FCD2D10-DB6A-EBB2-1E45-F3B0AF2ABB4B}"/>
-              </a:ext>
-            </a:extLst>
-          </p:cNvPr>
-          <p:cNvSpPr/>
-          <p:nvPr/>
-        </p:nvSpPr>
-        <p:spPr>
-          <a:xfrm>
-            <a:off x="822959" y="3831882"/>
-            <a:ext cx="9784081" cy="1654518"/>
-          </a:xfrm>
-          <a:prstGeom prst="roundRect">
-            <a:avLst/>
-          </a:prstGeom>
-          <a:solidFill>
-            <a:srgbClr val="F5F8FC"/>
-          </a:solidFill>
-          <a:ln>
-            <a:solidFill>
-              <a:srgbClr val="BED2E6"/>
-            </a:solidFill>
-          </a:ln>
-        </p:spPr>
-        <p:txBody>
-          <a:bodyPr lIns="137160" tIns="137160" rIns="137160" bIns="137160" rtlCol="0" anchor="t"/>
-          <a:lstStyle/>
-          <a:p>
-            <a:pPr algn="l">
-              <a:defRPr sz="1750"/>
-            </a:pPr>
-            <a:r>
-              <a:rPr lang="en-US" sz="1550" dirty="0">
-                <a:solidFill>
-                  <a:srgbClr val="0B2F5B"/>
-                </a:solidFill>
-                <a:latin typeface="Aptos" panose="020B0004020202020204" pitchFamily="34" charset="0"/>
-              </a:rPr>
-              <a:t>A neural network contains a gigantic Embedding table matrix</a:t>
-            </a:r>
-          </a:p>
-          <a:p>
-            <a:pPr algn="l">
-              <a:defRPr sz="1750"/>
-            </a:pPr>
-            <a:endParaRPr lang="en-US" sz="1550" dirty="0">
-              <a:solidFill>
-                <a:srgbClr val="0B2F5B"/>
-              </a:solidFill>
-              <a:latin typeface="Aptos" panose="020B0004020202020204" pitchFamily="34" charset="0"/>
-            </a:endParaRPr>
-          </a:p>
-          <a:p>
-            <a:pPr algn="l">
-              <a:defRPr sz="1750"/>
-            </a:pPr>
-            <a:r>
-              <a:rPr lang="en-US" sz="1550" dirty="0">
-                <a:solidFill>
-                  <a:srgbClr val="0B2F5B"/>
-                </a:solidFill>
-                <a:latin typeface="Aptos" panose="020B0004020202020204" pitchFamily="34" charset="0"/>
-              </a:rPr>
-              <a:t>Example dimensions:  Vocabulary size * Embedding dimension</a:t>
-            </a:r>
-          </a:p>
-          <a:p>
-            <a:pPr algn="l">
-              <a:defRPr sz="1750"/>
-            </a:pPr>
-            <a:r>
-              <a:rPr lang="en-US" sz="1550" dirty="0">
-                <a:solidFill>
-                  <a:srgbClr val="0B2F5B"/>
-                </a:solidFill>
-                <a:latin typeface="Aptos" panose="020B0004020202020204" pitchFamily="34" charset="0"/>
-              </a:rPr>
-              <a:t>GPT4                                            100,256          *               1,536</a:t>
-            </a:r>
-          </a:p>
-          <a:p>
-            <a:pPr algn="l">
-              <a:defRPr sz="1750"/>
-            </a:pPr>
-            <a:endParaRPr lang="en-US" sz="1550" dirty="0">
-              <a:solidFill>
-                <a:srgbClr val="0B2F5B"/>
-              </a:solidFill>
-              <a:latin typeface="Aptos" panose="020B0004020202020204" pitchFamily="34" charset="0"/>
-            </a:endParaRPr>
-          </a:p>
-          <a:p>
-            <a:pPr algn="l">
-              <a:defRPr sz="1750"/>
-            </a:pPr>
-            <a:r>
-              <a:rPr lang="en-US" sz="1550" dirty="0">
-                <a:solidFill>
-                  <a:srgbClr val="0B2F5B"/>
-                </a:solidFill>
-                <a:latin typeface="Aptos" panose="020B0004020202020204" pitchFamily="34" charset="0"/>
-              </a:rPr>
-              <a:t>Meaning: each token is represented by 1,536 floating point numbers</a:t>
-            </a:r>
-            <a:endParaRPr lang="en-US" sz="1550" dirty="0">
-              <a:latin typeface="Aptos" panose="020B0004020202020204" pitchFamily="34" charset="0"/>
-            </a:endParaRPr>
-          </a:p>
-          <a:p>
-            <a:pPr algn="l">
-              <a:defRPr sz="1750"/>
-            </a:pPr>
-            <a:endParaRPr sz="1750" dirty="0">
+            <a:endParaRPr lang="en-US" sz="1850" b="1" dirty="0">
               <a:solidFill>
                 <a:srgbClr val="0B2F5B"/>
               </a:solidFill>
@@ -3746,15 +3595,135 @@
             </a:endParaRPr>
           </a:p>
           <a:p>
-            <a:pPr algn="l">
-              <a:defRPr sz="1550"/>
-            </a:pPr>
-            <a:endParaRPr sz="1550" dirty="0">
+            <a:pPr algn="ctr">
+              <a:defRPr sz="1700"/>
+            </a:pPr>
+            <a:r>
+              <a:rPr sz="1700" dirty="0">
+                <a:solidFill>
+                  <a:srgbClr val="172B4D"/>
+                </a:solidFill>
+                <a:latin typeface="Aptos"/>
+              </a:rPr>
+              <a:t>A vector is the numeric representation that moves forward. </a:t>
+            </a:r>
+            <a:endParaRPr lang="en-US" sz="1700" dirty="0">
               <a:solidFill>
                 <a:srgbClr val="172B4D"/>
               </a:solidFill>
               <a:latin typeface="Aptos"/>
             </a:endParaRPr>
+          </a:p>
+          <a:p>
+            <a:pPr algn="ctr">
+              <a:defRPr sz="1700"/>
+            </a:pPr>
+            <a:r>
+              <a:rPr sz="1700" dirty="0">
+                <a:solidFill>
+                  <a:srgbClr val="172B4D"/>
+                </a:solidFill>
+                <a:latin typeface="Aptos"/>
+              </a:rPr>
+              <a:t>The values are learned, then selected by ID.</a:t>
+            </a:r>
+            <a:endParaRPr lang="en-US" sz="1700" dirty="0">
+              <a:solidFill>
+                <a:srgbClr val="172B4D"/>
+              </a:solidFill>
+              <a:latin typeface="Aptos"/>
+            </a:endParaRPr>
+          </a:p>
+          <a:p>
+            <a:pPr algn="ctr">
+              <a:defRPr sz="1700"/>
+            </a:pPr>
+            <a:endParaRPr lang="en-US" sz="1700" dirty="0">
+              <a:solidFill>
+                <a:srgbClr val="172B4D"/>
+              </a:solidFill>
+              <a:latin typeface="Aptos"/>
+            </a:endParaRPr>
+          </a:p>
+          <a:p>
+            <a:pPr algn="ctr">
+              <a:defRPr sz="1700"/>
+            </a:pPr>
+            <a:r>
+              <a:rPr lang="en-US" sz="1700" dirty="0">
+                <a:solidFill>
+                  <a:srgbClr val="172B4D"/>
+                </a:solidFill>
+                <a:highlight>
+                  <a:srgbClr val="FFFF00"/>
+                </a:highlight>
+                <a:latin typeface="Aptos"/>
+              </a:rPr>
+              <a:t>The word “Sales” now is a </a:t>
+            </a:r>
+            <a:r>
+              <a:rPr lang="en-US" sz="1700" u="sng" dirty="0">
+                <a:solidFill>
+                  <a:srgbClr val="172B4D"/>
+                </a:solidFill>
+                <a:highlight>
+                  <a:srgbClr val="FFFF00"/>
+                </a:highlight>
+                <a:latin typeface="Aptos"/>
+              </a:rPr>
+              <a:t>point in multidimensional space</a:t>
+            </a:r>
+            <a:r>
+              <a:rPr lang="en-US" sz="1700" dirty="0">
+                <a:solidFill>
+                  <a:srgbClr val="172B4D"/>
+                </a:solidFill>
+                <a:latin typeface="Aptos"/>
+              </a:rPr>
+              <a:t>.</a:t>
+            </a:r>
+            <a:endParaRPr sz="1700" dirty="0">
+              <a:solidFill>
+                <a:srgbClr val="172B4D"/>
+              </a:solidFill>
+              <a:latin typeface="Aptos"/>
+            </a:endParaRPr>
+          </a:p>
+        </p:txBody>
+      </p:sp>
+      <p:sp>
+        <p:nvSpPr>
+          <p:cNvPr id="40" name="Footer"/>
+          <p:cNvSpPr/>
+          <p:nvPr/>
+        </p:nvSpPr>
+        <p:spPr>
+          <a:xfrm>
+            <a:off x="320040" y="6473952"/>
+            <a:ext cx="11521440" cy="228600"/>
+          </a:xfrm>
+          <a:prstGeom prst="rect">
+            <a:avLst/>
+          </a:prstGeom>
+          <a:noFill/>
+          <a:ln/>
+        </p:spPr>
+        <p:txBody>
+          <a:bodyPr lIns="0" tIns="0" rIns="0" bIns="0" rtlCol="0" anchor="t"/>
+          <a:lstStyle/>
+          <a:p>
+            <a:pPr algn="r">
+              <a:defRPr sz="850"/>
+            </a:pPr>
+            <a:r>
+              <a:rPr sz="850" dirty="0">
+                <a:solidFill>
+                  <a:srgbClr val="6B778C"/>
+                </a:solidFill>
+                <a:latin typeface="Aptos"/>
+              </a:rPr>
+              <a:t>AI Under the hood | Slide 13</a:t>
+            </a:r>
           </a:p>
         </p:txBody>
       </p:sp>
@@ -3785,107 +3754,93 @@
       </p:grpSpPr>
       <p:sp>
         <p:nvSpPr>
-          <p:cNvPr id="2" name="Title"/>
+          <p:cNvPr id="2" name="TextBox 1"/>
           <p:cNvSpPr txBox="1"/>
           <p:nvPr/>
         </p:nvSpPr>
         <p:spPr>
           <a:xfrm>
-            <a:off x="548640" y="274320"/>
-            <a:ext cx="11125200" cy="548640"/>
+            <a:off x="502920" y="320040"/>
+            <a:ext cx="5577745" cy="553998"/>
           </a:xfrm>
           <a:prstGeom prst="rect">
             <a:avLst/>
           </a:prstGeom>
           <a:noFill/>
-          <a:ln/>
-        </p:spPr>
-        <p:txBody>
-          <a:bodyPr lIns="0" tIns="0" rIns="0" bIns="0" rtlCol="0" anchor="t"/>
-          <a:lstStyle/>
-          <a:p>
-            <a:pPr algn="l">
-              <a:defRPr sz="2600"/>
-            </a:pPr>
-            <a:r>
-              <a:rPr sz="2600" b="1" dirty="0">
+        </p:spPr>
+        <p:txBody>
+          <a:bodyPr wrap="none">
+            <a:spAutoFit/>
+          </a:bodyPr>
+          <a:lstStyle/>
+          <a:p>
+            <a:pPr>
+              <a:defRPr sz="3000" b="1">
                 <a:solidFill>
                   <a:srgbClr val="0B2F5B"/>
                 </a:solidFill>
-                <a:latin typeface="Aptos"/>
-              </a:rPr>
-              <a:t>Embeddings: Learned Geometric Coordinates of Meaning</a:t>
-            </a:r>
-          </a:p>
-        </p:txBody>
-      </p:sp>
-      <p:sp>
-        <p:nvSpPr>
-          <p:cNvPr id="3" name="Subtitle"/>
+              </a:defRPr>
+            </a:pPr>
+            <a:r>
+              <a:rPr dirty="0"/>
+              <a:t>How Token ID </a:t>
+            </a:r>
+            <a:r>
+              <a:rPr lang="en-US" dirty="0"/>
+              <a:t>3</a:t>
+            </a:r>
+            <a:r>
+              <a:rPr dirty="0"/>
+              <a:t> Becomes a Vector</a:t>
+            </a:r>
+          </a:p>
+        </p:txBody>
+      </p:sp>
+      <p:sp>
+        <p:nvSpPr>
+          <p:cNvPr id="3" name="TextBox 2"/>
           <p:cNvSpPr txBox="1"/>
           <p:nvPr/>
         </p:nvSpPr>
         <p:spPr>
           <a:xfrm>
-            <a:off x="594360" y="777240"/>
-            <a:ext cx="10820400" cy="365760"/>
+            <a:off x="530352" y="868680"/>
+            <a:ext cx="10972800" cy="365760"/>
           </a:xfrm>
           <a:prstGeom prst="rect">
             <a:avLst/>
           </a:prstGeom>
           <a:noFill/>
-          <a:ln/>
-        </p:spPr>
-        <p:txBody>
-          <a:bodyPr lIns="0" tIns="0" rIns="0" bIns="0" rtlCol="0" anchor="t"/>
-          <a:lstStyle/>
-          <a:p>
-            <a:pPr algn="l">
-              <a:defRPr sz="1550"/>
-            </a:pPr>
-            <a:r>
-              <a:rPr sz="1550" dirty="0">
+        </p:spPr>
+        <p:txBody>
+          <a:bodyPr wrap="none">
+            <a:spAutoFit/>
+          </a:bodyPr>
+          <a:lstStyle/>
+          <a:p>
+            <a:pPr>
+              <a:defRPr sz="1600">
                 <a:solidFill>
                   <a:srgbClr val="52616B"/>
                 </a:solidFill>
-                <a:latin typeface="Aptos"/>
-              </a:rPr>
-              <a:t>Training turns random vectors into a map where </a:t>
-            </a:r>
-            <a:r>
-              <a:rPr sz="1550" dirty="0">
-                <a:solidFill>
-                  <a:srgbClr val="52616B"/>
-                </a:solidFill>
-                <a:highlight>
-                  <a:srgbClr val="FFFF00"/>
-                </a:highlight>
-                <a:latin typeface="Aptos"/>
-              </a:rPr>
-              <a:t>distance carries semantics</a:t>
-            </a:r>
-            <a:r>
-              <a:rPr sz="1550" dirty="0">
-                <a:solidFill>
-                  <a:srgbClr val="52616B"/>
-                </a:solidFill>
-                <a:latin typeface="Aptos"/>
-              </a:rPr>
-              <a:t>.</a:t>
-            </a:r>
-          </a:p>
-        </p:txBody>
-      </p:sp>
-      <p:sp>
-        <p:nvSpPr>
-          <p:cNvPr id="4" name="Initially Random"/>
+              </a:defRPr>
+            </a:pPr>
+            <a:r>
+              <a:t>The algorithm is a row lookup</a:t>
+            </a:r>
+          </a:p>
+        </p:txBody>
+      </p:sp>
+      <p:sp>
+        <p:nvSpPr>
+          <p:cNvPr id="4" name="Rounded Rectangle 3"/>
           <p:cNvSpPr/>
           <p:nvPr/>
         </p:nvSpPr>
         <p:spPr>
           <a:xfrm>
-            <a:off x="640080" y="1280160"/>
-            <a:ext cx="3291840" cy="1737360"/>
+            <a:off x="731289" y="1234440"/>
+            <a:ext cx="3062113" cy="914400"/>
           </a:xfrm>
           <a:prstGeom prst="roundRect">
             <a:avLst/>
@@ -3899,69 +3854,91 @@
             </a:solidFill>
           </a:ln>
         </p:spPr>
-        <p:txBody>
-          <a:bodyPr lIns="91440" tIns="91440" rIns="91440" bIns="91440" rtlCol="0" anchor="t"/>
-          <a:lstStyle/>
-          <a:p>
-            <a:pPr algn="l">
-              <a:defRPr sz="1700"/>
-            </a:pPr>
-            <a:r>
-              <a:rPr sz="1700" b="1" dirty="0">
-                <a:solidFill>
-                  <a:srgbClr val="0B2F5B"/>
-                </a:solidFill>
-                <a:latin typeface="Aptos"/>
-              </a:rPr>
-              <a:t>Initially</a:t>
-            </a:r>
-          </a:p>
-          <a:p>
-            <a:pPr algn="l">
-              <a:defRPr sz="1250"/>
-            </a:pPr>
-            <a:r>
-              <a:rPr sz="1250" dirty="0">
+        <p:style>
+          <a:lnRef idx="1">
+            <a:schemeClr val="accent1"/>
+          </a:lnRef>
+          <a:fillRef idx="3">
+            <a:schemeClr val="accent1"/>
+          </a:fillRef>
+          <a:effectRef idx="2">
+            <a:schemeClr val="accent1"/>
+          </a:effectRef>
+          <a:fontRef idx="minor">
+            <a:schemeClr val="lt1"/>
+          </a:fontRef>
+        </p:style>
+        <p:txBody>
+          <a:bodyPr lIns="182880" tIns="109728" rIns="182880" rtlCol="0" anchor="ctr"/>
+          <a:lstStyle/>
+          <a:p>
+            <a:pPr algn="ctr">
+              <a:defRPr sz="2500">
                 <a:solidFill>
                   <a:srgbClr val="172B4D"/>
                 </a:solidFill>
                 <a:latin typeface="Consolas"/>
-              </a:rPr>
-              <a:t>MAG     = [random garbage]</a:t>
-            </a:r>
-            <a:br/>
-            <a:r>
-              <a:rPr sz="1250" dirty="0">
-                <a:solidFill>
-                  <a:srgbClr val="172B4D"/>
-                </a:solidFill>
-                <a:latin typeface="Consolas"/>
-              </a:rPr>
-              <a:t>sales   = [random garbage]</a:t>
-            </a:r>
-            <a:br/>
-            <a:r>
-              <a:rPr sz="1250" dirty="0">
-                <a:solidFill>
-                  <a:srgbClr val="172B4D"/>
-                </a:solidFill>
-                <a:latin typeface="Consolas"/>
-              </a:rPr>
-              <a:t>Chicago = [random garbage]</a:t>
-            </a:r>
-          </a:p>
-        </p:txBody>
-      </p:sp>
-      <p:sp>
-        <p:nvSpPr>
-          <p:cNvPr id="5" name="Training Contexts"/>
+              </a:defRPr>
+            </a:pPr>
+            <a:r>
+              <a:rPr dirty="0"/>
+              <a:t>Token ID </a:t>
+            </a:r>
+            <a:r>
+              <a:rPr lang="en-US" dirty="0"/>
+              <a:t>3</a:t>
+            </a:r>
+            <a:endParaRPr dirty="0"/>
+          </a:p>
+        </p:txBody>
+      </p:sp>
+      <p:cxnSp>
+        <p:nvCxnSpPr>
+          <p:cNvPr id="5" name="Connector 4"/>
+          <p:cNvCxnSpPr>
+            <a:cxnSpLocks/>
+          </p:cNvCxnSpPr>
+          <p:nvPr/>
+        </p:nvCxnSpPr>
+        <p:spPr>
+          <a:xfrm>
+            <a:off x="3793402" y="1691640"/>
+            <a:ext cx="675640" cy="0"/>
+          </a:xfrm>
+          <a:prstGeom prst="line">
+            <a:avLst/>
+          </a:prstGeom>
+          <a:ln w="38100">
+            <a:solidFill>
+              <a:srgbClr val="0B5CAD"/>
+            </a:solidFill>
+          </a:ln>
+        </p:spPr>
+        <p:style>
+          <a:lnRef idx="2">
+            <a:schemeClr val="accent1"/>
+          </a:lnRef>
+          <a:fillRef idx="0">
+            <a:schemeClr val="accent1"/>
+          </a:fillRef>
+          <a:effectRef idx="1">
+            <a:schemeClr val="accent1"/>
+          </a:effectRef>
+          <a:fontRef idx="minor">
+            <a:schemeClr val="tx1"/>
+          </a:fontRef>
+        </p:style>
+      </p:cxnSp>
+      <p:sp>
+        <p:nvSpPr>
+          <p:cNvPr id="6" name="Rounded Rectangle 5"/>
           <p:cNvSpPr/>
           <p:nvPr/>
         </p:nvSpPr>
         <p:spPr>
           <a:xfrm>
-            <a:off x="4389120" y="1280160"/>
-            <a:ext cx="3200400" cy="1737360"/>
+            <a:off x="4496474" y="1234440"/>
+            <a:ext cx="2485901" cy="914400"/>
           </a:xfrm>
           <a:prstGeom prst="roundRect">
             <a:avLst/>
@@ -3975,329 +3952,92 @@
             </a:solidFill>
           </a:ln>
         </p:spPr>
-        <p:txBody>
-          <a:bodyPr lIns="91440" tIns="91440" rIns="91440" bIns="91440" rtlCol="0" anchor="t"/>
-          <a:lstStyle/>
-          <a:p>
-            <a:pPr algn="l">
-              <a:defRPr sz="1700"/>
-            </a:pPr>
-            <a:r>
-              <a:rPr sz="1700" b="1" dirty="0">
-                <a:solidFill>
-                  <a:srgbClr val="0B2F5B"/>
-                </a:solidFill>
-                <a:latin typeface="Aptos"/>
-              </a:rPr>
-              <a:t>During training</a:t>
-            </a:r>
-          </a:p>
-          <a:p>
-            <a:pPr algn="l">
-              <a:defRPr sz="1350"/>
-            </a:pPr>
-            <a:r>
-              <a:rPr sz="1350" dirty="0">
+        <p:style>
+          <a:lnRef idx="1">
+            <a:schemeClr val="accent1"/>
+          </a:lnRef>
+          <a:fillRef idx="3">
+            <a:schemeClr val="accent1"/>
+          </a:fillRef>
+          <a:effectRef idx="2">
+            <a:schemeClr val="accent1"/>
+          </a:effectRef>
+          <a:fontRef idx="minor">
+            <a:schemeClr val="lt1"/>
+          </a:fontRef>
+        </p:style>
+        <p:txBody>
+          <a:bodyPr lIns="182880" tIns="109728" rIns="182880" rtlCol="0" anchor="ctr"/>
+          <a:lstStyle/>
+          <a:p>
+            <a:pPr algn="ctr">
+              <a:defRPr sz="2500">
                 <a:solidFill>
                   <a:srgbClr val="172B4D"/>
                 </a:solidFill>
                 <a:latin typeface="Consolas"/>
-              </a:rPr>
-              <a:t>sales up</a:t>
-            </a:r>
-            <a:br/>
-            <a:r>
-              <a:rPr sz="1350" dirty="0">
-                <a:solidFill>
-                  <a:srgbClr val="172B4D"/>
-                </a:solidFill>
-                <a:latin typeface="Consolas"/>
-              </a:rPr>
-              <a:t>sales increased</a:t>
-            </a:r>
-            <a:br/>
-            <a:r>
-              <a:rPr sz="1350" dirty="0">
-                <a:solidFill>
-                  <a:srgbClr val="172B4D"/>
-                </a:solidFill>
-                <a:latin typeface="Consolas"/>
-              </a:rPr>
-              <a:t>revenue growth</a:t>
-            </a:r>
-            <a:br/>
-            <a:r>
-              <a:rPr sz="1350" dirty="0">
-                <a:solidFill>
-                  <a:srgbClr val="172B4D"/>
-                </a:solidFill>
-                <a:latin typeface="Consolas"/>
-              </a:rPr>
-              <a:t>Chicago region</a:t>
-            </a:r>
-          </a:p>
-        </p:txBody>
-      </p:sp>
-      <p:sp>
-        <p:nvSpPr>
-          <p:cNvPr id="6" name="Geometry Meaning"/>
-          <p:cNvSpPr/>
-          <p:nvPr/>
-        </p:nvSpPr>
-        <p:spPr>
-          <a:xfrm>
-            <a:off x="8138160" y="1280160"/>
-            <a:ext cx="3200400" cy="1737360"/>
-          </a:xfrm>
-          <a:prstGeom prst="roundRect">
-            <a:avLst/>
-          </a:prstGeom>
-          <a:solidFill>
-            <a:srgbClr val="EAF3FF"/>
-          </a:solidFill>
-          <a:ln>
+              </a:defRPr>
+            </a:pPr>
+            <a:r>
+              <a:rPr dirty="0"/>
+              <a:t>E[</a:t>
+            </a:r>
+            <a:r>
+              <a:rPr lang="en-US" dirty="0"/>
+              <a:t>3</a:t>
+            </a:r>
+            <a:r>
+              <a:rPr dirty="0"/>
+              <a:t>]</a:t>
+            </a:r>
+          </a:p>
+        </p:txBody>
+      </p:sp>
+      <p:cxnSp>
+        <p:nvCxnSpPr>
+          <p:cNvPr id="7" name="Connector 6"/>
+          <p:cNvCxnSpPr/>
+          <p:nvPr/>
+        </p:nvCxnSpPr>
+        <p:spPr>
+          <a:xfrm>
+            <a:off x="6982375" y="1691640"/>
+            <a:ext cx="685800" cy="0"/>
+          </a:xfrm>
+          <a:prstGeom prst="line">
+            <a:avLst/>
+          </a:prstGeom>
+          <a:ln w="38100">
             <a:solidFill>
               <a:srgbClr val="0B5CAD"/>
             </a:solidFill>
           </a:ln>
         </p:spPr>
-        <p:txBody>
-          <a:bodyPr lIns="91440" tIns="91440" rIns="91440" bIns="91440" rtlCol="0" anchor="t"/>
-          <a:lstStyle/>
-          <a:p>
-            <a:pPr algn="l">
-              <a:defRPr sz="1700"/>
-            </a:pPr>
-            <a:r>
-              <a:rPr sz="1700" b="1" dirty="0">
-                <a:solidFill>
-                  <a:srgbClr val="0B2F5B"/>
-                </a:solidFill>
-                <a:latin typeface="Aptos"/>
-              </a:rPr>
-              <a:t>Backprop moves vectors</a:t>
-            </a:r>
-          </a:p>
-          <a:p>
-            <a:pPr algn="l">
-              <a:defRPr sz="1375"/>
-            </a:pPr>
-            <a:r>
-              <a:rPr sz="1375" dirty="0">
-                <a:solidFill>
-                  <a:srgbClr val="172B4D"/>
-                </a:solidFill>
-                <a:latin typeface="Aptos"/>
-              </a:rPr>
-              <a:t>similar words move closer</a:t>
-            </a:r>
-            <a:br/>
-            <a:r>
-              <a:rPr sz="1375" dirty="0">
-                <a:solidFill>
-                  <a:srgbClr val="172B4D"/>
-                </a:solidFill>
-                <a:latin typeface="Aptos"/>
-              </a:rPr>
-              <a:t>unrelated words move apart</a:t>
-            </a:r>
-            <a:br/>
-            <a:r>
-              <a:rPr sz="1375" dirty="0">
-                <a:solidFill>
-                  <a:srgbClr val="172B4D"/>
-                </a:solidFill>
-                <a:latin typeface="Aptos"/>
-              </a:rPr>
-              <a:t>geometry stores meaning</a:t>
-            </a:r>
-          </a:p>
-        </p:txBody>
-      </p:sp>
-      <p:sp>
-        <p:nvSpPr>
-          <p:cNvPr id="7" name="Visual Intuition"/>
+        <p:style>
+          <a:lnRef idx="2">
+            <a:schemeClr val="accent1"/>
+          </a:lnRef>
+          <a:fillRef idx="0">
+            <a:schemeClr val="accent1"/>
+          </a:fillRef>
+          <a:effectRef idx="1">
+            <a:schemeClr val="accent1"/>
+          </a:effectRef>
+          <a:fontRef idx="minor">
+            <a:schemeClr val="tx1"/>
+          </a:fontRef>
+        </p:style>
+      </p:cxnSp>
+      <p:sp>
+        <p:nvSpPr>
+          <p:cNvPr id="8" name="Rounded Rectangle 7"/>
           <p:cNvSpPr/>
           <p:nvPr/>
         </p:nvSpPr>
         <p:spPr>
           <a:xfrm>
-            <a:off x="640080" y="3370320"/>
-            <a:ext cx="5029200" cy="2011680"/>
-          </a:xfrm>
-          <a:prstGeom prst="roundRect">
-            <a:avLst/>
-          </a:prstGeom>
-          <a:solidFill>
-            <a:srgbClr val="FFFFFF"/>
-          </a:solidFill>
-          <a:ln>
-            <a:solidFill>
-              <a:srgbClr val="BED2E6"/>
-            </a:solidFill>
-          </a:ln>
-        </p:spPr>
-        <p:txBody>
-          <a:bodyPr lIns="91440" tIns="91440" rIns="91440" bIns="91440" rtlCol="0" anchor="t"/>
-          <a:lstStyle/>
-          <a:p>
-            <a:pPr algn="l">
-              <a:defRPr sz="1650"/>
-            </a:pPr>
-            <a:r>
-              <a:rPr sz="1650" b="1" dirty="0">
-                <a:solidFill>
-                  <a:srgbClr val="0B2F5B"/>
-                </a:solidFill>
-                <a:latin typeface="Aptos"/>
-              </a:rPr>
-              <a:t>Visual intuition: distances encode relationships</a:t>
-            </a:r>
-          </a:p>
-          <a:p>
-            <a:pPr algn="l">
-              <a:defRPr sz="1250"/>
-            </a:pPr>
-            <a:r>
-              <a:rPr sz="1250" dirty="0">
-                <a:solidFill>
-                  <a:srgbClr val="172B4D"/>
-                </a:solidFill>
-                <a:latin typeface="Consolas"/>
-              </a:rPr>
-              <a:t>king   (2, 9, 4)    queen  (2, 9, 5)</a:t>
-            </a:r>
-            <a:br/>
-            <a:r>
-              <a:rPr sz="1250" dirty="0">
-                <a:solidFill>
-                  <a:srgbClr val="172B4D"/>
-                </a:solidFill>
-                <a:latin typeface="Consolas"/>
-              </a:rPr>
-              <a:t>man    (1, 4, 3)    woman  (1, 4, 4)</a:t>
-            </a:r>
-          </a:p>
-          <a:p>
-            <a:pPr algn="l">
-              <a:defRPr sz="1550"/>
-            </a:pPr>
-            <a:r>
-              <a:rPr sz="1550" b="1" dirty="0">
-                <a:solidFill>
-                  <a:srgbClr val="0B5CAD"/>
-                </a:solidFill>
-                <a:latin typeface="Consolas"/>
-              </a:rPr>
-              <a:t>king - man + woman ~= queen</a:t>
-            </a:r>
-          </a:p>
-        </p:txBody>
-      </p:sp>
-      <p:sp>
-        <p:nvSpPr>
-          <p:cNvPr id="8" name="Sentence Embeddings"/>
-          <p:cNvSpPr/>
-          <p:nvPr/>
-        </p:nvSpPr>
-        <p:spPr>
-          <a:xfrm>
-            <a:off x="5989320" y="3370320"/>
-            <a:ext cx="5394960" cy="2011680"/>
-          </a:xfrm>
-          <a:prstGeom prst="roundRect">
-            <a:avLst/>
-          </a:prstGeom>
-          <a:solidFill>
-            <a:srgbClr val="FFFFFF"/>
-          </a:solidFill>
-          <a:ln>
-            <a:solidFill>
-              <a:srgbClr val="BED2E6"/>
-            </a:solidFill>
-          </a:ln>
-        </p:spPr>
-        <p:txBody>
-          <a:bodyPr lIns="91440" tIns="91440" rIns="91440" bIns="91440" rtlCol="0" anchor="t"/>
-          <a:lstStyle/>
-          <a:p>
-            <a:pPr algn="l">
-              <a:defRPr sz="1650"/>
-            </a:pPr>
-            <a:r>
-              <a:rPr sz="1650" b="1" dirty="0">
-                <a:solidFill>
-                  <a:srgbClr val="0B2F5B"/>
-                </a:solidFill>
-                <a:latin typeface="Aptos"/>
-              </a:rPr>
-              <a:t>Sentence embeddings combine token vectors</a:t>
-            </a:r>
-          </a:p>
-          <a:p>
-            <a:pPr algn="l">
-              <a:defRPr sz="1250"/>
-            </a:pPr>
-            <a:r>
-              <a:rPr sz="1250" dirty="0">
-                <a:solidFill>
-                  <a:srgbClr val="172B4D"/>
-                </a:solidFill>
-                <a:latin typeface="Aptos"/>
-              </a:rPr>
-              <a:t>averaging | attention | transformers | pooling</a:t>
-            </a:r>
-          </a:p>
-          <a:p>
-            <a:pPr algn="l">
-              <a:defRPr sz="1200"/>
-            </a:pPr>
-            <a:r>
-              <a:rPr sz="1200" dirty="0">
-                <a:solidFill>
-                  <a:srgbClr val="172B4D"/>
-                </a:solidFill>
-                <a:latin typeface="Consolas"/>
-              </a:rPr>
-              <a:t>"MAG sales are up in Chicago"</a:t>
-            </a:r>
-            <a:br/>
-            <a:r>
-              <a:rPr sz="1200" dirty="0">
-                <a:solidFill>
-                  <a:srgbClr val="172B4D"/>
-                </a:solidFill>
-                <a:latin typeface="Consolas"/>
-              </a:rPr>
-              <a:t>-&gt; [0.192, -0.551, 0.882, ... 1536 dims ...]</a:t>
-            </a:r>
-          </a:p>
-          <a:p>
-            <a:pPr algn="l">
-              <a:defRPr sz="1225"/>
-            </a:pPr>
-            <a:r>
-              <a:rPr sz="1225" dirty="0">
-                <a:solidFill>
-                  <a:srgbClr val="52616B"/>
-                </a:solidFill>
-                <a:latin typeface="Aptos"/>
-              </a:rPr>
-              <a:t>captures business context, trend, location, and organization semantics</a:t>
-            </a:r>
-          </a:p>
-        </p:txBody>
-      </p:sp>
-      <p:sp>
-        <p:nvSpPr>
-          <p:cNvPr id="9" name="Why This Works"/>
-          <p:cNvSpPr/>
-          <p:nvPr/>
-        </p:nvSpPr>
-        <p:spPr>
-          <a:xfrm>
-            <a:off x="914400" y="5791200"/>
-            <a:ext cx="10393680" cy="548640"/>
+            <a:off x="7668174" y="1228555"/>
+            <a:ext cx="3670385" cy="914400"/>
           </a:xfrm>
           <a:prstGeom prst="roundRect">
             <a:avLst/>
@@ -4311,54 +4051,141 @@
             </a:solidFill>
           </a:ln>
         </p:spPr>
-        <p:txBody>
-          <a:bodyPr lIns="91440" tIns="91440" rIns="91440" bIns="91440" rtlCol="0" anchor="ctr"/>
+        <p:style>
+          <a:lnRef idx="1">
+            <a:schemeClr val="accent1"/>
+          </a:lnRef>
+          <a:fillRef idx="3">
+            <a:schemeClr val="accent1"/>
+          </a:fillRef>
+          <a:effectRef idx="2">
+            <a:schemeClr val="accent1"/>
+          </a:effectRef>
+          <a:fontRef idx="minor">
+            <a:schemeClr val="lt1"/>
+          </a:fontRef>
+        </p:style>
+        <p:txBody>
+          <a:bodyPr lIns="182880" tIns="109728" rIns="182880" rtlCol="0" anchor="ctr"/>
+          <a:lstStyle/>
+          <a:p>
+            <a:pPr>
+              <a:defRPr sz="1600">
+                <a:solidFill>
+                  <a:srgbClr val="172B4D"/>
+                </a:solidFill>
+                <a:latin typeface="Consolas"/>
+              </a:defRPr>
+            </a:pPr>
+            <a:r>
+              <a:rPr dirty="0"/>
+              <a:t>[</a:t>
+            </a:r>
+            <a:r>
+              <a:rPr lang="en-US" dirty="0"/>
+              <a:t>-0.62,  0.18,  0.45, -0.09</a:t>
+            </a:r>
+            <a:r>
+              <a:rPr dirty="0"/>
+              <a:t>]</a:t>
+            </a:r>
+          </a:p>
+        </p:txBody>
+      </p:sp>
+      <p:sp>
+        <p:nvSpPr>
+          <p:cNvPr id="9" name="Rounded Rectangle 8"/>
+          <p:cNvSpPr/>
+          <p:nvPr/>
+        </p:nvSpPr>
+        <p:spPr>
+          <a:xfrm>
+            <a:off x="914400" y="3200400"/>
+            <a:ext cx="10424160" cy="1325880"/>
+          </a:xfrm>
+          <a:prstGeom prst="roundRect">
+            <a:avLst/>
+          </a:prstGeom>
+          <a:solidFill>
+            <a:srgbClr val="FFFFFF"/>
+          </a:solidFill>
+          <a:ln w="19050">
+            <a:solidFill>
+              <a:srgbClr val="0B5CAD"/>
+            </a:solidFill>
+          </a:ln>
+        </p:spPr>
+        <p:style>
+          <a:lnRef idx="1">
+            <a:schemeClr val="accent1"/>
+          </a:lnRef>
+          <a:fillRef idx="3">
+            <a:schemeClr val="accent1"/>
+          </a:fillRef>
+          <a:effectRef idx="2">
+            <a:schemeClr val="accent1"/>
+          </a:effectRef>
+          <a:fontRef idx="minor">
+            <a:schemeClr val="lt1"/>
+          </a:fontRef>
+        </p:style>
+        <p:txBody>
+          <a:bodyPr lIns="137160" tIns="91440" rIns="137160" rtlCol="0" anchor="ctr"/>
           <a:lstStyle/>
           <a:p>
             <a:pPr algn="ctr">
-              <a:defRPr sz="1450"/>
-            </a:pPr>
-            <a:r>
-              <a:rPr sz="1450" b="1" dirty="0">
+              <a:defRPr sz="1900" b="1">
+                <a:solidFill>
+                  <a:srgbClr val="0B2F5B"/>
+                </a:solidFill>
+              </a:defRPr>
+            </a:pPr>
+            <a:r>
+              <a:rPr dirty="0"/>
+              <a:t>Important distinction</a:t>
+            </a:r>
+          </a:p>
+          <a:p>
+            <a:pPr>
+              <a:spcAft>
+                <a:spcPts val="200"/>
+              </a:spcAft>
+              <a:defRPr sz="1800">
                 <a:solidFill>
                   <a:srgbClr val="172B4D"/>
                 </a:solidFill>
+              </a:defRPr>
+            </a:pPr>
+            <a:r>
+              <a:rPr dirty="0">
                 <a:highlight>
                   <a:srgbClr val="FFFF00"/>
                 </a:highlight>
-                <a:latin typeface="Aptos"/>
-              </a:rPr>
-              <a:t>Why it works: language has statistical structure. Context patterns -&gt; geometric relationships. </a:t>
-            </a:r>
-            <a:endParaRPr lang="en-US" sz="1450" b="1" dirty="0">
-              <a:solidFill>
-                <a:srgbClr val="172B4D"/>
-              </a:solidFill>
-              <a:highlight>
-                <a:srgbClr val="FFFF00"/>
-              </a:highlight>
-              <a:latin typeface="Aptos"/>
-            </a:endParaRPr>
-          </a:p>
-          <a:p>
-            <a:pPr algn="ctr">
-              <a:defRPr sz="1450"/>
-            </a:pPr>
-            <a:r>
-              <a:rPr sz="1450" dirty="0">
-                <a:solidFill>
-                  <a:srgbClr val="172B4D"/>
-                </a:solidFill>
-                <a:latin typeface="Aptos"/>
-              </a:rPr>
-              <a:t>Foundation for Word2Vec, GloVe, BERT, GPT, and LLMs.</a:t>
-            </a:r>
-          </a:p>
-        </p:txBody>
-      </p:sp>
-      <p:sp>
-        <p:nvSpPr>
-          <p:cNvPr id="10" name="Footer"/>
+              </a:rPr>
+              <a:t>The integer </a:t>
+            </a:r>
+            <a:r>
+              <a:rPr lang="en-US" dirty="0">
+                <a:highlight>
+                  <a:srgbClr val="FFFF00"/>
+                </a:highlight>
+              </a:rPr>
+              <a:t>3</a:t>
+            </a:r>
+            <a:r>
+              <a:rPr dirty="0">
+                <a:highlight>
+                  <a:srgbClr val="FFFF00"/>
+                </a:highlight>
+              </a:rPr>
+              <a:t> does not contain the meaning of “sales.” It points to a learned row in the embedding matrix.</a:t>
+            </a:r>
+          </a:p>
+        </p:txBody>
+      </p:sp>
+      <p:sp>
+        <p:nvSpPr>
+          <p:cNvPr id="10" name="TextBox 9"/>
           <p:cNvSpPr txBox="1"/>
           <p:nvPr/>
         </p:nvSpPr>
@@ -4386,7 +4213,7 @@
               </a:defRPr>
             </a:pPr>
             <a:r>
-              <a:t>AI Under the hood | Slide 11</a:t>
+              <a:t>AI Under the hood | Slide 14</a:t>
             </a:r>
           </a:p>
         </p:txBody>
@@ -4418,84 +4245,86 @@
       </p:grpSpPr>
       <p:sp>
         <p:nvSpPr>
-          <p:cNvPr id="2" name="TextBox 1"/>
-          <p:cNvSpPr txBox="1"/>
-          <p:nvPr/>
-        </p:nvSpPr>
-        <p:spPr>
-          <a:xfrm>
-            <a:off x="502920" y="320040"/>
-            <a:ext cx="11247120" cy="548640"/>
+          <p:cNvPr id="2" name="Title"/>
+          <p:cNvSpPr/>
+          <p:nvPr/>
+        </p:nvSpPr>
+        <p:spPr>
+          <a:xfrm>
+            <a:off x="640080" y="365760"/>
+            <a:ext cx="10911840" cy="548640"/>
           </a:xfrm>
           <a:prstGeom prst="rect">
             <a:avLst/>
           </a:prstGeom>
           <a:noFill/>
-        </p:spPr>
-        <p:txBody>
-          <a:bodyPr wrap="none">
-            <a:spAutoFit/>
-          </a:bodyPr>
-          <a:lstStyle/>
-          <a:p>
-            <a:pPr>
-              <a:defRPr sz="3000" b="1">
+          <a:ln/>
+        </p:spPr>
+        <p:txBody>
+          <a:bodyPr lIns="0" tIns="0" rIns="0" bIns="0" rtlCol="0" anchor="t"/>
+          <a:lstStyle/>
+          <a:p>
+            <a:pPr algn="l">
+              <a:defRPr sz="3000"/>
+            </a:pPr>
+            <a:r>
+              <a:rPr sz="3000" b="1" dirty="0">
                 <a:solidFill>
                   <a:srgbClr val="0B2F5B"/>
                 </a:solidFill>
-              </a:defRPr>
-            </a:pPr>
-            <a:r>
-              <a:t>Embedding Lookup</a:t>
-            </a:r>
-          </a:p>
-        </p:txBody>
-      </p:sp>
-      <p:sp>
-        <p:nvSpPr>
-          <p:cNvPr id="3" name="TextBox 2"/>
-          <p:cNvSpPr txBox="1"/>
-          <p:nvPr/>
-        </p:nvSpPr>
-        <p:spPr>
-          <a:xfrm>
-            <a:off x="530352" y="868680"/>
-            <a:ext cx="10972800" cy="365760"/>
+                <a:latin typeface="Aptos"/>
+              </a:rPr>
+              <a:t>What Is an Embedding?</a:t>
+            </a:r>
+          </a:p>
+        </p:txBody>
+      </p:sp>
+      <p:sp>
+        <p:nvSpPr>
+          <p:cNvPr id="3" name="Subtitle"/>
+          <p:cNvSpPr/>
+          <p:nvPr/>
+        </p:nvSpPr>
+        <p:spPr>
+          <a:xfrm>
+            <a:off x="640080" y="868680"/>
+            <a:ext cx="10911840" cy="365760"/>
           </a:xfrm>
           <a:prstGeom prst="rect">
             <a:avLst/>
           </a:prstGeom>
           <a:noFill/>
-        </p:spPr>
-        <p:txBody>
-          <a:bodyPr wrap="none">
-            <a:spAutoFit/>
-          </a:bodyPr>
-          <a:lstStyle/>
-          <a:p>
-            <a:pPr>
-              <a:defRPr sz="1600">
-                <a:solidFill>
-                  <a:srgbClr val="52616B"/>
-                </a:solidFill>
-              </a:defRPr>
-            </a:pPr>
-            <a:r>
-              <a:t>Token IDs become vectors</a:t>
-            </a:r>
-          </a:p>
-        </p:txBody>
-      </p:sp>
-      <p:sp>
-        <p:nvSpPr>
-          <p:cNvPr id="4" name="Rounded Rectangle 3"/>
+          <a:ln/>
+        </p:spPr>
+        <p:txBody>
+          <a:bodyPr lIns="0" tIns="0" rIns="0" bIns="0" rtlCol="0" anchor="t"/>
+          <a:lstStyle/>
+          <a:p>
+            <a:pPr algn="l">
+              <a:defRPr sz="1600"/>
+            </a:pPr>
+            <a:r>
+              <a:rPr sz="1600" dirty="0">
+                <a:solidFill>
+                  <a:srgbClr val="5E6C84"/>
+                </a:solidFill>
+                <a:latin typeface="Aptos"/>
+              </a:rPr>
+              <a:t>A learned table that turns token IDs into numeric rows</a:t>
+            </a:r>
+          </a:p>
+        </p:txBody>
+      </p:sp>
+      <p:sp>
+        <p:nvSpPr>
+          <p:cNvPr id="4" name="Definition"/>
           <p:cNvSpPr/>
           <p:nvPr/>
         </p:nvSpPr>
         <p:spPr>
           <a:xfrm>
-            <a:off x="914400" y="1280160"/>
-            <a:ext cx="10424160" cy="1616949"/>
+            <a:off x="822960" y="1371600"/>
+            <a:ext cx="3474720" cy="2194560"/>
           </a:xfrm>
           <a:prstGeom prst="roundRect">
             <a:avLst/>
@@ -4509,175 +4338,49 @@
             </a:solidFill>
           </a:ln>
         </p:spPr>
-        <p:style>
-          <a:lnRef idx="1">
-            <a:schemeClr val="accent1"/>
-          </a:lnRef>
-          <a:fillRef idx="3">
-            <a:schemeClr val="accent1"/>
-          </a:fillRef>
-          <a:effectRef idx="2">
-            <a:schemeClr val="accent1"/>
-          </a:effectRef>
-          <a:fontRef idx="minor">
-            <a:schemeClr val="lt1"/>
-          </a:fontRef>
-        </p:style>
-        <p:txBody>
-          <a:bodyPr lIns="182880" tIns="109728" rIns="182880" rtlCol="0" anchor="ctr"/>
-          <a:lstStyle/>
-          <a:p>
-            <a:pPr algn="ctr">
-              <a:defRPr sz="2200">
+        <p:txBody>
+          <a:bodyPr lIns="137160" tIns="137160" rIns="137160" bIns="137160" rtlCol="0" anchor="t"/>
+          <a:lstStyle/>
+          <a:p>
+            <a:pPr algn="l">
+              <a:defRPr sz="1750"/>
+            </a:pPr>
+            <a:r>
+              <a:rPr sz="1750" b="1" dirty="0">
+                <a:solidFill>
+                  <a:srgbClr val="0B2F5B"/>
+                </a:solidFill>
+                <a:latin typeface="Aptos"/>
+              </a:rPr>
+              <a:t>Embedding table</a:t>
+            </a:r>
+          </a:p>
+          <a:p>
+            <a:pPr algn="l">
+              <a:defRPr sz="1550"/>
+            </a:pPr>
+            <a:r>
+              <a:rPr sz="1550" dirty="0">
                 <a:solidFill>
                   <a:srgbClr val="172B4D"/>
                 </a:solidFill>
-                <a:latin typeface="Consolas"/>
-              </a:defRPr>
-            </a:pPr>
-            <a:r>
-              <a:rPr dirty="0"/>
-              <a:t>1 -&gt; [ 0.21, -0.44,  0.78,  0.12]</a:t>
-            </a:r>
-            <a:br>
-              <a:rPr dirty="0"/>
-            </a:br>
-            <a:r>
-              <a:rPr dirty="0"/>
-              <a:t>2 -&gt; [ 0.03,  0.91, -0.14,  0.36]</a:t>
-            </a:r>
-            <a:br>
-              <a:rPr dirty="0"/>
-            </a:br>
-            <a:r>
-              <a:rPr dirty="0"/>
-              <a:t>3 -&gt; [-0.62,  0.18,  0.45, -0.09]</a:t>
-            </a:r>
-          </a:p>
-        </p:txBody>
-      </p:sp>
-      <p:sp>
-        <p:nvSpPr>
-          <p:cNvPr id="5" name="Rounded Rectangle 4"/>
+                <a:latin typeface="Aptos"/>
+              </a:rPr>
+              <a:t>An embedding table is a matrix learned during training. Each token ID selects one row from that matrix.</a:t>
+            </a:r>
+          </a:p>
+        </p:txBody>
+      </p:sp>
+      <p:sp>
+        <p:nvSpPr>
+          <p:cNvPr id="5" name="Example Table"/>
           <p:cNvSpPr/>
           <p:nvPr/>
         </p:nvSpPr>
         <p:spPr>
           <a:xfrm>
-            <a:off x="868680" y="5288128"/>
-            <a:ext cx="10424160" cy="1097280"/>
-          </a:xfrm>
-          <a:prstGeom prst="roundRect">
-            <a:avLst/>
-          </a:prstGeom>
-          <a:solidFill>
-            <a:srgbClr val="EAF3FF"/>
-          </a:solidFill>
-          <a:ln w="19050">
-            <a:solidFill>
-              <a:srgbClr val="0B5CAD"/>
-            </a:solidFill>
-          </a:ln>
-        </p:spPr>
-        <p:style>
-          <a:lnRef idx="1">
-            <a:schemeClr val="accent1"/>
-          </a:lnRef>
-          <a:fillRef idx="3">
-            <a:schemeClr val="accent1"/>
-          </a:fillRef>
-          <a:effectRef idx="2">
-            <a:schemeClr val="accent1"/>
-          </a:effectRef>
-          <a:fontRef idx="minor">
-            <a:schemeClr val="lt1"/>
-          </a:fontRef>
-        </p:style>
-        <p:txBody>
-          <a:bodyPr lIns="137160" tIns="91440" rIns="137160" rtlCol="0" anchor="ctr"/>
-          <a:lstStyle/>
-          <a:p>
-            <a:pPr algn="ctr">
-              <a:defRPr sz="1900" b="1">
-                <a:solidFill>
-                  <a:srgbClr val="0B2F5B"/>
-                </a:solidFill>
-              </a:defRPr>
-            </a:pPr>
-            <a:r>
-              <a:rPr lang="en-US" dirty="0"/>
-              <a:t>Key takeaway</a:t>
-            </a:r>
-          </a:p>
-          <a:p>
-            <a:pPr>
-              <a:spcAft>
-                <a:spcPts val="200"/>
-              </a:spcAft>
-              <a:defRPr sz="1800">
-                <a:solidFill>
-                  <a:srgbClr val="172B4D"/>
-                </a:solidFill>
-              </a:defRPr>
-            </a:pPr>
-            <a:r>
-              <a:rPr dirty="0"/>
-              <a:t>The token ID is an index. It selects a row from the embedding matrix. The selected row is the token vector.</a:t>
-            </a:r>
-          </a:p>
-        </p:txBody>
-      </p:sp>
-      <p:sp>
-        <p:nvSpPr>
-          <p:cNvPr id="6" name="TextBox 5"/>
-          <p:cNvSpPr txBox="1"/>
-          <p:nvPr/>
-        </p:nvSpPr>
-        <p:spPr>
-          <a:xfrm>
-            <a:off x="320040" y="6473952"/>
-            <a:ext cx="11521440" cy="228600"/>
-          </a:xfrm>
-          <a:prstGeom prst="rect">
-            <a:avLst/>
-          </a:prstGeom>
-          <a:noFill/>
-        </p:spPr>
-        <p:txBody>
-          <a:bodyPr wrap="none">
-            <a:spAutoFit/>
-          </a:bodyPr>
-          <a:lstStyle/>
-          <a:p>
-            <a:pPr>
-              <a:defRPr sz="900">
-                <a:solidFill>
-                  <a:srgbClr val="52616B"/>
-                </a:solidFill>
-              </a:defRPr>
-            </a:pPr>
-            <a:r>
-              <a:t>AI Under the hood | Slide 12</a:t>
-            </a:r>
-          </a:p>
-        </p:txBody>
-      </p:sp>
-      <p:sp>
-        <p:nvSpPr>
-          <p:cNvPr id="7" name="Rounded Rectangle 3">
-            <a:extLst>
-              <a:ext uri="{FF2B5EF4-FFF2-40B4-BE49-F238E27FC236}">
-                <a16:creationId xmlns:a16="http://schemas.microsoft.com/office/drawing/2014/main" id="{4D62C980-9521-DFEE-0DCD-FEEC67E8FE40}"/>
-              </a:ext>
-            </a:extLst>
-          </p:cNvPr>
-          <p:cNvSpPr/>
-          <p:nvPr/>
-        </p:nvSpPr>
-        <p:spPr>
-          <a:xfrm>
-            <a:off x="883920" y="3307531"/>
-            <a:ext cx="10424160" cy="1616949"/>
+            <a:off x="4846320" y="1188720"/>
+            <a:ext cx="5760720" cy="2560320"/>
           </a:xfrm>
           <a:prstGeom prst="roundRect">
             <a:avLst/>
@@ -4691,53 +4394,319 @@
             </a:solidFill>
           </a:ln>
         </p:spPr>
-        <p:style>
-          <a:lnRef idx="1">
-            <a:schemeClr val="accent1"/>
-          </a:lnRef>
-          <a:fillRef idx="3">
-            <a:schemeClr val="accent1"/>
-          </a:fillRef>
-          <a:effectRef idx="2">
-            <a:schemeClr val="accent1"/>
-          </a:effectRef>
-          <a:fontRef idx="minor">
-            <a:schemeClr val="lt1"/>
-          </a:fontRef>
-        </p:style>
-        <p:txBody>
-          <a:bodyPr lIns="182880" tIns="109728" rIns="182880" rtlCol="0" anchor="ctr"/>
+        <p:txBody>
+          <a:bodyPr lIns="137160" tIns="137160" rIns="137160" bIns="137160" rtlCol="0" anchor="t"/>
+          <a:lstStyle/>
+          <a:p>
+            <a:pPr algn="l">
+              <a:defRPr sz="1750"/>
+            </a:pPr>
+            <a:r>
+              <a:rPr sz="1750" b="1" dirty="0">
+                <a:solidFill>
+                  <a:srgbClr val="0B2F5B"/>
+                </a:solidFill>
+                <a:latin typeface="Aptos"/>
+              </a:rPr>
+              <a:t>Tiny example</a:t>
+            </a:r>
+          </a:p>
+          <a:p>
+            <a:pPr algn="l">
+              <a:defRPr sz="1500"/>
+            </a:pPr>
+            <a:r>
+              <a:rPr sz="1500" dirty="0">
+                <a:solidFill>
+                  <a:srgbClr val="172B4D"/>
+                </a:solidFill>
+                <a:latin typeface="Consolas"/>
+              </a:rPr>
+              <a:t>ID   token      vector row</a:t>
+            </a:r>
+          </a:p>
+          <a:p>
+            <a:pPr algn="l">
+              <a:defRPr sz="1500"/>
+            </a:pPr>
+            <a:r>
+              <a:rPr sz="1500" dirty="0">
+                <a:solidFill>
+                  <a:srgbClr val="172B4D"/>
+                </a:solidFill>
+                <a:latin typeface="Consolas"/>
+              </a:rPr>
+              <a:t>1    are        [ 0.21, -0.44,  0.78,  0.12]</a:t>
+            </a:r>
+          </a:p>
+          <a:p>
+            <a:pPr algn="l">
+              <a:defRPr sz="1500"/>
+            </a:pPr>
+            <a:r>
+              <a:rPr sz="1500" dirty="0">
+                <a:solidFill>
+                  <a:srgbClr val="172B4D"/>
+                </a:solidFill>
+                <a:latin typeface="Consolas"/>
+              </a:rPr>
+              <a:t>2    MAG        [ 0.03,  0.91, -0.14,  0.36]</a:t>
+            </a:r>
+          </a:p>
+          <a:p>
+            <a:pPr algn="l">
+              <a:defRPr sz="1500"/>
+            </a:pPr>
+            <a:r>
+              <a:rPr sz="1500" dirty="0">
+                <a:solidFill>
+                  <a:srgbClr val="172B4D"/>
+                </a:solidFill>
+                <a:latin typeface="Consolas"/>
+              </a:rPr>
+              <a:t>3    sales      [-0.62,  0.18,  0.45, -0.09]</a:t>
+            </a:r>
+          </a:p>
+        </p:txBody>
+      </p:sp>
+      <p:sp>
+        <p:nvSpPr>
+          <p:cNvPr id="6" name="Key takeaway"/>
+          <p:cNvSpPr/>
+          <p:nvPr/>
+        </p:nvSpPr>
+        <p:spPr>
+          <a:xfrm>
+            <a:off x="822960" y="5577840"/>
+            <a:ext cx="9966960" cy="914400"/>
+          </a:xfrm>
+          <a:prstGeom prst="roundRect">
+            <a:avLst/>
+          </a:prstGeom>
+          <a:solidFill>
+            <a:srgbClr val="FFFFFF"/>
+          </a:solidFill>
+          <a:ln>
+            <a:solidFill>
+              <a:srgbClr val="0B5CAD"/>
+            </a:solidFill>
+          </a:ln>
+        </p:spPr>
+        <p:txBody>
+          <a:bodyPr lIns="91440" tIns="91440" rIns="91440" bIns="91440" rtlCol="0" anchor="ctr"/>
           <a:lstStyle/>
           <a:p>
             <a:pPr algn="ctr">
-              <a:defRPr sz="2200">
+              <a:defRPr sz="1850"/>
+            </a:pPr>
+            <a:r>
+              <a:rPr sz="1850" b="1" dirty="0">
+                <a:solidFill>
+                  <a:srgbClr val="0B2F5B"/>
+                </a:solidFill>
+                <a:latin typeface="Aptos"/>
+              </a:rPr>
+              <a:t>Key takeaway</a:t>
+            </a:r>
+          </a:p>
+          <a:p>
+            <a:pPr algn="ctr">
+              <a:defRPr sz="1700"/>
+            </a:pPr>
+            <a:r>
+              <a:rPr sz="1700" dirty="0">
                 <a:solidFill>
                   <a:srgbClr val="172B4D"/>
                 </a:solidFill>
-                <a:latin typeface="Consolas"/>
-              </a:defRPr>
-            </a:pPr>
-            <a:r>
-              <a:rPr lang="en-US" dirty="0"/>
-              <a:t>Conceptually: </a:t>
-            </a:r>
-            <a:r>
-              <a:rPr lang="en-US" dirty="0" err="1"/>
-              <a:t>EmbeddingMatrix</a:t>
-            </a:r>
-            <a:r>
-              <a:rPr lang="en-US" dirty="0"/>
-              <a:t>[ </a:t>
-            </a:r>
-            <a:r>
-              <a:rPr lang="en-US" dirty="0" err="1"/>
-              <a:t>token_id</a:t>
-            </a:r>
-            <a:r>
-              <a:rPr lang="en-US" dirty="0"/>
-              <a:t> ] returns a vector</a:t>
-            </a:r>
-            <a:endParaRPr dirty="0"/>
+                <a:highlight>
+                  <a:srgbClr val="FFFF00"/>
+                </a:highlight>
+                <a:latin typeface="Aptos"/>
+              </a:rPr>
+              <a:t>During inference, we do not calculate these numbers from spelling. </a:t>
+            </a:r>
+            <a:r>
+              <a:rPr sz="1700" dirty="0">
+                <a:solidFill>
+                  <a:srgbClr val="172B4D"/>
+                </a:solidFill>
+                <a:latin typeface="Aptos"/>
+              </a:rPr>
+              <a:t>We look up the learned row.</a:t>
+            </a:r>
+          </a:p>
+        </p:txBody>
+      </p:sp>
+      <p:sp>
+        <p:nvSpPr>
+          <p:cNvPr id="40" name="Footer"/>
+          <p:cNvSpPr/>
+          <p:nvPr/>
+        </p:nvSpPr>
+        <p:spPr>
+          <a:xfrm>
+            <a:off x="320040" y="6473952"/>
+            <a:ext cx="11521440" cy="228600"/>
+          </a:xfrm>
+          <a:prstGeom prst="rect">
+            <a:avLst/>
+          </a:prstGeom>
+          <a:noFill/>
+          <a:ln/>
+        </p:spPr>
+        <p:txBody>
+          <a:bodyPr lIns="0" tIns="0" rIns="0" bIns="0" rtlCol="0" anchor="t"/>
+          <a:lstStyle/>
+          <a:p>
+            <a:pPr algn="r">
+              <a:defRPr sz="850"/>
+            </a:pPr>
+            <a:r>
+              <a:rPr sz="850" dirty="0">
+                <a:solidFill>
+                  <a:srgbClr val="6B778C"/>
+                </a:solidFill>
+                <a:latin typeface="Aptos"/>
+              </a:rPr>
+              <a:t>AI Under the hood | Slide 10</a:t>
+            </a:r>
+          </a:p>
+        </p:txBody>
+      </p:sp>
+      <p:sp>
+        <p:nvSpPr>
+          <p:cNvPr id="9" name="Definition">
+            <a:extLst>
+              <a:ext uri="{FF2B5EF4-FFF2-40B4-BE49-F238E27FC236}">
+                <a16:creationId xmlns:a16="http://schemas.microsoft.com/office/drawing/2014/main" id="{0FCD2D10-DB6A-EBB2-1E45-F3B0AF2ABB4B}"/>
+              </a:ext>
+            </a:extLst>
+          </p:cNvPr>
+          <p:cNvSpPr/>
+          <p:nvPr/>
+        </p:nvSpPr>
+        <p:spPr>
+          <a:xfrm>
+            <a:off x="822959" y="3831882"/>
+            <a:ext cx="9784081" cy="1654518"/>
+          </a:xfrm>
+          <a:prstGeom prst="roundRect">
+            <a:avLst/>
+          </a:prstGeom>
+          <a:solidFill>
+            <a:srgbClr val="F5F8FC"/>
+          </a:solidFill>
+          <a:ln>
+            <a:solidFill>
+              <a:srgbClr val="BED2E6"/>
+            </a:solidFill>
+          </a:ln>
+        </p:spPr>
+        <p:txBody>
+          <a:bodyPr lIns="137160" tIns="137160" rIns="137160" bIns="137160" rtlCol="0" anchor="t"/>
+          <a:lstStyle/>
+          <a:p>
+            <a:pPr algn="l">
+              <a:defRPr sz="1750"/>
+            </a:pPr>
+            <a:r>
+              <a:rPr lang="en-US" sz="1550" dirty="0">
+                <a:solidFill>
+                  <a:srgbClr val="0B2F5B"/>
+                </a:solidFill>
+                <a:latin typeface="Aptos" panose="020B0004020202020204" pitchFamily="34" charset="0"/>
+              </a:rPr>
+              <a:t>A neural network contains a gigantic Embedding table matrix</a:t>
+            </a:r>
+          </a:p>
+          <a:p>
+            <a:pPr algn="l">
+              <a:defRPr sz="1750"/>
+            </a:pPr>
+            <a:endParaRPr lang="en-US" sz="1550" dirty="0">
+              <a:solidFill>
+                <a:srgbClr val="0B2F5B"/>
+              </a:solidFill>
+              <a:latin typeface="Aptos" panose="020B0004020202020204" pitchFamily="34" charset="0"/>
+            </a:endParaRPr>
+          </a:p>
+          <a:p>
+            <a:pPr algn="l">
+              <a:defRPr sz="1750"/>
+            </a:pPr>
+            <a:r>
+              <a:rPr lang="en-US" sz="1550" dirty="0">
+                <a:solidFill>
+                  <a:srgbClr val="0B2F5B"/>
+                </a:solidFill>
+                <a:latin typeface="Aptos" panose="020B0004020202020204" pitchFamily="34" charset="0"/>
+              </a:rPr>
+              <a:t>Example dimensions:  Vocabulary size * Embedding dimension</a:t>
+            </a:r>
+          </a:p>
+          <a:p>
+            <a:pPr algn="l">
+              <a:defRPr sz="1750"/>
+            </a:pPr>
+            <a:r>
+              <a:rPr lang="en-US" sz="1550" dirty="0">
+                <a:solidFill>
+                  <a:srgbClr val="0B2F5B"/>
+                </a:solidFill>
+                <a:latin typeface="Aptos" panose="020B0004020202020204" pitchFamily="34" charset="0"/>
+              </a:rPr>
+              <a:t>GPT4                                            100,256          *               1,536</a:t>
+            </a:r>
+          </a:p>
+          <a:p>
+            <a:pPr algn="l">
+              <a:defRPr sz="1750"/>
+            </a:pPr>
+            <a:endParaRPr lang="en-US" sz="1550" dirty="0">
+              <a:solidFill>
+                <a:srgbClr val="0B2F5B"/>
+              </a:solidFill>
+              <a:latin typeface="Aptos" panose="020B0004020202020204" pitchFamily="34" charset="0"/>
+            </a:endParaRPr>
+          </a:p>
+          <a:p>
+            <a:pPr algn="l">
+              <a:defRPr sz="1750"/>
+            </a:pPr>
+            <a:r>
+              <a:rPr lang="en-US" sz="1550" dirty="0">
+                <a:solidFill>
+                  <a:srgbClr val="0B2F5B"/>
+                </a:solidFill>
+                <a:latin typeface="Aptos" panose="020B0004020202020204" pitchFamily="34" charset="0"/>
+              </a:rPr>
+              <a:t>Meaning: each token is represented by 1,536 floating point numbers</a:t>
+            </a:r>
+            <a:endParaRPr lang="en-US" sz="1550" dirty="0">
+              <a:latin typeface="Aptos" panose="020B0004020202020204" pitchFamily="34" charset="0"/>
+            </a:endParaRPr>
+          </a:p>
+          <a:p>
+            <a:pPr algn="l">
+              <a:defRPr sz="1750"/>
+            </a:pPr>
+            <a:endParaRPr sz="1750" dirty="0">
+              <a:solidFill>
+                <a:srgbClr val="0B2F5B"/>
+              </a:solidFill>
+              <a:latin typeface="Aptos"/>
+            </a:endParaRPr>
+          </a:p>
+          <a:p>
+            <a:pPr algn="l">
+              <a:defRPr sz="1550"/>
+            </a:pPr>
+            <a:endParaRPr sz="1550" dirty="0">
+              <a:solidFill>
+                <a:srgbClr val="172B4D"/>
+              </a:solidFill>
+              <a:latin typeface="Aptos"/>
+            </a:endParaRPr>
           </a:p>
         </p:txBody>
       </p:sp>
@@ -4769,13 +4738,13 @@
       <p:sp>
         <p:nvSpPr>
           <p:cNvPr id="2" name="Title"/>
-          <p:cNvSpPr/>
-          <p:nvPr/>
-        </p:nvSpPr>
-        <p:spPr>
-          <a:xfrm>
-            <a:off x="640080" y="365760"/>
-            <a:ext cx="10911840" cy="548640"/>
+          <p:cNvSpPr txBox="1"/>
+          <p:nvPr/>
+        </p:nvSpPr>
+        <p:spPr>
+          <a:xfrm>
+            <a:off x="548640" y="274320"/>
+            <a:ext cx="11125200" cy="548640"/>
           </a:xfrm>
           <a:prstGeom prst="rect">
             <a:avLst/>
@@ -4788,16 +4757,16 @@
           <a:lstStyle/>
           <a:p>
             <a:pPr algn="l">
-              <a:defRPr sz="3000"/>
-            </a:pPr>
-            <a:r>
-              <a:rPr sz="3000" b="1" dirty="0">
+              <a:defRPr sz="2600"/>
+            </a:pPr>
+            <a:r>
+              <a:rPr sz="2600" b="1" dirty="0">
                 <a:solidFill>
                   <a:srgbClr val="0B2F5B"/>
                 </a:solidFill>
                 <a:latin typeface="Aptos"/>
               </a:rPr>
-              <a:t>What Is a Vector?</a:t>
+              <a:t>Embeddings: Learned Geometric Coordinates of Meaning</a:t>
             </a:r>
           </a:p>
         </p:txBody>
@@ -4805,13 +4774,13 @@
       <p:sp>
         <p:nvSpPr>
           <p:cNvPr id="3" name="Subtitle"/>
-          <p:cNvSpPr/>
-          <p:nvPr/>
-        </p:nvSpPr>
-        <p:spPr>
-          <a:xfrm>
-            <a:off x="640080" y="868680"/>
-            <a:ext cx="10911840" cy="365760"/>
+          <p:cNvSpPr txBox="1"/>
+          <p:nvPr/>
+        </p:nvSpPr>
+        <p:spPr>
+          <a:xfrm>
+            <a:off x="594360" y="777240"/>
+            <a:ext cx="10820400" cy="365760"/>
           </a:xfrm>
           <a:prstGeom prst="rect">
             <a:avLst/>
@@ -4824,30 +4793,51 @@
           <a:lstStyle/>
           <a:p>
             <a:pPr algn="l">
-              <a:defRPr sz="1600"/>
-            </a:pPr>
-            <a:r>
-              <a:rPr sz="1600" dirty="0">
-                <a:solidFill>
-                  <a:srgbClr val="5E6C84"/>
-                </a:solidFill>
-                <a:latin typeface="Aptos"/>
-              </a:rPr>
-              <a:t>A compact list of numbers the neural network can compute with</a:t>
-            </a:r>
-          </a:p>
-        </p:txBody>
-      </p:sp>
-      <p:sp>
-        <p:nvSpPr>
-          <p:cNvPr id="4" name="Vector"/>
+              <a:defRPr sz="1550"/>
+            </a:pPr>
+            <a:r>
+              <a:rPr sz="1550" dirty="0">
+                <a:solidFill>
+                  <a:srgbClr val="52616B"/>
+                </a:solidFill>
+                <a:latin typeface="Aptos"/>
+              </a:rPr>
+              <a:t>Training turns random vectors into a map where </a:t>
+            </a:r>
+            <a:r>
+              <a:rPr sz="1550" dirty="0">
+                <a:solidFill>
+                  <a:srgbClr val="52616B"/>
+                </a:solidFill>
+                <a:highlight>
+                  <a:srgbClr val="FFFF00"/>
+                </a:highlight>
+                <a:latin typeface="Aptos"/>
+              </a:rPr>
+              <a:t>distance carries semantics</a:t>
+            </a:r>
+            <a:r>
+              <a:rPr sz="1550" dirty="0">
+                <a:solidFill>
+                  <a:srgbClr val="52616B"/>
+                </a:solidFill>
+                <a:latin typeface="Aptos"/>
+              </a:rPr>
+              <a:t>.</a:t>
+            </a:r>
+          </a:p>
+        </p:txBody>
+      </p:sp>
+      <p:sp>
+        <p:nvSpPr>
+          <p:cNvPr id="4" name="Initially Random"/>
           <p:cNvSpPr/>
           <p:nvPr/>
         </p:nvSpPr>
         <p:spPr>
           <a:xfrm>
-            <a:off x="822960" y="1371600"/>
-            <a:ext cx="3474720" cy="2194560"/>
+            <a:off x="640080" y="1280160"/>
+            <a:ext cx="3291840" cy="1737360"/>
           </a:xfrm>
           <a:prstGeom prst="roundRect">
             <a:avLst/>
@@ -4862,62 +4852,68 @@
           </a:ln>
         </p:spPr>
         <p:txBody>
-          <a:bodyPr lIns="137160" tIns="137160" rIns="137160" bIns="137160" rtlCol="0" anchor="t"/>
+          <a:bodyPr lIns="91440" tIns="91440" rIns="91440" bIns="91440" rtlCol="0" anchor="t"/>
           <a:lstStyle/>
           <a:p>
             <a:pPr algn="l">
-              <a:defRPr sz="1750"/>
-            </a:pPr>
-            <a:r>
-              <a:rPr sz="1750" b="1" dirty="0">
+              <a:defRPr sz="1700"/>
+            </a:pPr>
+            <a:r>
+              <a:rPr sz="1700" b="1" dirty="0">
                 <a:solidFill>
                   <a:srgbClr val="0B2F5B"/>
                 </a:solidFill>
                 <a:latin typeface="Aptos"/>
               </a:rPr>
-              <a:t>Vector</a:t>
+              <a:t>Initially</a:t>
             </a:r>
           </a:p>
           <a:p>
             <a:pPr algn="l">
-              <a:defRPr sz="1500"/>
-            </a:pPr>
-            <a:r>
-              <a:rPr sz="1500" dirty="0">
+              <a:defRPr sz="1250"/>
+            </a:pPr>
+            <a:r>
+              <a:rPr sz="1250" dirty="0">
                 <a:solidFill>
                   <a:srgbClr val="172B4D"/>
                 </a:solidFill>
                 <a:latin typeface="Consolas"/>
               </a:rPr>
-              <a:t>sales vector:</a:t>
-            </a:r>
-          </a:p>
-          <a:p>
-            <a:pPr algn="l">
-              <a:defRPr sz="1500"/>
-            </a:pPr>
-            <a:r>
-              <a:rPr sz="1500" dirty="0">
+              <a:t>MAG     = [random garbage]</a:t>
+            </a:r>
+            <a:br/>
+            <a:r>
+              <a:rPr sz="1250" dirty="0">
                 <a:solidFill>
                   <a:srgbClr val="172B4D"/>
                 </a:solidFill>
                 <a:latin typeface="Consolas"/>
               </a:rPr>
-              <a:t>[-0.62, 0.18, 0.45, -0.09]</a:t>
-            </a:r>
-          </a:p>
-        </p:txBody>
-      </p:sp>
-      <p:sp>
-        <p:nvSpPr>
-          <p:cNvPr id="5" name="Algorithm"/>
+              <a:t>sales   = [random garbage]</a:t>
+            </a:r>
+            <a:br/>
+            <a:r>
+              <a:rPr sz="1250" dirty="0">
+                <a:solidFill>
+                  <a:srgbClr val="172B4D"/>
+                </a:solidFill>
+                <a:latin typeface="Consolas"/>
+              </a:rPr>
+              <a:t>Chicago = [random garbage]</a:t>
+            </a:r>
+          </a:p>
+        </p:txBody>
+      </p:sp>
+      <p:sp>
+        <p:nvSpPr>
+          <p:cNvPr id="5" name="Training Contexts"/>
           <p:cNvSpPr/>
           <p:nvPr/>
         </p:nvSpPr>
         <p:spPr>
           <a:xfrm>
-            <a:off x="4846320" y="1188720"/>
-            <a:ext cx="5760720" cy="2377440"/>
+            <a:off x="4389120" y="1280160"/>
+            <a:ext cx="3200400" cy="1737360"/>
           </a:xfrm>
           <a:prstGeom prst="roundRect">
             <a:avLst/>
@@ -4932,114 +4928,84 @@
           </a:ln>
         </p:spPr>
         <p:txBody>
-          <a:bodyPr lIns="137160" tIns="137160" rIns="137160" bIns="137160" rtlCol="0" anchor="t"/>
+          <a:bodyPr lIns="91440" tIns="91440" rIns="91440" bIns="91440" rtlCol="0" anchor="t"/>
           <a:lstStyle/>
           <a:p>
             <a:pPr algn="l">
-              <a:defRPr sz="1750"/>
-            </a:pPr>
-            <a:r>
-              <a:rPr sz="1750" b="1" dirty="0">
+              <a:defRPr sz="1700"/>
+            </a:pPr>
+            <a:r>
+              <a:rPr sz="1700" b="1" dirty="0">
                 <a:solidFill>
                   <a:srgbClr val="0B2F5B"/>
                 </a:solidFill>
                 <a:latin typeface="Aptos"/>
               </a:rPr>
-              <a:t>Demo algorithm for sales</a:t>
+              <a:t>During training</a:t>
             </a:r>
           </a:p>
           <a:p>
             <a:pPr algn="l">
-              <a:defRPr sz="1500"/>
-            </a:pPr>
-            <a:r>
-              <a:rPr sz="1500" dirty="0">
+              <a:defRPr sz="1350"/>
+            </a:pPr>
+            <a:r>
+              <a:rPr sz="1350" dirty="0">
                 <a:solidFill>
                   <a:srgbClr val="172B4D"/>
                 </a:solidFill>
                 <a:latin typeface="Consolas"/>
               </a:rPr>
-              <a:t>1. Token: "sales"</a:t>
-            </a:r>
-          </a:p>
-          <a:p>
-            <a:pPr algn="l">
-              <a:defRPr sz="1500"/>
-            </a:pPr>
-            <a:r>
-              <a:rPr sz="1500" dirty="0">
+              <a:t>sales up</a:t>
+            </a:r>
+            <a:br/>
+            <a:r>
+              <a:rPr sz="1350" dirty="0">
                 <a:solidFill>
                   <a:srgbClr val="172B4D"/>
                 </a:solidFill>
                 <a:latin typeface="Consolas"/>
               </a:rPr>
-              <a:t>2. Vocabulary lookup: "sales" -&gt; 3</a:t>
-            </a:r>
-          </a:p>
-          <a:p>
-            <a:pPr algn="l">
-              <a:defRPr sz="1500"/>
-            </a:pPr>
-            <a:r>
-              <a:rPr sz="1500" dirty="0">
+              <a:t>sales increased</a:t>
+            </a:r>
+            <a:br/>
+            <a:r>
+              <a:rPr sz="1350" dirty="0">
                 <a:solidFill>
                   <a:srgbClr val="172B4D"/>
                 </a:solidFill>
                 <a:latin typeface="Consolas"/>
               </a:rPr>
-              <a:t>3. Embedding lookup: E[3]</a:t>
-            </a:r>
-          </a:p>
-          <a:p>
-            <a:pPr algn="l">
-              <a:defRPr sz="1500"/>
-            </a:pPr>
-            <a:r>
-              <a:rPr sz="1500" dirty="0">
+              <a:t>revenue growth</a:t>
+            </a:r>
+            <a:br/>
+            <a:r>
+              <a:rPr sz="1350" dirty="0">
                 <a:solidFill>
                   <a:srgbClr val="172B4D"/>
                 </a:solidFill>
                 <a:latin typeface="Consolas"/>
               </a:rPr>
-              <a:t>4. Output</a:t>
-            </a:r>
-            <a:r>
-              <a:rPr lang="en-US" sz="1500" dirty="0">
-                <a:solidFill>
-                  <a:srgbClr val="172B4D"/>
-                </a:solidFill>
-                <a:latin typeface="Consolas"/>
-              </a:rPr>
-              <a:t> Vector</a:t>
-            </a:r>
-            <a:r>
-              <a:rPr sz="1500" dirty="0">
-                <a:solidFill>
-                  <a:srgbClr val="172B4D"/>
-                </a:solidFill>
-                <a:latin typeface="Consolas"/>
-              </a:rPr>
-              <a:t>: [-0.62, 0.18, 0.45, -0.09]</a:t>
-            </a:r>
-          </a:p>
-        </p:txBody>
-      </p:sp>
-      <p:sp>
-        <p:nvSpPr>
-          <p:cNvPr id="6" name="Key takeaway"/>
+              <a:t>Chicago region</a:t>
+            </a:r>
+          </a:p>
+        </p:txBody>
+      </p:sp>
+      <p:sp>
+        <p:nvSpPr>
+          <p:cNvPr id="6" name="Geometry Meaning"/>
           <p:cNvSpPr/>
           <p:nvPr/>
         </p:nvSpPr>
         <p:spPr>
           <a:xfrm>
-            <a:off x="822960" y="4346840"/>
-            <a:ext cx="9966960" cy="1807072"/>
+            <a:off x="8138160" y="1280160"/>
+            <a:ext cx="3200400" cy="1737360"/>
           </a:xfrm>
           <a:prstGeom prst="roundRect">
             <a:avLst/>
           </a:prstGeom>
           <a:solidFill>
-            <a:srgbClr val="FFFFFF"/>
+            <a:srgbClr val="EAF3FF"/>
           </a:solidFill>
           <a:ln>
             <a:solidFill>
@@ -5048,129 +5014,304 @@
           </a:ln>
         </p:spPr>
         <p:txBody>
+          <a:bodyPr lIns="91440" tIns="91440" rIns="91440" bIns="91440" rtlCol="0" anchor="t"/>
+          <a:lstStyle/>
+          <a:p>
+            <a:pPr algn="l">
+              <a:defRPr sz="1700"/>
+            </a:pPr>
+            <a:r>
+              <a:rPr sz="1700" b="1" dirty="0">
+                <a:solidFill>
+                  <a:srgbClr val="0B2F5B"/>
+                </a:solidFill>
+                <a:latin typeface="Aptos"/>
+              </a:rPr>
+              <a:t>Backprop moves vectors</a:t>
+            </a:r>
+          </a:p>
+          <a:p>
+            <a:pPr algn="l">
+              <a:defRPr sz="1375"/>
+            </a:pPr>
+            <a:r>
+              <a:rPr sz="1375" dirty="0">
+                <a:solidFill>
+                  <a:srgbClr val="172B4D"/>
+                </a:solidFill>
+                <a:latin typeface="Aptos"/>
+              </a:rPr>
+              <a:t>similar words move closer</a:t>
+            </a:r>
+            <a:br/>
+            <a:r>
+              <a:rPr sz="1375" dirty="0">
+                <a:solidFill>
+                  <a:srgbClr val="172B4D"/>
+                </a:solidFill>
+                <a:latin typeface="Aptos"/>
+              </a:rPr>
+              <a:t>unrelated words move apart</a:t>
+            </a:r>
+            <a:br/>
+            <a:r>
+              <a:rPr sz="1375" dirty="0">
+                <a:solidFill>
+                  <a:srgbClr val="172B4D"/>
+                </a:solidFill>
+                <a:latin typeface="Aptos"/>
+              </a:rPr>
+              <a:t>geometry stores meaning</a:t>
+            </a:r>
+          </a:p>
+        </p:txBody>
+      </p:sp>
+      <p:sp>
+        <p:nvSpPr>
+          <p:cNvPr id="7" name="Visual Intuition"/>
+          <p:cNvSpPr/>
+          <p:nvPr/>
+        </p:nvSpPr>
+        <p:spPr>
+          <a:xfrm>
+            <a:off x="640080" y="3370320"/>
+            <a:ext cx="5029200" cy="2011680"/>
+          </a:xfrm>
+          <a:prstGeom prst="roundRect">
+            <a:avLst/>
+          </a:prstGeom>
+          <a:solidFill>
+            <a:srgbClr val="FFFFFF"/>
+          </a:solidFill>
+          <a:ln>
+            <a:solidFill>
+              <a:srgbClr val="BED2E6"/>
+            </a:solidFill>
+          </a:ln>
+        </p:spPr>
+        <p:txBody>
+          <a:bodyPr lIns="91440" tIns="91440" rIns="91440" bIns="91440" rtlCol="0" anchor="t"/>
+          <a:lstStyle/>
+          <a:p>
+            <a:pPr algn="l">
+              <a:defRPr sz="1650"/>
+            </a:pPr>
+            <a:r>
+              <a:rPr sz="1650" b="1" dirty="0">
+                <a:solidFill>
+                  <a:srgbClr val="0B2F5B"/>
+                </a:solidFill>
+                <a:latin typeface="Aptos"/>
+              </a:rPr>
+              <a:t>Visual intuition: distances encode relationships</a:t>
+            </a:r>
+          </a:p>
+          <a:p>
+            <a:pPr algn="l">
+              <a:defRPr sz="1250"/>
+            </a:pPr>
+            <a:r>
+              <a:rPr sz="1250" dirty="0">
+                <a:solidFill>
+                  <a:srgbClr val="172B4D"/>
+                </a:solidFill>
+                <a:latin typeface="Consolas"/>
+              </a:rPr>
+              <a:t>king   (2, 9, 4)    queen  (2, 9, 5)</a:t>
+            </a:r>
+            <a:br/>
+            <a:r>
+              <a:rPr sz="1250" dirty="0">
+                <a:solidFill>
+                  <a:srgbClr val="172B4D"/>
+                </a:solidFill>
+                <a:latin typeface="Consolas"/>
+              </a:rPr>
+              <a:t>man    (1, 4, 3)    woman  (1, 4, 4)</a:t>
+            </a:r>
+          </a:p>
+          <a:p>
+            <a:pPr algn="l">
+              <a:defRPr sz="1550"/>
+            </a:pPr>
+            <a:r>
+              <a:rPr sz="1550" b="1" dirty="0">
+                <a:solidFill>
+                  <a:srgbClr val="0B5CAD"/>
+                </a:solidFill>
+                <a:latin typeface="Consolas"/>
+              </a:rPr>
+              <a:t>king - man + woman ~= queen</a:t>
+            </a:r>
+          </a:p>
+        </p:txBody>
+      </p:sp>
+      <p:sp>
+        <p:nvSpPr>
+          <p:cNvPr id="8" name="Sentence Embeddings"/>
+          <p:cNvSpPr/>
+          <p:nvPr/>
+        </p:nvSpPr>
+        <p:spPr>
+          <a:xfrm>
+            <a:off x="5989320" y="3370320"/>
+            <a:ext cx="5394960" cy="2011680"/>
+          </a:xfrm>
+          <a:prstGeom prst="roundRect">
+            <a:avLst/>
+          </a:prstGeom>
+          <a:solidFill>
+            <a:srgbClr val="FFFFFF"/>
+          </a:solidFill>
+          <a:ln>
+            <a:solidFill>
+              <a:srgbClr val="BED2E6"/>
+            </a:solidFill>
+          </a:ln>
+        </p:spPr>
+        <p:txBody>
+          <a:bodyPr lIns="91440" tIns="91440" rIns="91440" bIns="91440" rtlCol="0" anchor="t"/>
+          <a:lstStyle/>
+          <a:p>
+            <a:pPr algn="l">
+              <a:defRPr sz="1650"/>
+            </a:pPr>
+            <a:r>
+              <a:rPr sz="1650" b="1" dirty="0">
+                <a:solidFill>
+                  <a:srgbClr val="0B2F5B"/>
+                </a:solidFill>
+                <a:latin typeface="Aptos"/>
+              </a:rPr>
+              <a:t>Sentence embeddings combine token vectors</a:t>
+            </a:r>
+          </a:p>
+          <a:p>
+            <a:pPr algn="l">
+              <a:defRPr sz="1250"/>
+            </a:pPr>
+            <a:r>
+              <a:rPr sz="1250" dirty="0">
+                <a:solidFill>
+                  <a:srgbClr val="172B4D"/>
+                </a:solidFill>
+                <a:latin typeface="Aptos"/>
+              </a:rPr>
+              <a:t>averaging | attention | transformers | pooling</a:t>
+            </a:r>
+          </a:p>
+          <a:p>
+            <a:pPr algn="l">
+              <a:defRPr sz="1200"/>
+            </a:pPr>
+            <a:r>
+              <a:rPr sz="1200" dirty="0">
+                <a:solidFill>
+                  <a:srgbClr val="172B4D"/>
+                </a:solidFill>
+                <a:latin typeface="Consolas"/>
+              </a:rPr>
+              <a:t>"MAG sales are up in Chicago"</a:t>
+            </a:r>
+            <a:br/>
+            <a:r>
+              <a:rPr sz="1200" dirty="0">
+                <a:solidFill>
+                  <a:srgbClr val="172B4D"/>
+                </a:solidFill>
+                <a:latin typeface="Consolas"/>
+              </a:rPr>
+              <a:t>-&gt; [0.192, -0.551, 0.882, ... 1536 dims ...]</a:t>
+            </a:r>
+          </a:p>
+          <a:p>
+            <a:pPr algn="l">
+              <a:defRPr sz="1225"/>
+            </a:pPr>
+            <a:r>
+              <a:rPr sz="1225" dirty="0">
+                <a:solidFill>
+                  <a:srgbClr val="52616B"/>
+                </a:solidFill>
+                <a:latin typeface="Aptos"/>
+              </a:rPr>
+              <a:t>captures business context, trend, location, and organization semantics</a:t>
+            </a:r>
+          </a:p>
+        </p:txBody>
+      </p:sp>
+      <p:sp>
+        <p:nvSpPr>
+          <p:cNvPr id="9" name="Why This Works"/>
+          <p:cNvSpPr/>
+          <p:nvPr/>
+        </p:nvSpPr>
+        <p:spPr>
+          <a:xfrm>
+            <a:off x="914400" y="5791200"/>
+            <a:ext cx="10393680" cy="548640"/>
+          </a:xfrm>
+          <a:prstGeom prst="roundRect">
+            <a:avLst/>
+          </a:prstGeom>
+          <a:solidFill>
+            <a:srgbClr val="F5F8FC"/>
+          </a:solidFill>
+          <a:ln>
+            <a:solidFill>
+              <a:srgbClr val="BED2E6"/>
+            </a:solidFill>
+          </a:ln>
+        </p:spPr>
+        <p:txBody>
           <a:bodyPr lIns="91440" tIns="91440" rIns="91440" bIns="91440" rtlCol="0" anchor="ctr"/>
           <a:lstStyle/>
           <a:p>
             <a:pPr algn="ctr">
-              <a:defRPr sz="1850"/>
-            </a:pPr>
-            <a:r>
-              <a:rPr sz="1850" b="1" dirty="0">
-                <a:solidFill>
-                  <a:srgbClr val="0B2F5B"/>
-                </a:solidFill>
-                <a:latin typeface="Aptos"/>
-              </a:rPr>
-              <a:t>Key takeaway</a:t>
-            </a:r>
-            <a:endParaRPr lang="en-US" sz="1850" b="1" dirty="0">
-              <a:solidFill>
-                <a:srgbClr val="0B2F5B"/>
-              </a:solidFill>
-              <a:latin typeface="Aptos"/>
-            </a:endParaRPr>
-          </a:p>
-          <a:p>
-            <a:pPr algn="ctr">
-              <a:defRPr sz="1700"/>
-            </a:pPr>
-            <a:r>
-              <a:rPr sz="1700" dirty="0">
+              <a:defRPr sz="1450"/>
+            </a:pPr>
+            <a:r>
+              <a:rPr sz="1450" b="1" dirty="0">
                 <a:solidFill>
                   <a:srgbClr val="172B4D"/>
                 </a:solidFill>
-                <a:latin typeface="Aptos"/>
-              </a:rPr>
-              <a:t>A vector is the numeric representation that moves forward. </a:t>
-            </a:r>
-            <a:endParaRPr lang="en-US" sz="1700" dirty="0">
+                <a:highlight>
+                  <a:srgbClr val="FFFF00"/>
+                </a:highlight>
+                <a:latin typeface="Aptos"/>
+              </a:rPr>
+              <a:t>Why it works: language has statistical structure. Context patterns -&gt; geometric relationships. </a:t>
+            </a:r>
+            <a:endParaRPr lang="en-US" sz="1450" b="1" dirty="0">
               <a:solidFill>
                 <a:srgbClr val="172B4D"/>
               </a:solidFill>
+              <a:highlight>
+                <a:srgbClr val="FFFF00"/>
+              </a:highlight>
               <a:latin typeface="Aptos"/>
             </a:endParaRPr>
           </a:p>
           <a:p>
             <a:pPr algn="ctr">
-              <a:defRPr sz="1700"/>
-            </a:pPr>
-            <a:r>
-              <a:rPr sz="1700" dirty="0">
+              <a:defRPr sz="1450"/>
+            </a:pPr>
+            <a:r>
+              <a:rPr sz="1450" dirty="0">
                 <a:solidFill>
                   <a:srgbClr val="172B4D"/>
                 </a:solidFill>
                 <a:latin typeface="Aptos"/>
               </a:rPr>
-              <a:t>The values are learned, then selected by ID.</a:t>
-            </a:r>
-            <a:endParaRPr lang="en-US" sz="1700" dirty="0">
-              <a:solidFill>
-                <a:srgbClr val="172B4D"/>
-              </a:solidFill>
-              <a:latin typeface="Aptos"/>
-            </a:endParaRPr>
-          </a:p>
-          <a:p>
-            <a:pPr algn="ctr">
-              <a:defRPr sz="1700"/>
-            </a:pPr>
-            <a:endParaRPr lang="en-US" sz="1700" dirty="0">
-              <a:solidFill>
-                <a:srgbClr val="172B4D"/>
-              </a:solidFill>
-              <a:latin typeface="Aptos"/>
-            </a:endParaRPr>
-          </a:p>
-          <a:p>
-            <a:pPr algn="ctr">
-              <a:defRPr sz="1700"/>
-            </a:pPr>
-            <a:r>
-              <a:rPr lang="en-US" sz="1700" dirty="0">
-                <a:solidFill>
-                  <a:srgbClr val="172B4D"/>
-                </a:solidFill>
-                <a:highlight>
-                  <a:srgbClr val="FFFF00"/>
-                </a:highlight>
-                <a:latin typeface="Aptos"/>
-              </a:rPr>
-              <a:t>The word “Sales” now is a </a:t>
-            </a:r>
-            <a:r>
-              <a:rPr lang="en-US" sz="1700" u="sng" dirty="0">
-                <a:solidFill>
-                  <a:srgbClr val="172B4D"/>
-                </a:solidFill>
-                <a:highlight>
-                  <a:srgbClr val="FFFF00"/>
-                </a:highlight>
-                <a:latin typeface="Aptos"/>
-              </a:rPr>
-              <a:t>point in multidimensional space</a:t>
-            </a:r>
-            <a:r>
-              <a:rPr lang="en-US" sz="1700" dirty="0">
-                <a:solidFill>
-                  <a:srgbClr val="172B4D"/>
-                </a:solidFill>
-                <a:latin typeface="Aptos"/>
-              </a:rPr>
-              <a:t>.</a:t>
-            </a:r>
-            <a:endParaRPr sz="1700" dirty="0">
-              <a:solidFill>
-                <a:srgbClr val="172B4D"/>
-              </a:solidFill>
-              <a:latin typeface="Aptos"/>
-            </a:endParaRPr>
-          </a:p>
-        </p:txBody>
-      </p:sp>
-      <p:sp>
-        <p:nvSpPr>
-          <p:cNvPr id="40" name="Footer"/>
-          <p:cNvSpPr/>
+              <a:t>Foundation for Word2Vec, GloVe, BERT, GPT, and LLMs.</a:t>
+            </a:r>
+          </a:p>
+        </p:txBody>
+      </p:sp>
+      <p:sp>
+        <p:nvSpPr>
+          <p:cNvPr id="10" name="Footer"/>
+          <p:cNvSpPr txBox="1"/>
           <p:nvPr/>
         </p:nvSpPr>
         <p:spPr>
@@ -5182,23 +5323,22 @@
             <a:avLst/>
           </a:prstGeom>
           <a:noFill/>
-          <a:ln/>
-        </p:spPr>
-        <p:txBody>
-          <a:bodyPr lIns="0" tIns="0" rIns="0" bIns="0" rtlCol="0" anchor="t"/>
-          <a:lstStyle/>
-          <a:p>
-            <a:pPr algn="r">
-              <a:defRPr sz="850"/>
-            </a:pPr>
-            <a:r>
-              <a:rPr sz="850" dirty="0">
-                <a:solidFill>
-                  <a:srgbClr val="6B778C"/>
-                </a:solidFill>
-                <a:latin typeface="Aptos"/>
-              </a:rPr>
-              <a:t>AI Under the hood | Slide 13</a:t>
+        </p:spPr>
+        <p:txBody>
+          <a:bodyPr wrap="none">
+            <a:spAutoFit/>
+          </a:bodyPr>
+          <a:lstStyle/>
+          <a:p>
+            <a:pPr>
+              <a:defRPr sz="900">
+                <a:solidFill>
+                  <a:srgbClr val="52616B"/>
+                </a:solidFill>
+              </a:defRPr>
+            </a:pPr>
+            <a:r>
+              <a:t>AI Under the hood | Slide 11</a:t>
             </a:r>
           </a:p>
         </p:txBody>
@@ -5237,7 +5377,7 @@
         <p:spPr>
           <a:xfrm>
             <a:off x="502920" y="320040"/>
-            <a:ext cx="5577745" cy="553998"/>
+            <a:ext cx="11247120" cy="548640"/>
           </a:xfrm>
           <a:prstGeom prst="rect">
             <a:avLst/>
@@ -5258,16 +5398,7 @@
               </a:defRPr>
             </a:pPr>
             <a:r>
-              <a:rPr dirty="0"/>
-              <a:t>How Token ID </a:t>
-            </a:r>
-            <a:r>
-              <a:rPr lang="en-US" dirty="0"/>
-              <a:t>3</a:t>
-            </a:r>
-            <a:r>
-              <a:rPr dirty="0"/>
-              <a:t> Becomes a Vector</a:t>
+              <a:t>Embedding Lookup</a:t>
             </a:r>
           </a:p>
         </p:txBody>
@@ -5302,7 +5433,7 @@
               </a:defRPr>
             </a:pPr>
             <a:r>
-              <a:t>The algorithm is a row lookup</a:t>
+              <a:t>Token IDs become vectors</a:t>
             </a:r>
           </a:p>
         </p:txBody>
@@ -5315,8 +5446,8 @@
         </p:nvSpPr>
         <p:spPr>
           <a:xfrm>
-            <a:off x="731289" y="1234440"/>
-            <a:ext cx="3062113" cy="914400"/>
+            <a:off x="914400" y="1280160"/>
+            <a:ext cx="10424160" cy="1616949"/>
           </a:xfrm>
           <a:prstGeom prst="roundRect">
             <a:avLst/>
@@ -5349,7 +5480,7 @@
           <a:lstStyle/>
           <a:p>
             <a:pPr algn="ctr">
-              <a:defRPr sz="2500">
+              <a:defRPr sz="2200">
                 <a:solidFill>
                   <a:srgbClr val="172B4D"/>
                 </a:solidFill>
@@ -5358,73 +5489,45 @@
             </a:pPr>
             <a:r>
               <a:rPr dirty="0"/>
-              <a:t>Token ID </a:t>
-            </a:r>
-            <a:r>
-              <a:rPr lang="en-US" dirty="0"/>
-              <a:t>3</a:t>
-            </a:r>
-            <a:endParaRPr dirty="0"/>
-          </a:p>
-        </p:txBody>
-      </p:sp>
-      <p:cxnSp>
-        <p:nvCxnSpPr>
-          <p:cNvPr id="5" name="Connector 4"/>
-          <p:cNvCxnSpPr>
-            <a:cxnSpLocks/>
-          </p:cNvCxnSpPr>
-          <p:nvPr/>
-        </p:nvCxnSpPr>
-        <p:spPr>
-          <a:xfrm>
-            <a:off x="3793402" y="1691640"/>
-            <a:ext cx="675640" cy="0"/>
-          </a:xfrm>
-          <a:prstGeom prst="line">
-            <a:avLst/>
-          </a:prstGeom>
-          <a:ln w="38100">
+              <a:t>1 -&gt; [ 0.21, -0.44,  0.78,  0.12]</a:t>
+            </a:r>
+            <a:br>
+              <a:rPr dirty="0"/>
+            </a:br>
+            <a:r>
+              <a:rPr dirty="0"/>
+              <a:t>2 -&gt; [ 0.03,  0.91, -0.14,  0.36]</a:t>
+            </a:r>
+            <a:br>
+              <a:rPr dirty="0"/>
+            </a:br>
+            <a:r>
+              <a:rPr dirty="0"/>
+              <a:t>3 -&gt; [-0.62,  0.18,  0.45, -0.09]</a:t>
+            </a:r>
+          </a:p>
+        </p:txBody>
+      </p:sp>
+      <p:sp>
+        <p:nvSpPr>
+          <p:cNvPr id="5" name="Rounded Rectangle 4"/>
+          <p:cNvSpPr/>
+          <p:nvPr/>
+        </p:nvSpPr>
+        <p:spPr>
+          <a:xfrm>
+            <a:off x="868680" y="5288128"/>
+            <a:ext cx="10424160" cy="1097280"/>
+          </a:xfrm>
+          <a:prstGeom prst="roundRect">
+            <a:avLst/>
+          </a:prstGeom>
+          <a:solidFill>
+            <a:srgbClr val="EAF3FF"/>
+          </a:solidFill>
+          <a:ln w="19050">
             <a:solidFill>
               <a:srgbClr val="0B5CAD"/>
-            </a:solidFill>
-          </a:ln>
-        </p:spPr>
-        <p:style>
-          <a:lnRef idx="2">
-            <a:schemeClr val="accent1"/>
-          </a:lnRef>
-          <a:fillRef idx="0">
-            <a:schemeClr val="accent1"/>
-          </a:fillRef>
-          <a:effectRef idx="1">
-            <a:schemeClr val="accent1"/>
-          </a:effectRef>
-          <a:fontRef idx="minor">
-            <a:schemeClr val="tx1"/>
-          </a:fontRef>
-        </p:style>
-      </p:cxnSp>
-      <p:sp>
-        <p:nvSpPr>
-          <p:cNvPr id="6" name="Rounded Rectangle 5"/>
-          <p:cNvSpPr/>
-          <p:nvPr/>
-        </p:nvSpPr>
-        <p:spPr>
-          <a:xfrm>
-            <a:off x="4496474" y="1234440"/>
-            <a:ext cx="2485901" cy="914400"/>
-          </a:xfrm>
-          <a:prstGeom prst="roundRect">
-            <a:avLst/>
-          </a:prstGeom>
-          <a:solidFill>
-            <a:srgbClr val="F5F8FC"/>
-          </a:solidFill>
-          <a:ln>
-            <a:solidFill>
-              <a:srgbClr val="BED2E6"/>
             </a:solidFill>
           </a:ln>
         </p:spPr>
@@ -5443,77 +5546,90 @@
           </a:fontRef>
         </p:style>
         <p:txBody>
-          <a:bodyPr lIns="182880" tIns="109728" rIns="182880" rtlCol="0" anchor="ctr"/>
+          <a:bodyPr lIns="137160" tIns="91440" rIns="137160" rtlCol="0" anchor="ctr"/>
           <a:lstStyle/>
           <a:p>
             <a:pPr algn="ctr">
-              <a:defRPr sz="2500">
+              <a:defRPr sz="1900" b="1">
+                <a:solidFill>
+                  <a:srgbClr val="0B2F5B"/>
+                </a:solidFill>
+              </a:defRPr>
+            </a:pPr>
+            <a:r>
+              <a:rPr lang="en-US" dirty="0"/>
+              <a:t>Key takeaway</a:t>
+            </a:r>
+          </a:p>
+          <a:p>
+            <a:pPr>
+              <a:spcAft>
+                <a:spcPts val="200"/>
+              </a:spcAft>
+              <a:defRPr sz="1800">
                 <a:solidFill>
                   <a:srgbClr val="172B4D"/>
                 </a:solidFill>
-                <a:latin typeface="Consolas"/>
               </a:defRPr>
             </a:pPr>
             <a:r>
               <a:rPr dirty="0"/>
-              <a:t>E[</a:t>
-            </a:r>
-            <a:r>
-              <a:rPr lang="en-US" dirty="0"/>
-              <a:t>3</a:t>
-            </a:r>
-            <a:r>
-              <a:rPr dirty="0"/>
-              <a:t>]</a:t>
-            </a:r>
-          </a:p>
-        </p:txBody>
-      </p:sp>
-      <p:cxnSp>
-        <p:nvCxnSpPr>
-          <p:cNvPr id="7" name="Connector 6"/>
-          <p:cNvCxnSpPr/>
-          <p:nvPr/>
-        </p:nvCxnSpPr>
-        <p:spPr>
-          <a:xfrm>
-            <a:off x="6982375" y="1691640"/>
-            <a:ext cx="685800" cy="0"/>
-          </a:xfrm>
-          <a:prstGeom prst="line">
-            <a:avLst/>
-          </a:prstGeom>
-          <a:ln w="38100">
-            <a:solidFill>
-              <a:srgbClr val="0B5CAD"/>
-            </a:solidFill>
-          </a:ln>
-        </p:spPr>
-        <p:style>
-          <a:lnRef idx="2">
-            <a:schemeClr val="accent1"/>
-          </a:lnRef>
-          <a:fillRef idx="0">
-            <a:schemeClr val="accent1"/>
-          </a:fillRef>
-          <a:effectRef idx="1">
-            <a:schemeClr val="accent1"/>
-          </a:effectRef>
-          <a:fontRef idx="minor">
-            <a:schemeClr val="tx1"/>
-          </a:fontRef>
-        </p:style>
-      </p:cxnSp>
-      <p:sp>
-        <p:nvSpPr>
-          <p:cNvPr id="8" name="Rounded Rectangle 7"/>
+              <a:t>The token ID is an index. It selects a row from the embedding matrix. The selected row is the token vector.</a:t>
+            </a:r>
+          </a:p>
+        </p:txBody>
+      </p:sp>
+      <p:sp>
+        <p:nvSpPr>
+          <p:cNvPr id="6" name="TextBox 5"/>
+          <p:cNvSpPr txBox="1"/>
+          <p:nvPr/>
+        </p:nvSpPr>
+        <p:spPr>
+          <a:xfrm>
+            <a:off x="320040" y="6473952"/>
+            <a:ext cx="11521440" cy="228600"/>
+          </a:xfrm>
+          <a:prstGeom prst="rect">
+            <a:avLst/>
+          </a:prstGeom>
+          <a:noFill/>
+        </p:spPr>
+        <p:txBody>
+          <a:bodyPr wrap="none">
+            <a:spAutoFit/>
+          </a:bodyPr>
+          <a:lstStyle/>
+          <a:p>
+            <a:pPr>
+              <a:defRPr sz="900">
+                <a:solidFill>
+                  <a:srgbClr val="52616B"/>
+                </a:solidFill>
+              </a:defRPr>
+            </a:pPr>
+            <a:r>
+              <a:t>AI Under the hood | Slide 12</a:t>
+            </a:r>
+          </a:p>
+        </p:txBody>
+      </p:sp>
+      <p:sp>
+        <p:nvSpPr>
+          <p:cNvPr id="7" name="Rounded Rectangle 3">
+            <a:extLst>
+              <a:ext uri="{FF2B5EF4-FFF2-40B4-BE49-F238E27FC236}">
+                <a16:creationId xmlns:a16="http://schemas.microsoft.com/office/drawing/2014/main" id="{4D62C980-9521-DFEE-0DCD-FEEC67E8FE40}"/>
+              </a:ext>
+            </a:extLst>
+          </p:cNvPr>
           <p:cNvSpPr/>
           <p:nvPr/>
         </p:nvSpPr>
         <p:spPr>
           <a:xfrm>
-            <a:off x="7668174" y="1228555"/>
-            <a:ext cx="3670385" cy="914400"/>
+            <a:off x="883920" y="3307531"/>
+            <a:ext cx="10424160" cy="1616949"/>
           </a:xfrm>
           <a:prstGeom prst="roundRect">
             <a:avLst/>
@@ -5545,8 +5661,8 @@
           <a:bodyPr lIns="182880" tIns="109728" rIns="182880" rtlCol="0" anchor="ctr"/>
           <a:lstStyle/>
           <a:p>
-            <a:pPr>
-              <a:defRPr sz="1600">
+            <a:pPr algn="ctr">
+              <a:defRPr sz="2200">
                 <a:solidFill>
                   <a:srgbClr val="172B4D"/>
                 </a:solidFill>
@@ -5554,143 +5670,26 @@
               </a:defRPr>
             </a:pPr>
             <a:r>
-              <a:rPr dirty="0"/>
-              <a:t>[</a:t>
-            </a:r>
-            <a:r>
               <a:rPr lang="en-US" dirty="0"/>
-              <a:t>-0.62,  0.18,  0.45, -0.09</a:t>
-            </a:r>
-            <a:r>
-              <a:rPr dirty="0"/>
-              <a:t>]</a:t>
-            </a:r>
-          </a:p>
-        </p:txBody>
-      </p:sp>
-      <p:sp>
-        <p:nvSpPr>
-          <p:cNvPr id="9" name="Rounded Rectangle 8"/>
-          <p:cNvSpPr/>
-          <p:nvPr/>
-        </p:nvSpPr>
-        <p:spPr>
-          <a:xfrm>
-            <a:off x="914400" y="3200400"/>
-            <a:ext cx="10424160" cy="1325880"/>
-          </a:xfrm>
-          <a:prstGeom prst="roundRect">
-            <a:avLst/>
-          </a:prstGeom>
-          <a:solidFill>
-            <a:srgbClr val="FFFFFF"/>
-          </a:solidFill>
-          <a:ln w="19050">
-            <a:solidFill>
-              <a:srgbClr val="0B5CAD"/>
-            </a:solidFill>
-          </a:ln>
-        </p:spPr>
-        <p:style>
-          <a:lnRef idx="1">
-            <a:schemeClr val="accent1"/>
-          </a:lnRef>
-          <a:fillRef idx="3">
-            <a:schemeClr val="accent1"/>
-          </a:fillRef>
-          <a:effectRef idx="2">
-            <a:schemeClr val="accent1"/>
-          </a:effectRef>
-          <a:fontRef idx="minor">
-            <a:schemeClr val="lt1"/>
-          </a:fontRef>
-        </p:style>
-        <p:txBody>
-          <a:bodyPr lIns="137160" tIns="91440" rIns="137160" rtlCol="0" anchor="ctr"/>
-          <a:lstStyle/>
-          <a:p>
-            <a:pPr algn="ctr">
-              <a:defRPr sz="1900" b="1">
-                <a:solidFill>
-                  <a:srgbClr val="0B2F5B"/>
-                </a:solidFill>
-              </a:defRPr>
-            </a:pPr>
-            <a:r>
-              <a:rPr dirty="0"/>
-              <a:t>Important distinction</a:t>
-            </a:r>
-          </a:p>
-          <a:p>
-            <a:pPr>
-              <a:spcAft>
-                <a:spcPts val="200"/>
-              </a:spcAft>
-              <a:defRPr sz="1800">
-                <a:solidFill>
-                  <a:srgbClr val="172B4D"/>
-                </a:solidFill>
-              </a:defRPr>
-            </a:pPr>
-            <a:r>
-              <a:rPr dirty="0">
-                <a:highlight>
-                  <a:srgbClr val="FFFF00"/>
-                </a:highlight>
-              </a:rPr>
-              <a:t>The integer </a:t>
-            </a:r>
-            <a:r>
-              <a:rPr lang="en-US" dirty="0">
-                <a:highlight>
-                  <a:srgbClr val="FFFF00"/>
-                </a:highlight>
-              </a:rPr>
-              <a:t>3</a:t>
-            </a:r>
-            <a:r>
-              <a:rPr dirty="0">
-                <a:highlight>
-                  <a:srgbClr val="FFFF00"/>
-                </a:highlight>
-              </a:rPr>
-              <a:t> does not contain the meaning of “sales.” It points to a learned row in the embedding matrix.</a:t>
-            </a:r>
-          </a:p>
-        </p:txBody>
-      </p:sp>
-      <p:sp>
-        <p:nvSpPr>
-          <p:cNvPr id="10" name="TextBox 9"/>
-          <p:cNvSpPr txBox="1"/>
-          <p:nvPr/>
-        </p:nvSpPr>
-        <p:spPr>
-          <a:xfrm>
-            <a:off x="320040" y="6473952"/>
-            <a:ext cx="11521440" cy="228600"/>
-          </a:xfrm>
-          <a:prstGeom prst="rect">
-            <a:avLst/>
-          </a:prstGeom>
-          <a:noFill/>
-        </p:spPr>
-        <p:txBody>
-          <a:bodyPr wrap="none">
-            <a:spAutoFit/>
-          </a:bodyPr>
-          <a:lstStyle/>
-          <a:p>
-            <a:pPr>
-              <a:defRPr sz="900">
-                <a:solidFill>
-                  <a:srgbClr val="52616B"/>
-                </a:solidFill>
-              </a:defRPr>
-            </a:pPr>
-            <a:r>
-              <a:t>AI Under the hood | Slide 14</a:t>
-            </a:r>
+              <a:t>Conceptually: </a:t>
+            </a:r>
+            <a:r>
+              <a:rPr lang="en-US" dirty="0" err="1"/>
+              <a:t>EmbeddingMatrix</a:t>
+            </a:r>
+            <a:r>
+              <a:rPr lang="en-US" dirty="0"/>
+              <a:t>[ </a:t>
+            </a:r>
+            <a:r>
+              <a:rPr lang="en-US" dirty="0" err="1"/>
+              <a:t>token_id</a:t>
+            </a:r>
+            <a:r>
+              <a:rPr lang="en-US" dirty="0"/>
+              <a:t> ] returns a vector</a:t>
+            </a:r>
+            <a:endParaRPr dirty="0"/>
           </a:p>
         </p:txBody>
       </p:sp>
@@ -11261,61 +11260,398 @@
       </p:grpSpPr>
       <p:pic>
         <p:nvPicPr>
-          <p:cNvPr id="2" name="MAGPAI From Question to Insight"/>
-          <p:cNvPicPr/>
-          <p:nvPr/>
+          <p:cNvPr id="6" name="Picture Placeholder 5">
+            <a:extLst>
+              <a:ext uri="{FF2B5EF4-FFF2-40B4-BE49-F238E27FC236}">
+                <a16:creationId xmlns:a16="http://schemas.microsoft.com/office/drawing/2014/main" id="{BC56227F-0E35-3518-A770-5486C9C41AE4}"/>
+              </a:ext>
+            </a:extLst>
+          </p:cNvPr>
+          <p:cNvPicPr>
+            <a:picLocks noGrp="1" noChangeAspect="1"/>
+          </p:cNvPicPr>
+          <p:nvPr>
+            <p:ph type="pic" idx="1"/>
+          </p:nvPr>
         </p:nvPicPr>
         <p:blipFill>
           <a:blip r:embed="rId2"/>
+          <a:srcRect l="3333" r="3333"/>
           <a:stretch>
             <a:fillRect/>
           </a:stretch>
         </p:blipFill>
         <p:spPr>
           <a:xfrm>
-            <a:off x="1466850" y="274320"/>
-            <a:ext cx="9258300" cy="6172200"/>
+            <a:off x="3068801" y="612775"/>
+            <a:ext cx="5486400" cy="4114800"/>
+          </a:xfrm>
+        </p:spPr>
+      </p:pic>
+      <p:sp>
+        <p:nvSpPr>
+          <p:cNvPr id="200" name="Closing dark readable overlay"/>
+          <p:cNvSpPr/>
+          <p:nvPr/>
+        </p:nvSpPr>
+        <p:spPr>
+          <a:xfrm>
+            <a:off x="0" y="0"/>
+            <a:ext cx="12192000" cy="6858000"/>
           </a:xfrm>
           <a:prstGeom prst="rect">
             <a:avLst/>
           </a:prstGeom>
-        </p:spPr>
-      </p:pic>
-      <p:sp>
-        <p:nvSpPr>
-          <p:cNvPr id="3" name="Footer"/>
-          <p:cNvSpPr txBox="1"/>
-          <p:nvPr/>
-        </p:nvSpPr>
-        <p:spPr>
-          <a:xfrm>
-            <a:off x="320040" y="6473952"/>
-            <a:ext cx="11521440" cy="228600"/>
+          <a:solidFill>
+            <a:srgbClr val="050A0F">
+              <a:alpha val="65000"/>
+            </a:srgbClr>
+          </a:solidFill>
+          <a:ln>
+            <a:noFill/>
+          </a:ln>
+        </p:spPr>
+      </p:sp>
+      <p:sp>
+        <p:nvSpPr>
+          <p:cNvPr id="201" name="Closing left ink panel"/>
+          <p:cNvSpPr/>
+          <p:nvPr/>
+        </p:nvSpPr>
+        <p:spPr>
+          <a:xfrm>
+            <a:off x="0" y="0"/>
+            <a:ext cx="7600000" cy="6858000"/>
           </a:xfrm>
           <a:prstGeom prst="rect">
             <a:avLst/>
           </a:prstGeom>
+          <a:solidFill>
+            <a:srgbClr val="07111B">
+              <a:alpha val="18000"/>
+            </a:srgbClr>
+          </a:solidFill>
+          <a:ln>
+            <a:noFill/>
+          </a:ln>
+        </p:spPr>
+      </p:sp>
+      <p:sp>
+        <p:nvSpPr>
+          <p:cNvPr id="202" name="Closing accent rule"/>
+          <p:cNvSpPr/>
+          <p:nvPr/>
+        </p:nvSpPr>
+        <p:spPr>
+          <a:xfrm>
+            <a:off x="760000" y="1070000"/>
+            <a:ext cx="3000000" cy="0"/>
+          </a:xfrm>
+          <a:prstGeom prst="rect">
+            <a:avLst/>
+          </a:prstGeom>
           <a:noFill/>
-          <a:ln/>
-        </p:spPr>
-        <p:txBody>
-          <a:bodyPr lIns="0" tIns="0" rIns="0" bIns="0" rtlCol="0" anchor="t"/>
-          <a:lstStyle/>
-          <a:p>
-            <a:pPr algn="r"/>
-            <a:r>
-              <a:rPr sz="850" dirty="0">
-                <a:solidFill>
-                  <a:srgbClr val="6B778C"/>
-                </a:solidFill>
-                <a:latin typeface="Aptos"/>
-              </a:rPr>
-              <a:t>AI Under the hood | Slide 20</a:t>
-            </a:r>
+          <a:ln w="38100">
+            <a:solidFill>
+              <a:srgbClr val="42D17A"/>
+            </a:solidFill>
+          </a:ln>
+        </p:spPr>
+      </p:sp>
+      <p:sp>
+        <p:nvSpPr>
+          <p:cNvPr id="203" name="Closing kicker"/>
+          <p:cNvSpPr/>
+          <p:nvPr/>
+        </p:nvSpPr>
+        <p:spPr>
+          <a:xfrm>
+            <a:off x="760000" y="520000"/>
+            <a:ext cx="4800000" cy="420000"/>
+          </a:xfrm>
+          <a:prstGeom prst="rect">
+            <a:avLst/>
+          </a:prstGeom>
+          <a:noFill/>
+          <a:ln>
+            <a:noFill/>
+          </a:ln>
+        </p:spPr>
+        <p:txBody>
+          <a:bodyPr wrap="square" anchor="t"/>
+          <a:lstStyle/>
+          <a:p>
+            <a:pPr algn="l">
+              <a:buNone/>
+            </a:pPr>
+            <a:r>
+              <a:rPr lang="en-US" sz="1600" b="1" dirty="0">
+                <a:solidFill>
+                  <a:srgbClr val="9AE6B4"/>
+                </a:solidFill>
+              </a:rPr>
+              <a:t>MAGPAI</a:t>
+            </a:r>
+            <a:endParaRPr lang="en-US" sz="1600" dirty="0"/>
+          </a:p>
+        </p:txBody>
+      </p:sp>
+      <p:sp>
+        <p:nvSpPr>
+          <p:cNvPr id="204" name="Closing title"/>
+          <p:cNvSpPr/>
+          <p:nvPr/>
+        </p:nvSpPr>
+        <p:spPr>
+          <a:xfrm>
+            <a:off x="730000" y="1180000"/>
+            <a:ext cx="7200000" cy="1500000"/>
+          </a:xfrm>
+          <a:prstGeom prst="rect">
+            <a:avLst/>
+          </a:prstGeom>
+          <a:noFill/>
+          <a:ln>
+            <a:noFill/>
+          </a:ln>
+        </p:spPr>
+        <p:txBody>
+          <a:bodyPr wrap="square" anchor="t"/>
+          <a:lstStyle/>
+          <a:p>
+            <a:pPr algn="l">
+              <a:buNone/>
+            </a:pPr>
+            <a:r>
+              <a:rPr lang="en-US" sz="3200" b="1" dirty="0">
+                <a:solidFill>
+                  <a:srgbClr val="FFFFFF"/>
+                </a:solidFill>
+              </a:rPr>
+              <a:t>You now know what is under the hood.</a:t>
+            </a:r>
+            <a:endParaRPr lang="en-US" sz="3200" dirty="0"/>
+          </a:p>
+        </p:txBody>
+      </p:sp>
+      <p:sp>
+        <p:nvSpPr>
+          <p:cNvPr id="205" name="Closing subtitle"/>
+          <p:cNvSpPr/>
+          <p:nvPr/>
+        </p:nvSpPr>
+        <p:spPr>
+          <a:xfrm>
+            <a:off x="780000" y="2700000"/>
+            <a:ext cx="6350000" cy="720000"/>
+          </a:xfrm>
+          <a:prstGeom prst="rect">
+            <a:avLst/>
+          </a:prstGeom>
+          <a:noFill/>
+          <a:ln>
+            <a:noFill/>
+          </a:ln>
+        </p:spPr>
+        <p:txBody>
+          <a:bodyPr wrap="square" anchor="t"/>
+          <a:lstStyle/>
+          <a:p>
+            <a:pPr algn="l">
+              <a:buNone/>
+            </a:pPr>
+            <a:r>
+              <a:rPr lang="en-US" sz="1800" b="0">
+                <a:solidFill>
+                  <a:srgbClr val="DCEAF7"/>
+                </a:solidFill>
+              </a:rPr>
+              <a:t>Words become tokens. Tokens become vectors. Vectors activate neural networks. Systems turn answers into action.</a:t>
+            </a:r>
+            <a:endParaRPr lang="en-US" sz="1800"/>
+          </a:p>
+        </p:txBody>
+      </p:sp>
+      <p:sp>
+        <p:nvSpPr>
+          <p:cNvPr id="206" name="Closing key takeaways"/>
+          <p:cNvSpPr/>
+          <p:nvPr/>
+        </p:nvSpPr>
+        <p:spPr>
+          <a:xfrm>
+            <a:off x="820000" y="3650000"/>
+            <a:ext cx="7110000" cy="1900000"/>
+          </a:xfrm>
+          <a:prstGeom prst="rect">
+            <a:avLst/>
+          </a:prstGeom>
+          <a:solidFill>
+            <a:srgbClr val="0B1B2A">
+              <a:alpha val="18000"/>
+            </a:srgbClr>
+          </a:solidFill>
+          <a:ln>
+            <a:noFill/>
+          </a:ln>
+        </p:spPr>
+        <p:txBody>
+          <a:bodyPr wrap="square" anchor="t"/>
+          <a:lstStyle/>
+          <a:p>
+            <a:pPr algn="l">
+              <a:buChar char="•"/>
+            </a:pPr>
+            <a:r>
+              <a:rPr lang="en-US" sz="1500" b="0" dirty="0">
+                <a:solidFill>
+                  <a:srgbClr val="F4F8FF"/>
+                </a:solidFill>
+              </a:rPr>
+              <a:t>AI is not magic; it is a pipeline you can inspect.</a:t>
+            </a:r>
+            <a:endParaRPr lang="en-US" sz="1500" dirty="0"/>
+          </a:p>
+          <a:p>
+            <a:pPr algn="l">
+              <a:buChar char="•"/>
+            </a:pPr>
+            <a:r>
+              <a:rPr lang="en-US" sz="1500" b="0" dirty="0">
+                <a:solidFill>
+                  <a:srgbClr val="F4F8FF"/>
+                </a:solidFill>
+              </a:rPr>
+              <a:t>Tokenization is where language first becomes structure.</a:t>
+            </a:r>
+            <a:endParaRPr lang="en-US" sz="1500" dirty="0"/>
+          </a:p>
+          <a:p>
+            <a:pPr algn="l">
+              <a:buChar char="•"/>
+            </a:pPr>
+            <a:r>
+              <a:rPr lang="en-US" sz="1500" b="0" dirty="0">
+                <a:solidFill>
+                  <a:srgbClr val="F4F8FF"/>
+                </a:solidFill>
+              </a:rPr>
+              <a:t>Embeddings are learned coordinates of meaning.</a:t>
+            </a:r>
+            <a:endParaRPr lang="en-US" sz="1500" dirty="0"/>
+          </a:p>
+          <a:p>
+            <a:pPr algn="l">
+              <a:buChar char="•"/>
+            </a:pPr>
+            <a:r>
+              <a:rPr lang="en-US" sz="1500" b="0" dirty="0">
+                <a:solidFill>
+                  <a:srgbClr val="F4F8FF"/>
+                </a:solidFill>
+              </a:rPr>
+              <a:t>Neural networks learn by changing weights and bias.</a:t>
+            </a:r>
+            <a:endParaRPr lang="en-US" sz="1500" dirty="0"/>
+          </a:p>
+          <a:p>
+            <a:pPr algn="l">
+              <a:buChar char="•"/>
+            </a:pPr>
+            <a:r>
+              <a:rPr lang="en-US" sz="1500" b="0" dirty="0">
+                <a:solidFill>
+                  <a:srgbClr val="F4F8FF"/>
+                </a:solidFill>
+              </a:rPr>
+              <a:t>Enterprise value comes when the model is connected to data, tools, and governance.</a:t>
+            </a:r>
+            <a:endParaRPr lang="en-US" sz="1500" dirty="0"/>
+          </a:p>
+        </p:txBody>
+      </p:sp>
+      <p:sp>
+        <p:nvSpPr>
+          <p:cNvPr id="207" name="Closing memorable line"/>
+          <p:cNvSpPr/>
+          <p:nvPr/>
+        </p:nvSpPr>
+        <p:spPr>
+          <a:xfrm>
+            <a:off x="835000" y="5750000"/>
+            <a:ext cx="8292222" cy="560000"/>
+          </a:xfrm>
+          <a:prstGeom prst="rect">
+            <a:avLst/>
+          </a:prstGeom>
+          <a:noFill/>
+          <a:ln>
+            <a:noFill/>
+          </a:ln>
+        </p:spPr>
+        <p:txBody>
+          <a:bodyPr wrap="square" anchor="t"/>
+          <a:lstStyle/>
+          <a:p>
+            <a:pPr algn="l">
+              <a:buNone/>
+            </a:pPr>
+            <a:r>
+              <a:rPr lang="en-US" sz="1800" b="1" dirty="0">
+                <a:solidFill>
+                  <a:srgbClr val="9AE6B4"/>
+                </a:solidFill>
+              </a:rPr>
+              <a:t>The advantage goes to teams who can see the machinery, not just use the interface.</a:t>
+            </a:r>
+            <a:endParaRPr lang="en-US" sz="1800" dirty="0"/>
+          </a:p>
+        </p:txBody>
+      </p:sp>
+      <p:sp>
+        <p:nvSpPr>
+          <p:cNvPr id="208" name="Closing footer"/>
+          <p:cNvSpPr/>
+          <p:nvPr/>
+        </p:nvSpPr>
+        <p:spPr>
+          <a:xfrm>
+            <a:off x="820000" y="6450000"/>
+            <a:ext cx="3500000" cy="260000"/>
+          </a:xfrm>
+          <a:prstGeom prst="rect">
+            <a:avLst/>
+          </a:prstGeom>
+          <a:noFill/>
+          <a:ln>
+            <a:noFill/>
+          </a:ln>
+        </p:spPr>
+        <p:txBody>
+          <a:bodyPr wrap="square" anchor="t"/>
+          <a:lstStyle/>
+          <a:p>
+            <a:pPr algn="l">
+              <a:buNone/>
+            </a:pPr>
+            <a:r>
+              <a:rPr lang="en-US" sz="1000" b="0">
+                <a:solidFill>
+                  <a:srgbClr val="A9B8C8"/>
+                </a:solidFill>
+              </a:rPr>
+              <a:t>AI Under the hood</a:t>
+            </a:r>
+            <a:endParaRPr lang="en-US" sz="1000"/>
           </a:p>
         </p:txBody>
       </p:sp>
     </p:spTree>
+    <p:extLst>
+      <p:ext uri="{BB962C8B-B14F-4D97-AF65-F5344CB8AC3E}">
+        <p14:creationId xmlns:p14="http://schemas.microsoft.com/office/powerpoint/2010/main" val="4093375280"/>
+      </p:ext>
+    </p:extLst>
   </p:cSld>
   <p:clrMapOvr>
     <a:masterClrMapping/>
@@ -11482,280 +11818,222 @@
   <p:clrMapOvr>
     <a:masterClrMapping/>
   </p:clrMapOvr>
-</p:sld>
-</file>
-
-<file path=ppt/slides/slide20.xml><?xml version="1.0" encoding="utf-8"?>
-<p:sld xmlns:a="http://schemas.openxmlformats.org/drawingml/2006/main" xmlns:r="http://schemas.openxmlformats.org/officeDocument/2006/relationships" xmlns:p="http://schemas.openxmlformats.org/presentationml/2006/main">
-  <p:cSld>
-    <p:spTree>
-      <p:nvGrpSpPr>
-        <p:cNvPr id="1" name=""/>
-        <p:cNvGrpSpPr/>
-        <p:nvPr/>
-      </p:nvGrpSpPr>
-      <p:grpSpPr>
-        <a:xfrm>
-          <a:off x="0" y="0"/>
-          <a:ext cx="0" cy="0"/>
-          <a:chOff x="0" y="0"/>
-          <a:chExt cx="0" cy="0"/>
-        </a:xfrm>
-      </p:grpSpPr>
-      <p:sp>
-        <p:nvSpPr>
-          <p:cNvPr id="2" name="TextBox 1"/>
-          <p:cNvSpPr txBox="1"/>
-          <p:nvPr/>
-        </p:nvSpPr>
-        <p:spPr>
-          <a:xfrm>
-            <a:off x="502920" y="320040"/>
-            <a:ext cx="11247120" cy="548640"/>
-          </a:xfrm>
-          <a:prstGeom prst="rect">
-            <a:avLst/>
-          </a:prstGeom>
-          <a:noFill/>
-        </p:spPr>
-        <p:txBody>
-          <a:bodyPr wrap="none">
-            <a:spAutoFit/>
-          </a:bodyPr>
-          <a:lstStyle/>
-          <a:p>
-            <a:pPr>
-              <a:defRPr sz="3000" b="1">
-                <a:solidFill>
-                  <a:srgbClr val="0B2F5B"/>
-                </a:solidFill>
-              </a:defRPr>
-            </a:pPr>
-            <a:r>
-              <a:t>Audience Takeaway</a:t>
-            </a:r>
-          </a:p>
-        </p:txBody>
-      </p:sp>
-      <p:sp>
-        <p:nvSpPr>
-          <p:cNvPr id="3" name="TextBox 2"/>
-          <p:cNvSpPr txBox="1"/>
-          <p:nvPr/>
-        </p:nvSpPr>
-        <p:spPr>
-          <a:xfrm>
-            <a:off x="530352" y="868680"/>
-            <a:ext cx="10972800" cy="365760"/>
-          </a:xfrm>
-          <a:prstGeom prst="rect">
-            <a:avLst/>
-          </a:prstGeom>
-          <a:noFill/>
-        </p:spPr>
-        <p:txBody>
-          <a:bodyPr wrap="none">
-            <a:spAutoFit/>
-          </a:bodyPr>
-          <a:lstStyle/>
-          <a:p>
-            <a:pPr>
-              <a:defRPr sz="1600">
-                <a:solidFill>
-                  <a:srgbClr val="52616B"/>
-                </a:solidFill>
-              </a:defRPr>
-            </a:pPr>
-            <a:r>
-              <a:t>The first stable mental model</a:t>
-            </a:r>
-          </a:p>
-        </p:txBody>
-      </p:sp>
-      <p:sp>
-        <p:nvSpPr>
-          <p:cNvPr id="4" name="Rounded Rectangle 3"/>
-          <p:cNvSpPr/>
-          <p:nvPr/>
-        </p:nvSpPr>
-        <p:spPr>
-          <a:xfrm>
-            <a:off x="914400" y="1463040"/>
-            <a:ext cx="10424160" cy="1097280"/>
-          </a:xfrm>
-          <a:prstGeom prst="roundRect">
-            <a:avLst/>
-          </a:prstGeom>
-          <a:solidFill>
-            <a:srgbClr val="F5F8FC"/>
-          </a:solidFill>
-          <a:ln>
-            <a:solidFill>
-              <a:srgbClr val="BED2E6"/>
-            </a:solidFill>
-          </a:ln>
-        </p:spPr>
-        <p:style>
-          <a:lnRef idx="1">
-            <a:schemeClr val="accent1"/>
-          </a:lnRef>
-          <a:fillRef idx="3">
-            <a:schemeClr val="accent1"/>
-          </a:fillRef>
-          <a:effectRef idx="2">
-            <a:schemeClr val="accent1"/>
-          </a:effectRef>
-          <a:fontRef idx="minor">
-            <a:schemeClr val="lt1"/>
-          </a:fontRef>
-        </p:style>
-        <p:txBody>
-          <a:bodyPr lIns="182880" tIns="109728" rIns="182880" rtlCol="0" anchor="ctr"/>
-          <a:lstStyle/>
-          <a:p>
-            <a:pPr algn="ctr">
-              <a:defRPr sz="2700">
-                <a:solidFill>
-                  <a:srgbClr val="172B4D"/>
-                </a:solidFill>
-                <a:latin typeface="Consolas"/>
-              </a:defRPr>
-            </a:pPr>
-            <a:r>
-              <a:t>A model never sees “sales” as a word.</a:t>
-            </a:r>
-            <a:br/>
-            <a:r>
-              <a:t>It sees a numeric pattern.</a:t>
-            </a:r>
-          </a:p>
-        </p:txBody>
-      </p:sp>
-      <p:sp>
-        <p:nvSpPr>
-          <p:cNvPr id="5" name="Rounded Rectangle 4"/>
-          <p:cNvSpPr/>
-          <p:nvPr/>
-        </p:nvSpPr>
-        <p:spPr>
-          <a:xfrm>
-            <a:off x="914400" y="2971800"/>
-            <a:ext cx="10424160" cy="1600200"/>
-          </a:xfrm>
-          <a:prstGeom prst="roundRect">
-            <a:avLst/>
-          </a:prstGeom>
-          <a:solidFill>
-            <a:srgbClr val="F5F8FC"/>
-          </a:solidFill>
-          <a:ln>
-            <a:solidFill>
-              <a:srgbClr val="BED2E6"/>
-            </a:solidFill>
-          </a:ln>
-        </p:spPr>
-        <p:style>
-          <a:lnRef idx="1">
-            <a:schemeClr val="accent1"/>
-          </a:lnRef>
-          <a:fillRef idx="3">
-            <a:schemeClr val="accent1"/>
-          </a:fillRef>
-          <a:effectRef idx="2">
-            <a:schemeClr val="accent1"/>
-          </a:effectRef>
-          <a:fontRef idx="minor">
-            <a:schemeClr val="lt1"/>
-          </a:fontRef>
-        </p:style>
-        <p:txBody>
-          <a:bodyPr lIns="182880" tIns="109728" rIns="182880" rtlCol="0" anchor="ctr"/>
-          <a:lstStyle/>
-          <a:p>
-            <a:pPr algn="ctr">
-              <a:defRPr sz="2200">
-                <a:solidFill>
-                  <a:srgbClr val="172B4D"/>
-                </a:solidFill>
-                <a:latin typeface="Consolas"/>
-              </a:defRPr>
-            </a:pPr>
-            <a:r>
-              <a:rPr dirty="0"/>
-              <a:t>Text becomes tokens.</a:t>
-            </a:r>
-            <a:br>
-              <a:rPr dirty="0"/>
-            </a:br>
-            <a:r>
-              <a:rPr dirty="0"/>
-              <a:t>Tokens become IDs.</a:t>
-            </a:r>
-            <a:br>
-              <a:rPr dirty="0"/>
-            </a:br>
-            <a:r>
-              <a:rPr dirty="0"/>
-              <a:t>IDs become vectors.</a:t>
-            </a:r>
-            <a:br>
-              <a:rPr dirty="0"/>
-            </a:br>
-            <a:r>
-              <a:rPr dirty="0"/>
-              <a:t>Vectors become an </a:t>
-            </a:r>
-            <a:r>
-              <a:rPr lang="en-US" dirty="0"/>
-              <a:t>input tensor for the NN </a:t>
-            </a:r>
-            <a:r>
-              <a:rPr dirty="0"/>
-              <a:t>model.</a:t>
-            </a:r>
-          </a:p>
-        </p:txBody>
-      </p:sp>
-      <p:sp>
-        <p:nvSpPr>
-          <p:cNvPr id="6" name="TextBox 5"/>
-          <p:cNvSpPr txBox="1"/>
-          <p:nvPr/>
-        </p:nvSpPr>
-        <p:spPr>
-          <a:xfrm>
-            <a:off x="320040" y="6473952"/>
-            <a:ext cx="11521440" cy="228600"/>
-          </a:xfrm>
-          <a:prstGeom prst="rect">
-            <a:avLst/>
-          </a:prstGeom>
-          <a:noFill/>
-        </p:spPr>
-        <p:txBody>
-          <a:bodyPr wrap="none">
-            <a:spAutoFit/>
-          </a:bodyPr>
-          <a:lstStyle/>
-          <a:p>
-            <a:pPr>
-              <a:defRPr sz="900">
-                <a:solidFill>
-                  <a:srgbClr val="52616B"/>
-                </a:solidFill>
-              </a:defRPr>
-            </a:pPr>
-            <a:r>
-              <a:t>AI Under the hood | Slide 22</a:t>
-            </a:r>
-          </a:p>
-        </p:txBody>
-      </p:sp>
-    </p:spTree>
-  </p:cSld>
-  <p:clrMapOvr>
-    <a:masterClrMapping/>
-  </p:clrMapOvr>
+  <p:timing>
+    <p:tnLst>
+      <p:par>
+        <p:cTn id="1" dur="indefinite" restart="never" nodeType="tmRoot">
+          <p:childTnLst>
+            <p:seq concurrent="1" nextAc="seek">
+              <p:cTn id="2" dur="indefinite" nodeType="mainSeq">
+                <p:childTnLst>
+                  <p:par>
+                    <p:cTn id="3" fill="hold">
+                      <p:stCondLst>
+                        <p:cond delay="indefinite"/>
+                      </p:stCondLst>
+                      <p:childTnLst>
+                        <p:par>
+                          <p:cTn id="4" fill="hold">
+                            <p:stCondLst>
+                              <p:cond delay="0"/>
+                            </p:stCondLst>
+                            <p:childTnLst>
+                              <p:par>
+                                <p:cTn id="5" presetID="2" presetClass="entr" presetSubtype="4" fill="hold" grpId="0" nodeType="clickEffect">
+                                  <p:stCondLst>
+                                    <p:cond delay="0"/>
+                                  </p:stCondLst>
+                                  <p:childTnLst>
+                                    <p:set>
+                                      <p:cBhvr>
+                                        <p:cTn id="6" dur="1" fill="hold">
+                                          <p:stCondLst>
+                                            <p:cond delay="0"/>
+                                          </p:stCondLst>
+                                        </p:cTn>
+                                        <p:tgtEl>
+                                          <p:spTgt spid="91"/>
+                                        </p:tgtEl>
+                                        <p:attrNameLst>
+                                          <p:attrName>style.visibility</p:attrName>
+                                        </p:attrNameLst>
+                                      </p:cBhvr>
+                                      <p:to>
+                                        <p:strVal val="visible"/>
+                                      </p:to>
+                                    </p:set>
+                                    <p:anim calcmode="lin" valueType="num">
+                                      <p:cBhvr additive="base">
+                                        <p:cTn id="7" dur="500" fill="hold"/>
+                                        <p:tgtEl>
+                                          <p:spTgt spid="91"/>
+                                        </p:tgtEl>
+                                        <p:attrNameLst>
+                                          <p:attrName>ppt_x</p:attrName>
+                                        </p:attrNameLst>
+                                      </p:cBhvr>
+                                      <p:tavLst>
+                                        <p:tav tm="0">
+                                          <p:val>
+                                            <p:strVal val="#ppt_x"/>
+                                          </p:val>
+                                        </p:tav>
+                                        <p:tav tm="100000">
+                                          <p:val>
+                                            <p:strVal val="#ppt_x"/>
+                                          </p:val>
+                                        </p:tav>
+                                      </p:tavLst>
+                                    </p:anim>
+                                    <p:anim calcmode="lin" valueType="num">
+                                      <p:cBhvr additive="base">
+                                        <p:cTn id="8" dur="500" fill="hold"/>
+                                        <p:tgtEl>
+                                          <p:spTgt spid="91"/>
+                                        </p:tgtEl>
+                                        <p:attrNameLst>
+                                          <p:attrName>ppt_y</p:attrName>
+                                        </p:attrNameLst>
+                                      </p:cBhvr>
+                                      <p:tavLst>
+                                        <p:tav tm="0">
+                                          <p:val>
+                                            <p:strVal val="1+#ppt_h/2"/>
+                                          </p:val>
+                                        </p:tav>
+                                        <p:tav tm="100000">
+                                          <p:val>
+                                            <p:strVal val="#ppt_y"/>
+                                          </p:val>
+                                        </p:tav>
+                                      </p:tavLst>
+                                    </p:anim>
+                                  </p:childTnLst>
+                                </p:cTn>
+                              </p:par>
+                            </p:childTnLst>
+                          </p:cTn>
+                        </p:par>
+                      </p:childTnLst>
+                    </p:cTn>
+                  </p:par>
+                  <p:par>
+                    <p:cTn id="9" fill="hold">
+                      <p:stCondLst>
+                        <p:cond delay="indefinite"/>
+                      </p:stCondLst>
+                      <p:childTnLst>
+                        <p:par>
+                          <p:cTn id="10" fill="hold">
+                            <p:stCondLst>
+                              <p:cond delay="0"/>
+                            </p:stCondLst>
+                            <p:childTnLst>
+                              <p:par>
+                                <p:cTn id="11" presetID="2" presetClass="entr" presetSubtype="4" fill="hold" grpId="0" nodeType="clickEffect">
+                                  <p:stCondLst>
+                                    <p:cond delay="0"/>
+                                  </p:stCondLst>
+                                  <p:childTnLst>
+                                    <p:set>
+                                      <p:cBhvr>
+                                        <p:cTn id="12" dur="1" fill="hold">
+                                          <p:stCondLst>
+                                            <p:cond delay="0"/>
+                                          </p:stCondLst>
+                                        </p:cTn>
+                                        <p:tgtEl>
+                                          <p:spTgt spid="92"/>
+                                        </p:tgtEl>
+                                        <p:attrNameLst>
+                                          <p:attrName>style.visibility</p:attrName>
+                                        </p:attrNameLst>
+                                      </p:cBhvr>
+                                      <p:to>
+                                        <p:strVal val="visible"/>
+                                      </p:to>
+                                    </p:set>
+                                    <p:anim calcmode="lin" valueType="num">
+                                      <p:cBhvr additive="base">
+                                        <p:cTn id="13" dur="500" fill="hold"/>
+                                        <p:tgtEl>
+                                          <p:spTgt spid="92"/>
+                                        </p:tgtEl>
+                                        <p:attrNameLst>
+                                          <p:attrName>ppt_x</p:attrName>
+                                        </p:attrNameLst>
+                                      </p:cBhvr>
+                                      <p:tavLst>
+                                        <p:tav tm="0">
+                                          <p:val>
+                                            <p:strVal val="#ppt_x"/>
+                                          </p:val>
+                                        </p:tav>
+                                        <p:tav tm="100000">
+                                          <p:val>
+                                            <p:strVal val="#ppt_x"/>
+                                          </p:val>
+                                        </p:tav>
+                                      </p:tavLst>
+                                    </p:anim>
+                                    <p:anim calcmode="lin" valueType="num">
+                                      <p:cBhvr additive="base">
+                                        <p:cTn id="14" dur="500" fill="hold"/>
+                                        <p:tgtEl>
+                                          <p:spTgt spid="92"/>
+                                        </p:tgtEl>
+                                        <p:attrNameLst>
+                                          <p:attrName>ppt_y</p:attrName>
+                                        </p:attrNameLst>
+                                      </p:cBhvr>
+                                      <p:tavLst>
+                                        <p:tav tm="0">
+                                          <p:val>
+                                            <p:strVal val="1+#ppt_h/2"/>
+                                          </p:val>
+                                        </p:tav>
+                                        <p:tav tm="100000">
+                                          <p:val>
+                                            <p:strVal val="#ppt_y"/>
+                                          </p:val>
+                                        </p:tav>
+                                      </p:tavLst>
+                                    </p:anim>
+                                  </p:childTnLst>
+                                </p:cTn>
+                              </p:par>
+                            </p:childTnLst>
+                          </p:cTn>
+                        </p:par>
+                      </p:childTnLst>
+                    </p:cTn>
+                  </p:par>
+                </p:childTnLst>
+              </p:cTn>
+              <p:prevCondLst>
+                <p:cond evt="onPrev" delay="0">
+                  <p:tgtEl>
+                    <p:sldTgt/>
+                  </p:tgtEl>
+                </p:cond>
+              </p:prevCondLst>
+              <p:nextCondLst>
+                <p:cond evt="onNext" delay="0">
+                  <p:tgtEl>
+                    <p:sldTgt/>
+                  </p:tgtEl>
+                </p:cond>
+              </p:nextCondLst>
+            </p:seq>
+          </p:childTnLst>
+        </p:cTn>
+      </p:par>
+    </p:tnLst>
+    <p:bldLst>
+      <p:bldP spid="91" grpId="0" animBg="1"/>
+      <p:bldP spid="92" grpId="0" animBg="1"/>
+    </p:bldLst>
+  </p:timing>
 </p:sld>
 </file>
 

</xml_diff>

<commit_message>
Last updates before the demo. All looks good. I will merge and push to the main branch, so that the demo can be done from the main branch.
</commit_message>
<xml_diff>
--- a/pptx/Session_01_Tokens_v1.0.pptx
+++ b/pptx/Session_01_Tokens_v1.0.pptx
@@ -23,7 +23,8 @@
     <p:sldId id="277" r:id="rId17"/>
     <p:sldId id="270" r:id="rId18"/>
     <p:sldId id="271" r:id="rId19"/>
-    <p:sldId id="278" r:id="rId20"/>
+    <p:sldId id="279" r:id="rId20"/>
+    <p:sldId id="278" r:id="rId21"/>
   </p:sldIdLst>
   <p:sldSz cx="12192000" cy="6858000"/>
   <p:notesSz cx="6858000" cy="9144000"/>
@@ -320,7 +321,7 @@
           <a:p>
             <a:fld id="{5BCAD085-E8A6-8845-BD4E-CB4CCA059FC4}" type="datetimeFigureOut">
               <a:rPr lang="en-US" smtClean="0"/>
-              <a:t>6/4/2026</a:t>
+              <a:t>6/5/2026</a:t>
             </a:fld>
             <a:endParaRPr lang="en-US"/>
           </a:p>
@@ -488,7 +489,7 @@
           <a:p>
             <a:fld id="{5BCAD085-E8A6-8845-BD4E-CB4CCA059FC4}" type="datetimeFigureOut">
               <a:rPr lang="en-US" smtClean="0"/>
-              <a:t>6/4/2026</a:t>
+              <a:t>6/5/2026</a:t>
             </a:fld>
             <a:endParaRPr lang="en-US"/>
           </a:p>
@@ -666,7 +667,7 @@
           <a:p>
             <a:fld id="{5BCAD085-E8A6-8845-BD4E-CB4CCA059FC4}" type="datetimeFigureOut">
               <a:rPr lang="en-US" smtClean="0"/>
-              <a:t>6/4/2026</a:t>
+              <a:t>6/5/2026</a:t>
             </a:fld>
             <a:endParaRPr lang="en-US"/>
           </a:p>
@@ -834,7 +835,7 @@
           <a:p>
             <a:fld id="{5BCAD085-E8A6-8845-BD4E-CB4CCA059FC4}" type="datetimeFigureOut">
               <a:rPr lang="en-US" smtClean="0"/>
-              <a:t>6/4/2026</a:t>
+              <a:t>6/5/2026</a:t>
             </a:fld>
             <a:endParaRPr lang="en-US"/>
           </a:p>
@@ -1079,7 +1080,7 @@
           <a:p>
             <a:fld id="{5BCAD085-E8A6-8845-BD4E-CB4CCA059FC4}" type="datetimeFigureOut">
               <a:rPr lang="en-US" smtClean="0"/>
-              <a:t>6/4/2026</a:t>
+              <a:t>6/5/2026</a:t>
             </a:fld>
             <a:endParaRPr lang="en-US"/>
           </a:p>
@@ -1364,7 +1365,7 @@
           <a:p>
             <a:fld id="{5BCAD085-E8A6-8845-BD4E-CB4CCA059FC4}" type="datetimeFigureOut">
               <a:rPr lang="en-US" smtClean="0"/>
-              <a:t>6/4/2026</a:t>
+              <a:t>6/5/2026</a:t>
             </a:fld>
             <a:endParaRPr lang="en-US"/>
           </a:p>
@@ -1783,7 +1784,7 @@
           <a:p>
             <a:fld id="{5BCAD085-E8A6-8845-BD4E-CB4CCA059FC4}" type="datetimeFigureOut">
               <a:rPr lang="en-US" smtClean="0"/>
-              <a:t>6/4/2026</a:t>
+              <a:t>6/5/2026</a:t>
             </a:fld>
             <a:endParaRPr lang="en-US"/>
           </a:p>
@@ -1900,7 +1901,7 @@
           <a:p>
             <a:fld id="{5BCAD085-E8A6-8845-BD4E-CB4CCA059FC4}" type="datetimeFigureOut">
               <a:rPr lang="en-US" smtClean="0"/>
-              <a:t>6/4/2026</a:t>
+              <a:t>6/5/2026</a:t>
             </a:fld>
             <a:endParaRPr lang="en-US"/>
           </a:p>
@@ -1995,7 +1996,7 @@
           <a:p>
             <a:fld id="{5BCAD085-E8A6-8845-BD4E-CB4CCA059FC4}" type="datetimeFigureOut">
               <a:rPr lang="en-US" smtClean="0"/>
-              <a:t>6/4/2026</a:t>
+              <a:t>6/5/2026</a:t>
             </a:fld>
             <a:endParaRPr lang="en-US"/>
           </a:p>
@@ -2270,7 +2271,7 @@
           <a:p>
             <a:fld id="{5BCAD085-E8A6-8845-BD4E-CB4CCA059FC4}" type="datetimeFigureOut">
               <a:rPr lang="en-US" smtClean="0"/>
-              <a:t>6/4/2026</a:t>
+              <a:t>6/5/2026</a:t>
             </a:fld>
             <a:endParaRPr lang="en-US"/>
           </a:p>
@@ -2522,7 +2523,7 @@
           <a:p>
             <a:fld id="{5BCAD085-E8A6-8845-BD4E-CB4CCA059FC4}" type="datetimeFigureOut">
               <a:rPr lang="en-US" smtClean="0"/>
-              <a:t>6/4/2026</a:t>
+              <a:t>6/5/2026</a:t>
             </a:fld>
             <a:endParaRPr lang="en-US"/>
           </a:p>
@@ -2733,7 +2734,7 @@
           <a:p>
             <a:fld id="{5BCAD085-E8A6-8845-BD4E-CB4CCA059FC4}" type="datetimeFigureOut">
               <a:rPr lang="en-US" smtClean="0"/>
-              <a:t>6/4/2026</a:t>
+              <a:t>6/5/2026</a:t>
             </a:fld>
             <a:endParaRPr lang="en-US"/>
           </a:p>
@@ -11260,396 +11261,38 @@
       </p:grpSpPr>
       <p:pic>
         <p:nvPicPr>
-          <p:cNvPr id="6" name="Picture Placeholder 5">
+          <p:cNvPr id="3" name="Picture 2">
             <a:extLst>
               <a:ext uri="{FF2B5EF4-FFF2-40B4-BE49-F238E27FC236}">
-                <a16:creationId xmlns:a16="http://schemas.microsoft.com/office/drawing/2014/main" id="{BC56227F-0E35-3518-A770-5486C9C41AE4}"/>
+                <a16:creationId xmlns:a16="http://schemas.microsoft.com/office/drawing/2014/main" id="{D45CE668-48F2-9EC1-3F0B-A8E665B4675A}"/>
               </a:ext>
             </a:extLst>
           </p:cNvPr>
           <p:cNvPicPr>
-            <a:picLocks noGrp="1" noChangeAspect="1"/>
+            <a:picLocks noChangeAspect="1"/>
           </p:cNvPicPr>
-          <p:nvPr>
-            <p:ph type="pic" idx="1"/>
-          </p:nvPr>
+          <p:nvPr/>
         </p:nvPicPr>
         <p:blipFill>
           <a:blip r:embed="rId2"/>
-          <a:srcRect l="3333" r="3333"/>
           <a:stretch>
             <a:fillRect/>
           </a:stretch>
         </p:blipFill>
         <p:spPr>
           <a:xfrm>
-            <a:off x="3068801" y="612775"/>
-            <a:ext cx="5486400" cy="4114800"/>
-          </a:xfrm>
+            <a:off x="1564022" y="302003"/>
+            <a:ext cx="9063955" cy="6042637"/>
+          </a:xfrm>
+          <a:prstGeom prst="rect">
+            <a:avLst/>
+          </a:prstGeom>
         </p:spPr>
       </p:pic>
-      <p:sp>
-        <p:nvSpPr>
-          <p:cNvPr id="200" name="Closing dark readable overlay"/>
-          <p:cNvSpPr/>
-          <p:nvPr/>
-        </p:nvSpPr>
-        <p:spPr>
-          <a:xfrm>
-            <a:off x="0" y="0"/>
-            <a:ext cx="12192000" cy="6858000"/>
-          </a:xfrm>
-          <a:prstGeom prst="rect">
-            <a:avLst/>
-          </a:prstGeom>
-          <a:solidFill>
-            <a:srgbClr val="050A0F">
-              <a:alpha val="65000"/>
-            </a:srgbClr>
-          </a:solidFill>
-          <a:ln>
-            <a:noFill/>
-          </a:ln>
-        </p:spPr>
-      </p:sp>
-      <p:sp>
-        <p:nvSpPr>
-          <p:cNvPr id="201" name="Closing left ink panel"/>
-          <p:cNvSpPr/>
-          <p:nvPr/>
-        </p:nvSpPr>
-        <p:spPr>
-          <a:xfrm>
-            <a:off x="0" y="0"/>
-            <a:ext cx="7600000" cy="6858000"/>
-          </a:xfrm>
-          <a:prstGeom prst="rect">
-            <a:avLst/>
-          </a:prstGeom>
-          <a:solidFill>
-            <a:srgbClr val="07111B">
-              <a:alpha val="18000"/>
-            </a:srgbClr>
-          </a:solidFill>
-          <a:ln>
-            <a:noFill/>
-          </a:ln>
-        </p:spPr>
-      </p:sp>
-      <p:sp>
-        <p:nvSpPr>
-          <p:cNvPr id="202" name="Closing accent rule"/>
-          <p:cNvSpPr/>
-          <p:nvPr/>
-        </p:nvSpPr>
-        <p:spPr>
-          <a:xfrm>
-            <a:off x="760000" y="1070000"/>
-            <a:ext cx="3000000" cy="0"/>
-          </a:xfrm>
-          <a:prstGeom prst="rect">
-            <a:avLst/>
-          </a:prstGeom>
-          <a:noFill/>
-          <a:ln w="38100">
-            <a:solidFill>
-              <a:srgbClr val="42D17A"/>
-            </a:solidFill>
-          </a:ln>
-        </p:spPr>
-      </p:sp>
-      <p:sp>
-        <p:nvSpPr>
-          <p:cNvPr id="203" name="Closing kicker"/>
-          <p:cNvSpPr/>
-          <p:nvPr/>
-        </p:nvSpPr>
-        <p:spPr>
-          <a:xfrm>
-            <a:off x="760000" y="520000"/>
-            <a:ext cx="4800000" cy="420000"/>
-          </a:xfrm>
-          <a:prstGeom prst="rect">
-            <a:avLst/>
-          </a:prstGeom>
-          <a:noFill/>
-          <a:ln>
-            <a:noFill/>
-          </a:ln>
-        </p:spPr>
-        <p:txBody>
-          <a:bodyPr wrap="square" anchor="t"/>
-          <a:lstStyle/>
-          <a:p>
-            <a:pPr algn="l">
-              <a:buNone/>
-            </a:pPr>
-            <a:r>
-              <a:rPr lang="en-US" sz="1600" b="1" dirty="0">
-                <a:solidFill>
-                  <a:srgbClr val="9AE6B4"/>
-                </a:solidFill>
-              </a:rPr>
-              <a:t>MAGPAI</a:t>
-            </a:r>
-            <a:endParaRPr lang="en-US" sz="1600" dirty="0"/>
-          </a:p>
-        </p:txBody>
-      </p:sp>
-      <p:sp>
-        <p:nvSpPr>
-          <p:cNvPr id="204" name="Closing title"/>
-          <p:cNvSpPr/>
-          <p:nvPr/>
-        </p:nvSpPr>
-        <p:spPr>
-          <a:xfrm>
-            <a:off x="730000" y="1180000"/>
-            <a:ext cx="7200000" cy="1500000"/>
-          </a:xfrm>
-          <a:prstGeom prst="rect">
-            <a:avLst/>
-          </a:prstGeom>
-          <a:noFill/>
-          <a:ln>
-            <a:noFill/>
-          </a:ln>
-        </p:spPr>
-        <p:txBody>
-          <a:bodyPr wrap="square" anchor="t"/>
-          <a:lstStyle/>
-          <a:p>
-            <a:pPr algn="l">
-              <a:buNone/>
-            </a:pPr>
-            <a:r>
-              <a:rPr lang="en-US" sz="3200" b="1" dirty="0">
-                <a:solidFill>
-                  <a:srgbClr val="FFFFFF"/>
-                </a:solidFill>
-              </a:rPr>
-              <a:t>You now know what is under the hood.</a:t>
-            </a:r>
-            <a:endParaRPr lang="en-US" sz="3200" dirty="0"/>
-          </a:p>
-        </p:txBody>
-      </p:sp>
-      <p:sp>
-        <p:nvSpPr>
-          <p:cNvPr id="205" name="Closing subtitle"/>
-          <p:cNvSpPr/>
-          <p:nvPr/>
-        </p:nvSpPr>
-        <p:spPr>
-          <a:xfrm>
-            <a:off x="780000" y="2700000"/>
-            <a:ext cx="6350000" cy="720000"/>
-          </a:xfrm>
-          <a:prstGeom prst="rect">
-            <a:avLst/>
-          </a:prstGeom>
-          <a:noFill/>
-          <a:ln>
-            <a:noFill/>
-          </a:ln>
-        </p:spPr>
-        <p:txBody>
-          <a:bodyPr wrap="square" anchor="t"/>
-          <a:lstStyle/>
-          <a:p>
-            <a:pPr algn="l">
-              <a:buNone/>
-            </a:pPr>
-            <a:r>
-              <a:rPr lang="en-US" sz="1800" b="0">
-                <a:solidFill>
-                  <a:srgbClr val="DCEAF7"/>
-                </a:solidFill>
-              </a:rPr>
-              <a:t>Words become tokens. Tokens become vectors. Vectors activate neural networks. Systems turn answers into action.</a:t>
-            </a:r>
-            <a:endParaRPr lang="en-US" sz="1800"/>
-          </a:p>
-        </p:txBody>
-      </p:sp>
-      <p:sp>
-        <p:nvSpPr>
-          <p:cNvPr id="206" name="Closing key takeaways"/>
-          <p:cNvSpPr/>
-          <p:nvPr/>
-        </p:nvSpPr>
-        <p:spPr>
-          <a:xfrm>
-            <a:off x="820000" y="3650000"/>
-            <a:ext cx="7110000" cy="1900000"/>
-          </a:xfrm>
-          <a:prstGeom prst="rect">
-            <a:avLst/>
-          </a:prstGeom>
-          <a:solidFill>
-            <a:srgbClr val="0B1B2A">
-              <a:alpha val="18000"/>
-            </a:srgbClr>
-          </a:solidFill>
-          <a:ln>
-            <a:noFill/>
-          </a:ln>
-        </p:spPr>
-        <p:txBody>
-          <a:bodyPr wrap="square" anchor="t"/>
-          <a:lstStyle/>
-          <a:p>
-            <a:pPr algn="l">
-              <a:buChar char="•"/>
-            </a:pPr>
-            <a:r>
-              <a:rPr lang="en-US" sz="1500" b="0" dirty="0">
-                <a:solidFill>
-                  <a:srgbClr val="F4F8FF"/>
-                </a:solidFill>
-              </a:rPr>
-              <a:t>AI is not magic; it is a pipeline you can inspect.</a:t>
-            </a:r>
-            <a:endParaRPr lang="en-US" sz="1500" dirty="0"/>
-          </a:p>
-          <a:p>
-            <a:pPr algn="l">
-              <a:buChar char="•"/>
-            </a:pPr>
-            <a:r>
-              <a:rPr lang="en-US" sz="1500" b="0" dirty="0">
-                <a:solidFill>
-                  <a:srgbClr val="F4F8FF"/>
-                </a:solidFill>
-              </a:rPr>
-              <a:t>Tokenization is where language first becomes structure.</a:t>
-            </a:r>
-            <a:endParaRPr lang="en-US" sz="1500" dirty="0"/>
-          </a:p>
-          <a:p>
-            <a:pPr algn="l">
-              <a:buChar char="•"/>
-            </a:pPr>
-            <a:r>
-              <a:rPr lang="en-US" sz="1500" b="0" dirty="0">
-                <a:solidFill>
-                  <a:srgbClr val="F4F8FF"/>
-                </a:solidFill>
-              </a:rPr>
-              <a:t>Embeddings are learned coordinates of meaning.</a:t>
-            </a:r>
-            <a:endParaRPr lang="en-US" sz="1500" dirty="0"/>
-          </a:p>
-          <a:p>
-            <a:pPr algn="l">
-              <a:buChar char="•"/>
-            </a:pPr>
-            <a:r>
-              <a:rPr lang="en-US" sz="1500" b="0" dirty="0">
-                <a:solidFill>
-                  <a:srgbClr val="F4F8FF"/>
-                </a:solidFill>
-              </a:rPr>
-              <a:t>Neural networks learn by changing weights and bias.</a:t>
-            </a:r>
-            <a:endParaRPr lang="en-US" sz="1500" dirty="0"/>
-          </a:p>
-          <a:p>
-            <a:pPr algn="l">
-              <a:buChar char="•"/>
-            </a:pPr>
-            <a:r>
-              <a:rPr lang="en-US" sz="1500" b="0" dirty="0">
-                <a:solidFill>
-                  <a:srgbClr val="F4F8FF"/>
-                </a:solidFill>
-              </a:rPr>
-              <a:t>Enterprise value comes when the model is connected to data, tools, and governance.</a:t>
-            </a:r>
-            <a:endParaRPr lang="en-US" sz="1500" dirty="0"/>
-          </a:p>
-        </p:txBody>
-      </p:sp>
-      <p:sp>
-        <p:nvSpPr>
-          <p:cNvPr id="207" name="Closing memorable line"/>
-          <p:cNvSpPr/>
-          <p:nvPr/>
-        </p:nvSpPr>
-        <p:spPr>
-          <a:xfrm>
-            <a:off x="835000" y="5750000"/>
-            <a:ext cx="8292222" cy="560000"/>
-          </a:xfrm>
-          <a:prstGeom prst="rect">
-            <a:avLst/>
-          </a:prstGeom>
-          <a:noFill/>
-          <a:ln>
-            <a:noFill/>
-          </a:ln>
-        </p:spPr>
-        <p:txBody>
-          <a:bodyPr wrap="square" anchor="t"/>
-          <a:lstStyle/>
-          <a:p>
-            <a:pPr algn="l">
-              <a:buNone/>
-            </a:pPr>
-            <a:r>
-              <a:rPr lang="en-US" sz="1800" b="1" dirty="0">
-                <a:solidFill>
-                  <a:srgbClr val="9AE6B4"/>
-                </a:solidFill>
-              </a:rPr>
-              <a:t>The advantage goes to teams who can see the machinery, not just use the interface.</a:t>
-            </a:r>
-            <a:endParaRPr lang="en-US" sz="1800" dirty="0"/>
-          </a:p>
-        </p:txBody>
-      </p:sp>
-      <p:sp>
-        <p:nvSpPr>
-          <p:cNvPr id="208" name="Closing footer"/>
-          <p:cNvSpPr/>
-          <p:nvPr/>
-        </p:nvSpPr>
-        <p:spPr>
-          <a:xfrm>
-            <a:off x="820000" y="6450000"/>
-            <a:ext cx="3500000" cy="260000"/>
-          </a:xfrm>
-          <a:prstGeom prst="rect">
-            <a:avLst/>
-          </a:prstGeom>
-          <a:noFill/>
-          <a:ln>
-            <a:noFill/>
-          </a:ln>
-        </p:spPr>
-        <p:txBody>
-          <a:bodyPr wrap="square" anchor="t"/>
-          <a:lstStyle/>
-          <a:p>
-            <a:pPr algn="l">
-              <a:buNone/>
-            </a:pPr>
-            <a:r>
-              <a:rPr lang="en-US" sz="1000" b="0">
-                <a:solidFill>
-                  <a:srgbClr val="A9B8C8"/>
-                </a:solidFill>
-              </a:rPr>
-              <a:t>AI Under the hood</a:t>
-            </a:r>
-            <a:endParaRPr lang="en-US" sz="1000"/>
-          </a:p>
-        </p:txBody>
-      </p:sp>
     </p:spTree>
     <p:extLst>
       <p:ext uri="{BB962C8B-B14F-4D97-AF65-F5344CB8AC3E}">
-        <p14:creationId xmlns:p14="http://schemas.microsoft.com/office/powerpoint/2010/main" val="4093375280"/>
+        <p14:creationId xmlns:p14="http://schemas.microsoft.com/office/powerpoint/2010/main" val="2774029093"/>
       </p:ext>
     </p:extLst>
   </p:cSld>
@@ -12034,6 +11677,424 @@
       <p:bldP spid="92" grpId="0" animBg="1"/>
     </p:bldLst>
   </p:timing>
+</p:sld>
+</file>
+
+<file path=ppt/slides/slide20.xml><?xml version="1.0" encoding="utf-8"?>
+<p:sld xmlns:a="http://schemas.openxmlformats.org/drawingml/2006/main" xmlns:r="http://schemas.openxmlformats.org/officeDocument/2006/relationships" xmlns:p="http://schemas.openxmlformats.org/presentationml/2006/main">
+  <p:cSld>
+    <p:spTree>
+      <p:nvGrpSpPr>
+        <p:cNvPr id="1" name=""/>
+        <p:cNvGrpSpPr/>
+        <p:nvPr/>
+      </p:nvGrpSpPr>
+      <p:grpSpPr>
+        <a:xfrm>
+          <a:off x="0" y="0"/>
+          <a:ext cx="0" cy="0"/>
+          <a:chOff x="0" y="0"/>
+          <a:chExt cx="0" cy="0"/>
+        </a:xfrm>
+      </p:grpSpPr>
+      <p:pic>
+        <p:nvPicPr>
+          <p:cNvPr id="6" name="Picture Placeholder 5">
+            <a:extLst>
+              <a:ext uri="{FF2B5EF4-FFF2-40B4-BE49-F238E27FC236}">
+                <a16:creationId xmlns:a16="http://schemas.microsoft.com/office/drawing/2014/main" id="{BC56227F-0E35-3518-A770-5486C9C41AE4}"/>
+              </a:ext>
+            </a:extLst>
+          </p:cNvPr>
+          <p:cNvPicPr>
+            <a:picLocks noGrp="1" noChangeAspect="1"/>
+          </p:cNvPicPr>
+          <p:nvPr>
+            <p:ph type="pic" idx="1"/>
+          </p:nvPr>
+        </p:nvPicPr>
+        <p:blipFill>
+          <a:blip r:embed="rId2"/>
+          <a:srcRect l="3333" r="3333"/>
+          <a:stretch>
+            <a:fillRect/>
+          </a:stretch>
+        </p:blipFill>
+        <p:spPr>
+          <a:xfrm>
+            <a:off x="3068801" y="612775"/>
+            <a:ext cx="5486400" cy="4114800"/>
+          </a:xfrm>
+        </p:spPr>
+      </p:pic>
+      <p:sp>
+        <p:nvSpPr>
+          <p:cNvPr id="200" name="Closing dark readable overlay"/>
+          <p:cNvSpPr/>
+          <p:nvPr/>
+        </p:nvSpPr>
+        <p:spPr>
+          <a:xfrm>
+            <a:off x="0" y="0"/>
+            <a:ext cx="12192000" cy="6858000"/>
+          </a:xfrm>
+          <a:prstGeom prst="rect">
+            <a:avLst/>
+          </a:prstGeom>
+          <a:solidFill>
+            <a:srgbClr val="050A0F">
+              <a:alpha val="65000"/>
+            </a:srgbClr>
+          </a:solidFill>
+          <a:ln>
+            <a:noFill/>
+          </a:ln>
+        </p:spPr>
+      </p:sp>
+      <p:sp>
+        <p:nvSpPr>
+          <p:cNvPr id="201" name="Closing left ink panel"/>
+          <p:cNvSpPr/>
+          <p:nvPr/>
+        </p:nvSpPr>
+        <p:spPr>
+          <a:xfrm>
+            <a:off x="0" y="0"/>
+            <a:ext cx="7600000" cy="6858000"/>
+          </a:xfrm>
+          <a:prstGeom prst="rect">
+            <a:avLst/>
+          </a:prstGeom>
+          <a:solidFill>
+            <a:srgbClr val="07111B">
+              <a:alpha val="18000"/>
+            </a:srgbClr>
+          </a:solidFill>
+          <a:ln>
+            <a:noFill/>
+          </a:ln>
+        </p:spPr>
+      </p:sp>
+      <p:sp>
+        <p:nvSpPr>
+          <p:cNvPr id="202" name="Closing accent rule"/>
+          <p:cNvSpPr/>
+          <p:nvPr/>
+        </p:nvSpPr>
+        <p:spPr>
+          <a:xfrm>
+            <a:off x="760000" y="1070000"/>
+            <a:ext cx="3000000" cy="0"/>
+          </a:xfrm>
+          <a:prstGeom prst="rect">
+            <a:avLst/>
+          </a:prstGeom>
+          <a:noFill/>
+          <a:ln w="38100">
+            <a:solidFill>
+              <a:srgbClr val="42D17A"/>
+            </a:solidFill>
+          </a:ln>
+        </p:spPr>
+      </p:sp>
+      <p:sp>
+        <p:nvSpPr>
+          <p:cNvPr id="203" name="Closing kicker"/>
+          <p:cNvSpPr/>
+          <p:nvPr/>
+        </p:nvSpPr>
+        <p:spPr>
+          <a:xfrm>
+            <a:off x="760000" y="520000"/>
+            <a:ext cx="4800000" cy="420000"/>
+          </a:xfrm>
+          <a:prstGeom prst="rect">
+            <a:avLst/>
+          </a:prstGeom>
+          <a:noFill/>
+          <a:ln>
+            <a:noFill/>
+          </a:ln>
+        </p:spPr>
+        <p:txBody>
+          <a:bodyPr wrap="square" anchor="t"/>
+          <a:lstStyle/>
+          <a:p>
+            <a:pPr algn="l">
+              <a:buNone/>
+            </a:pPr>
+            <a:r>
+              <a:rPr lang="en-US" sz="1600" b="1" dirty="0">
+                <a:solidFill>
+                  <a:srgbClr val="9AE6B4"/>
+                </a:solidFill>
+              </a:rPr>
+              <a:t>MAGPAI</a:t>
+            </a:r>
+            <a:endParaRPr lang="en-US" sz="1600" dirty="0"/>
+          </a:p>
+        </p:txBody>
+      </p:sp>
+      <p:sp>
+        <p:nvSpPr>
+          <p:cNvPr id="204" name="Closing title"/>
+          <p:cNvSpPr/>
+          <p:nvPr/>
+        </p:nvSpPr>
+        <p:spPr>
+          <a:xfrm>
+            <a:off x="730000" y="1180000"/>
+            <a:ext cx="7200000" cy="1500000"/>
+          </a:xfrm>
+          <a:prstGeom prst="rect">
+            <a:avLst/>
+          </a:prstGeom>
+          <a:noFill/>
+          <a:ln>
+            <a:noFill/>
+          </a:ln>
+        </p:spPr>
+        <p:txBody>
+          <a:bodyPr wrap="square" anchor="t"/>
+          <a:lstStyle/>
+          <a:p>
+            <a:pPr algn="l">
+              <a:buNone/>
+            </a:pPr>
+            <a:r>
+              <a:rPr lang="en-US" sz="3200" b="1" dirty="0">
+                <a:solidFill>
+                  <a:srgbClr val="FFFFFF"/>
+                </a:solidFill>
+              </a:rPr>
+              <a:t>You now know what is under the hood.</a:t>
+            </a:r>
+            <a:endParaRPr lang="en-US" sz="3200" dirty="0"/>
+          </a:p>
+        </p:txBody>
+      </p:sp>
+      <p:sp>
+        <p:nvSpPr>
+          <p:cNvPr id="205" name="Closing subtitle"/>
+          <p:cNvSpPr/>
+          <p:nvPr/>
+        </p:nvSpPr>
+        <p:spPr>
+          <a:xfrm>
+            <a:off x="780000" y="2700000"/>
+            <a:ext cx="6350000" cy="720000"/>
+          </a:xfrm>
+          <a:prstGeom prst="rect">
+            <a:avLst/>
+          </a:prstGeom>
+          <a:noFill/>
+          <a:ln>
+            <a:noFill/>
+          </a:ln>
+        </p:spPr>
+        <p:txBody>
+          <a:bodyPr wrap="square" anchor="t"/>
+          <a:lstStyle/>
+          <a:p>
+            <a:pPr algn="l">
+              <a:buNone/>
+            </a:pPr>
+            <a:r>
+              <a:rPr lang="en-US" sz="1800" b="0">
+                <a:solidFill>
+                  <a:srgbClr val="DCEAF7"/>
+                </a:solidFill>
+              </a:rPr>
+              <a:t>Words become tokens. Tokens become vectors. Vectors activate neural networks. Systems turn answers into action.</a:t>
+            </a:r>
+            <a:endParaRPr lang="en-US" sz="1800"/>
+          </a:p>
+        </p:txBody>
+      </p:sp>
+      <p:sp>
+        <p:nvSpPr>
+          <p:cNvPr id="206" name="Closing key takeaways"/>
+          <p:cNvSpPr/>
+          <p:nvPr/>
+        </p:nvSpPr>
+        <p:spPr>
+          <a:xfrm>
+            <a:off x="820000" y="3650000"/>
+            <a:ext cx="7110000" cy="1900000"/>
+          </a:xfrm>
+          <a:prstGeom prst="rect">
+            <a:avLst/>
+          </a:prstGeom>
+          <a:solidFill>
+            <a:srgbClr val="0B1B2A">
+              <a:alpha val="18000"/>
+            </a:srgbClr>
+          </a:solidFill>
+          <a:ln>
+            <a:noFill/>
+          </a:ln>
+        </p:spPr>
+        <p:txBody>
+          <a:bodyPr wrap="square" anchor="t"/>
+          <a:lstStyle/>
+          <a:p>
+            <a:pPr algn="l">
+              <a:buChar char="•"/>
+            </a:pPr>
+            <a:r>
+              <a:rPr lang="en-US" sz="1500" b="0" dirty="0">
+                <a:solidFill>
+                  <a:srgbClr val="F4F8FF"/>
+                </a:solidFill>
+              </a:rPr>
+              <a:t>AI is not magic; it is a pipeline you can inspect.</a:t>
+            </a:r>
+            <a:endParaRPr lang="en-US" sz="1500" dirty="0"/>
+          </a:p>
+          <a:p>
+            <a:pPr algn="l">
+              <a:buChar char="•"/>
+            </a:pPr>
+            <a:r>
+              <a:rPr lang="en-US" sz="1500" b="0" dirty="0">
+                <a:solidFill>
+                  <a:srgbClr val="F4F8FF"/>
+                </a:solidFill>
+              </a:rPr>
+              <a:t>Tokenization is where language first becomes structure.</a:t>
+            </a:r>
+            <a:endParaRPr lang="en-US" sz="1500" dirty="0"/>
+          </a:p>
+          <a:p>
+            <a:pPr algn="l">
+              <a:buChar char="•"/>
+            </a:pPr>
+            <a:r>
+              <a:rPr lang="en-US" sz="1500" b="0" dirty="0">
+                <a:solidFill>
+                  <a:srgbClr val="F4F8FF"/>
+                </a:solidFill>
+              </a:rPr>
+              <a:t>Embeddings are learned coordinates of meaning.</a:t>
+            </a:r>
+            <a:endParaRPr lang="en-US" sz="1500" dirty="0"/>
+          </a:p>
+          <a:p>
+            <a:pPr algn="l">
+              <a:buChar char="•"/>
+            </a:pPr>
+            <a:r>
+              <a:rPr lang="en-US" sz="1500" b="0" dirty="0">
+                <a:solidFill>
+                  <a:srgbClr val="F4F8FF"/>
+                </a:solidFill>
+              </a:rPr>
+              <a:t>Neural networks learn by changing weights and bias.</a:t>
+            </a:r>
+            <a:endParaRPr lang="en-US" sz="1500" dirty="0"/>
+          </a:p>
+          <a:p>
+            <a:pPr algn="l">
+              <a:buChar char="•"/>
+            </a:pPr>
+            <a:r>
+              <a:rPr lang="en-US" sz="1500" b="0" dirty="0">
+                <a:solidFill>
+                  <a:srgbClr val="F4F8FF"/>
+                </a:solidFill>
+              </a:rPr>
+              <a:t>Enterprise value comes when the model is connected to data, tools, and governance.</a:t>
+            </a:r>
+            <a:endParaRPr lang="en-US" sz="1500" dirty="0"/>
+          </a:p>
+        </p:txBody>
+      </p:sp>
+      <p:sp>
+        <p:nvSpPr>
+          <p:cNvPr id="207" name="Closing memorable line"/>
+          <p:cNvSpPr/>
+          <p:nvPr/>
+        </p:nvSpPr>
+        <p:spPr>
+          <a:xfrm>
+            <a:off x="835000" y="5750000"/>
+            <a:ext cx="8292222" cy="560000"/>
+          </a:xfrm>
+          <a:prstGeom prst="rect">
+            <a:avLst/>
+          </a:prstGeom>
+          <a:noFill/>
+          <a:ln>
+            <a:noFill/>
+          </a:ln>
+        </p:spPr>
+        <p:txBody>
+          <a:bodyPr wrap="square" anchor="t"/>
+          <a:lstStyle/>
+          <a:p>
+            <a:pPr algn="l">
+              <a:buNone/>
+            </a:pPr>
+            <a:r>
+              <a:rPr lang="en-US" sz="1800" b="1" dirty="0">
+                <a:solidFill>
+                  <a:srgbClr val="9AE6B4"/>
+                </a:solidFill>
+              </a:rPr>
+              <a:t>The advantage goes to teams who can see the machinery, not just use the interface.</a:t>
+            </a:r>
+            <a:endParaRPr lang="en-US" sz="1800" dirty="0"/>
+          </a:p>
+        </p:txBody>
+      </p:sp>
+      <p:sp>
+        <p:nvSpPr>
+          <p:cNvPr id="208" name="Closing footer"/>
+          <p:cNvSpPr/>
+          <p:nvPr/>
+        </p:nvSpPr>
+        <p:spPr>
+          <a:xfrm>
+            <a:off x="820000" y="6450000"/>
+            <a:ext cx="3500000" cy="260000"/>
+          </a:xfrm>
+          <a:prstGeom prst="rect">
+            <a:avLst/>
+          </a:prstGeom>
+          <a:noFill/>
+          <a:ln>
+            <a:noFill/>
+          </a:ln>
+        </p:spPr>
+        <p:txBody>
+          <a:bodyPr wrap="square" anchor="t"/>
+          <a:lstStyle/>
+          <a:p>
+            <a:pPr algn="l">
+              <a:buNone/>
+            </a:pPr>
+            <a:r>
+              <a:rPr lang="en-US" sz="1000" b="0">
+                <a:solidFill>
+                  <a:srgbClr val="A9B8C8"/>
+                </a:solidFill>
+              </a:rPr>
+              <a:t>AI Under the hood</a:t>
+            </a:r>
+            <a:endParaRPr lang="en-US" sz="1000"/>
+          </a:p>
+        </p:txBody>
+      </p:sp>
+    </p:spTree>
+    <p:extLst>
+      <p:ext uri="{BB962C8B-B14F-4D97-AF65-F5344CB8AC3E}">
+        <p14:creationId xmlns:p14="http://schemas.microsoft.com/office/powerpoint/2010/main" val="4093375280"/>
+      </p:ext>
+    </p:extLst>
+  </p:cSld>
+  <p:clrMapOvr>
+    <a:masterClrMapping/>
+  </p:clrMapOvr>
 </p:sld>
 </file>
 

</xml_diff>